<commit_message>
Fix hackathon jury feedback: add custom vulnerability checks
- Implement user-defined vulnerability validation
- Minor refactoring for code clarity
</commit_message>
<xml_diff>
--- a/documentation/presentation/SeagullNest-Team293.pptx
+++ b/documentation/presentation/SeagullNest-Team293.pptx
@@ -8,21 +8,23 @@
     <p:sldId id="256" r:id="rId2"/>
     <p:sldId id="261" r:id="rId3"/>
     <p:sldId id="263" r:id="rId4"/>
-    <p:sldId id="267" r:id="rId5"/>
-    <p:sldId id="262" r:id="rId6"/>
-    <p:sldId id="265" r:id="rId7"/>
-    <p:sldId id="268" r:id="rId8"/>
-    <p:sldId id="269" r:id="rId9"/>
-    <p:sldId id="270" r:id="rId10"/>
-    <p:sldId id="271" r:id="rId11"/>
-    <p:sldId id="272" r:id="rId12"/>
-    <p:sldId id="273" r:id="rId13"/>
-    <p:sldId id="275" r:id="rId14"/>
-    <p:sldId id="276" r:id="rId15"/>
-    <p:sldId id="274" r:id="rId16"/>
-    <p:sldId id="277" r:id="rId17"/>
-    <p:sldId id="278" r:id="rId18"/>
-    <p:sldId id="279" r:id="rId19"/>
+    <p:sldId id="281" r:id="rId5"/>
+    <p:sldId id="280" r:id="rId6"/>
+    <p:sldId id="262" r:id="rId7"/>
+    <p:sldId id="265" r:id="rId8"/>
+    <p:sldId id="282" r:id="rId9"/>
+    <p:sldId id="268" r:id="rId10"/>
+    <p:sldId id="269" r:id="rId11"/>
+    <p:sldId id="270" r:id="rId12"/>
+    <p:sldId id="271" r:id="rId13"/>
+    <p:sldId id="272" r:id="rId14"/>
+    <p:sldId id="273" r:id="rId15"/>
+    <p:sldId id="283" r:id="rId16"/>
+    <p:sldId id="275" r:id="rId17"/>
+    <p:sldId id="276" r:id="rId18"/>
+    <p:sldId id="274" r:id="rId19"/>
+    <p:sldId id="277" r:id="rId20"/>
+    <p:sldId id="279" r:id="rId21"/>
   </p:sldIdLst>
   <p:sldSz cx="12192000" cy="6858000"/>
   <p:notesSz cx="6858000" cy="9144000"/>
@@ -276,7 +278,7 @@
           <a:p>
             <a:fld id="{FE4F4E17-2AD6-A64C-AD07-B43B6438BF55}" type="datetimeFigureOut">
               <a:rPr lang="ru-RU" smtClean="0"/>
-              <a:t>09.11.2025</a:t>
+              <a:t>21.11.2025</a:t>
             </a:fld>
             <a:endParaRPr lang="ru-RU"/>
           </a:p>
@@ -474,7 +476,7 @@
           <a:p>
             <a:fld id="{FE4F4E17-2AD6-A64C-AD07-B43B6438BF55}" type="datetimeFigureOut">
               <a:rPr lang="ru-RU" smtClean="0"/>
-              <a:t>09.11.2025</a:t>
+              <a:t>21.11.2025</a:t>
             </a:fld>
             <a:endParaRPr lang="ru-RU"/>
           </a:p>
@@ -682,7 +684,7 @@
           <a:p>
             <a:fld id="{FE4F4E17-2AD6-A64C-AD07-B43B6438BF55}" type="datetimeFigureOut">
               <a:rPr lang="ru-RU" smtClean="0"/>
-              <a:t>09.11.2025</a:t>
+              <a:t>21.11.2025</a:t>
             </a:fld>
             <a:endParaRPr lang="ru-RU"/>
           </a:p>
@@ -880,7 +882,7 @@
           <a:p>
             <a:fld id="{FE4F4E17-2AD6-A64C-AD07-B43B6438BF55}" type="datetimeFigureOut">
               <a:rPr lang="ru-RU" smtClean="0"/>
-              <a:t>09.11.2025</a:t>
+              <a:t>21.11.2025</a:t>
             </a:fld>
             <a:endParaRPr lang="ru-RU"/>
           </a:p>
@@ -1155,7 +1157,7 @@
           <a:p>
             <a:fld id="{FE4F4E17-2AD6-A64C-AD07-B43B6438BF55}" type="datetimeFigureOut">
               <a:rPr lang="ru-RU" smtClean="0"/>
-              <a:t>09.11.2025</a:t>
+              <a:t>21.11.2025</a:t>
             </a:fld>
             <a:endParaRPr lang="ru-RU"/>
           </a:p>
@@ -1420,7 +1422,7 @@
           <a:p>
             <a:fld id="{FE4F4E17-2AD6-A64C-AD07-B43B6438BF55}" type="datetimeFigureOut">
               <a:rPr lang="ru-RU" smtClean="0"/>
-              <a:t>09.11.2025</a:t>
+              <a:t>21.11.2025</a:t>
             </a:fld>
             <a:endParaRPr lang="ru-RU"/>
           </a:p>
@@ -1832,7 +1834,7 @@
           <a:p>
             <a:fld id="{FE4F4E17-2AD6-A64C-AD07-B43B6438BF55}" type="datetimeFigureOut">
               <a:rPr lang="ru-RU" smtClean="0"/>
-              <a:t>09.11.2025</a:t>
+              <a:t>21.11.2025</a:t>
             </a:fld>
             <a:endParaRPr lang="ru-RU"/>
           </a:p>
@@ -1973,7 +1975,7 @@
           <a:p>
             <a:fld id="{FE4F4E17-2AD6-A64C-AD07-B43B6438BF55}" type="datetimeFigureOut">
               <a:rPr lang="ru-RU" smtClean="0"/>
-              <a:t>09.11.2025</a:t>
+              <a:t>21.11.2025</a:t>
             </a:fld>
             <a:endParaRPr lang="ru-RU"/>
           </a:p>
@@ -2086,7 +2088,7 @@
           <a:p>
             <a:fld id="{FE4F4E17-2AD6-A64C-AD07-B43B6438BF55}" type="datetimeFigureOut">
               <a:rPr lang="ru-RU" smtClean="0"/>
-              <a:t>09.11.2025</a:t>
+              <a:t>21.11.2025</a:t>
             </a:fld>
             <a:endParaRPr lang="ru-RU"/>
           </a:p>
@@ -2397,7 +2399,7 @@
           <a:p>
             <a:fld id="{FE4F4E17-2AD6-A64C-AD07-B43B6438BF55}" type="datetimeFigureOut">
               <a:rPr lang="ru-RU" smtClean="0"/>
-              <a:t>09.11.2025</a:t>
+              <a:t>21.11.2025</a:t>
             </a:fld>
             <a:endParaRPr lang="ru-RU"/>
           </a:p>
@@ -2685,7 +2687,7 @@
           <a:p>
             <a:fld id="{FE4F4E17-2AD6-A64C-AD07-B43B6438BF55}" type="datetimeFigureOut">
               <a:rPr lang="ru-RU" smtClean="0"/>
-              <a:t>09.11.2025</a:t>
+              <a:t>21.11.2025</a:t>
             </a:fld>
             <a:endParaRPr lang="ru-RU"/>
           </a:p>
@@ -2935,7 +2937,7 @@
           <a:p>
             <a:fld id="{FE4F4E17-2AD6-A64C-AD07-B43B6438BF55}" type="datetimeFigureOut">
               <a:rPr lang="ru-RU" smtClean="0"/>
-              <a:t>09.11.2025</a:t>
+              <a:t>21.11.2025</a:t>
             </a:fld>
             <a:endParaRPr lang="ru-RU"/>
           </a:p>
@@ -3646,7 +3648,7 @@
         <p:spPr>
           <a:xfrm>
             <a:off x="8908868" y="4376013"/>
-            <a:ext cx="3236648" cy="369332"/>
+            <a:ext cx="3236648" cy="1200329"/>
           </a:xfrm>
           <a:prstGeom prst="rect">
             <a:avLst/>
@@ -3669,6 +3671,53 @@
               </a:rPr>
               <a:t>Капитан-разработчик</a:t>
             </a:r>
+            <a:endParaRPr lang="en-US" dirty="0">
+              <a:solidFill>
+                <a:schemeClr val="bg1"/>
+              </a:solidFill>
+              <a:latin typeface="Arial" panose="020B0604020202020204" pitchFamily="34" charset="0"/>
+              <a:cs typeface="Arial" panose="020B0604020202020204" pitchFamily="34" charset="0"/>
+            </a:endParaRPr>
+          </a:p>
+          <a:p>
+            <a:endParaRPr lang="en-US" dirty="0">
+              <a:solidFill>
+                <a:schemeClr val="bg1"/>
+              </a:solidFill>
+              <a:latin typeface="Arial" panose="020B0604020202020204" pitchFamily="34" charset="0"/>
+              <a:cs typeface="Arial" panose="020B0604020202020204" pitchFamily="34" charset="0"/>
+            </a:endParaRPr>
+          </a:p>
+          <a:p>
+            <a:r>
+              <a:rPr lang="en-US" dirty="0">
+                <a:solidFill>
+                  <a:schemeClr val="bg1"/>
+                </a:solidFill>
+                <a:latin typeface="Arial" panose="020B0604020202020204" pitchFamily="34" charset="0"/>
+                <a:cs typeface="Arial" panose="020B0604020202020204" pitchFamily="34" charset="0"/>
+              </a:rPr>
+              <a:t>Senior Backend Engineer</a:t>
+            </a:r>
+          </a:p>
+          <a:p>
+            <a:r>
+              <a:rPr lang="en-US" dirty="0">
+                <a:solidFill>
+                  <a:schemeClr val="bg1"/>
+                </a:solidFill>
+                <a:latin typeface="Arial" panose="020B0604020202020204" pitchFamily="34" charset="0"/>
+                <a:cs typeface="Arial" panose="020B0604020202020204" pitchFamily="34" charset="0"/>
+              </a:rPr>
+              <a:t>OKKO</a:t>
+            </a:r>
+            <a:endParaRPr lang="ru-RU" dirty="0">
+              <a:solidFill>
+                <a:schemeClr val="bg1"/>
+              </a:solidFill>
+              <a:latin typeface="Arial" panose="020B0604020202020204" pitchFamily="34" charset="0"/>
+              <a:cs typeface="Arial" panose="020B0604020202020204" pitchFamily="34" charset="0"/>
+            </a:endParaRPr>
           </a:p>
         </p:txBody>
       </p:sp>
@@ -3953,7 +4002,7 @@
                 <a:latin typeface="Arial" panose="020B0604020202020204" pitchFamily="34" charset="0"/>
                 <a:cs typeface="Arial" panose="020B0604020202020204" pitchFamily="34" charset="0"/>
               </a:rPr>
-              <a:t>Примеры уязвимостей</a:t>
+              <a:t>Изучите результаты</a:t>
             </a:r>
           </a:p>
         </p:txBody>
@@ -4030,10 +4079,10 @@
       </p:sp>
       <p:pic>
         <p:nvPicPr>
-          <p:cNvPr id="10" name="Picture 9">
-            <a:extLst>
-              <a:ext uri="{FF2B5EF4-FFF2-40B4-BE49-F238E27FC236}">
-                <a16:creationId xmlns:a16="http://schemas.microsoft.com/office/drawing/2014/main" id="{61CE6B98-ED80-4F2D-A821-F56DC79CD43C}"/>
+          <p:cNvPr id="7" name="Picture 6">
+            <a:extLst>
+              <a:ext uri="{FF2B5EF4-FFF2-40B4-BE49-F238E27FC236}">
+                <a16:creationId xmlns:a16="http://schemas.microsoft.com/office/drawing/2014/main" id="{6357C3A3-4554-4B5F-9F69-5F48942EE5ED}"/>
               </a:ext>
             </a:extLst>
           </p:cNvPr>
@@ -4050,18 +4099,140 @@
         </p:blipFill>
         <p:spPr>
           <a:xfrm>
-            <a:off x="0" y="2388839"/>
-            <a:ext cx="12192000" cy="3827235"/>
+            <a:off x="172385" y="1959429"/>
+            <a:ext cx="8629804" cy="4782713"/>
           </a:xfrm>
           <a:prstGeom prst="rect">
             <a:avLst/>
           </a:prstGeom>
         </p:spPr>
       </p:pic>
+      <p:sp>
+        <p:nvSpPr>
+          <p:cNvPr id="9" name="Rectangle: Rounded Corners 8">
+            <a:extLst>
+              <a:ext uri="{FF2B5EF4-FFF2-40B4-BE49-F238E27FC236}">
+                <a16:creationId xmlns:a16="http://schemas.microsoft.com/office/drawing/2014/main" id="{F541D3EB-E795-4DE2-B490-1220CA09DA7B}"/>
+              </a:ext>
+            </a:extLst>
+          </p:cNvPr>
+          <p:cNvSpPr/>
+          <p:nvPr/>
+        </p:nvSpPr>
+        <p:spPr>
+          <a:xfrm>
+            <a:off x="6820591" y="4944291"/>
+            <a:ext cx="5319556" cy="1303863"/>
+          </a:xfrm>
+          <a:prstGeom prst="roundRect">
+            <a:avLst/>
+          </a:prstGeom>
+        </p:spPr>
+        <p:style>
+          <a:lnRef idx="2">
+            <a:schemeClr val="accent1">
+              <a:shade val="50000"/>
+            </a:schemeClr>
+          </a:lnRef>
+          <a:fillRef idx="1">
+            <a:schemeClr val="accent1"/>
+          </a:fillRef>
+          <a:effectRef idx="0">
+            <a:schemeClr val="accent1"/>
+          </a:effectRef>
+          <a:fontRef idx="minor">
+            <a:schemeClr val="lt1"/>
+          </a:fontRef>
+        </p:style>
+        <p:txBody>
+          <a:bodyPr rtlCol="0" anchor="ctr"/>
+          <a:lstStyle/>
+          <a:p>
+            <a:pPr algn="ctr"/>
+            <a:r>
+              <a:rPr lang="ru-RU" sz="1800" b="1" dirty="0">
+                <a:solidFill>
+                  <a:schemeClr val="bg1"/>
+                </a:solidFill>
+              </a:rPr>
+              <a:t>Новый этап (по замечаниям экспертов)</a:t>
+            </a:r>
+            <a:r>
+              <a:rPr lang="en-US" sz="1800" b="1" dirty="0">
+                <a:solidFill>
+                  <a:schemeClr val="bg1"/>
+                </a:solidFill>
+              </a:rPr>
+              <a:t>:</a:t>
+            </a:r>
+            <a:br>
+              <a:rPr lang="en-US" sz="1800" dirty="0">
+                <a:solidFill>
+                  <a:schemeClr val="bg1"/>
+                </a:solidFill>
+              </a:rPr>
+            </a:br>
+            <a:r>
+              <a:rPr lang="ru-RU" sz="1800" dirty="0">
+                <a:solidFill>
+                  <a:schemeClr val="bg1"/>
+                </a:solidFill>
+              </a:rPr>
+              <a:t>Возможность расширения за счет пользовательских проверок</a:t>
+            </a:r>
+            <a:endParaRPr lang="en-US" sz="1800" dirty="0">
+              <a:solidFill>
+                <a:schemeClr val="bg1"/>
+              </a:solidFill>
+            </a:endParaRPr>
+          </a:p>
+        </p:txBody>
+      </p:sp>
+      <p:cxnSp>
+        <p:nvCxnSpPr>
+          <p:cNvPr id="11" name="Straight Arrow Connector 10">
+            <a:extLst>
+              <a:ext uri="{FF2B5EF4-FFF2-40B4-BE49-F238E27FC236}">
+                <a16:creationId xmlns:a16="http://schemas.microsoft.com/office/drawing/2014/main" id="{97FE4CE4-4F40-42C7-B4CC-5EAFB50D6CA6}"/>
+              </a:ext>
+            </a:extLst>
+          </p:cNvPr>
+          <p:cNvCxnSpPr>
+            <a:stCxn id="9" idx="0"/>
+          </p:cNvCxnSpPr>
+          <p:nvPr/>
+        </p:nvCxnSpPr>
+        <p:spPr>
+          <a:xfrm flipH="1" flipV="1">
+            <a:off x="6185263" y="4082143"/>
+            <a:ext cx="3295106" cy="862148"/>
+          </a:xfrm>
+          <a:prstGeom prst="straightConnector1">
+            <a:avLst/>
+          </a:prstGeom>
+          <a:ln>
+            <a:tailEnd type="triangle"/>
+          </a:ln>
+        </p:spPr>
+        <p:style>
+          <a:lnRef idx="2">
+            <a:schemeClr val="dk1"/>
+          </a:lnRef>
+          <a:fillRef idx="0">
+            <a:schemeClr val="dk1"/>
+          </a:fillRef>
+          <a:effectRef idx="1">
+            <a:schemeClr val="dk1"/>
+          </a:effectRef>
+          <a:fontRef idx="minor">
+            <a:schemeClr val="tx1"/>
+          </a:fontRef>
+        </p:style>
+      </p:cxnSp>
     </p:spTree>
     <p:extLst>
       <p:ext uri="{BB962C8B-B14F-4D97-AF65-F5344CB8AC3E}">
-        <p14:creationId xmlns:p14="http://schemas.microsoft.com/office/powerpoint/2010/main" val="2938326689"/>
+        <p14:creationId xmlns:p14="http://schemas.microsoft.com/office/powerpoint/2010/main" val="1763766263"/>
       </p:ext>
     </p:extLst>
   </p:cSld>
@@ -4237,10 +4408,10 @@
       </p:sp>
       <p:pic>
         <p:nvPicPr>
-          <p:cNvPr id="4" name="Picture 3">
-            <a:extLst>
-              <a:ext uri="{FF2B5EF4-FFF2-40B4-BE49-F238E27FC236}">
-                <a16:creationId xmlns:a16="http://schemas.microsoft.com/office/drawing/2014/main" id="{D0E36C2C-79F6-4204-8368-C28FF00891A0}"/>
+          <p:cNvPr id="10" name="Picture 9">
+            <a:extLst>
+              <a:ext uri="{FF2B5EF4-FFF2-40B4-BE49-F238E27FC236}">
+                <a16:creationId xmlns:a16="http://schemas.microsoft.com/office/drawing/2014/main" id="{18D55B43-3C84-4ABE-BA8D-9C69494977FA}"/>
               </a:ext>
             </a:extLst>
           </p:cNvPr>
@@ -4257,8 +4428,8 @@
         </p:blipFill>
         <p:spPr>
           <a:xfrm>
-            <a:off x="0" y="2517443"/>
-            <a:ext cx="12192000" cy="3864131"/>
+            <a:off x="-54591" y="2158650"/>
+            <a:ext cx="12192000" cy="4442564"/>
           </a:xfrm>
           <a:prstGeom prst="rect">
             <a:avLst/>
@@ -4268,7 +4439,7 @@
     </p:spTree>
     <p:extLst>
       <p:ext uri="{BB962C8B-B14F-4D97-AF65-F5344CB8AC3E}">
-        <p14:creationId xmlns:p14="http://schemas.microsoft.com/office/powerpoint/2010/main" val="3418775211"/>
+        <p14:creationId xmlns:p14="http://schemas.microsoft.com/office/powerpoint/2010/main" val="1386375262"/>
       </p:ext>
     </p:extLst>
   </p:cSld>
@@ -4418,7 +4589,7 @@
         <p:spPr>
           <a:xfrm>
             <a:off x="353137" y="1278425"/>
-            <a:ext cx="11615950" cy="1785104"/>
+            <a:ext cx="6097136" cy="553998"/>
           </a:xfrm>
           <a:prstGeom prst="rect">
             <a:avLst/>
@@ -4436,47 +4607,18 @@
                 <a:solidFill>
                   <a:schemeClr val="bg1"/>
                 </a:solidFill>
-                <a:hlinkClick r:id="rId4"/>
               </a:rPr>
               <a:t>https://vtb.seag.pro/</a:t>
             </a:r>
-            <a:endParaRPr lang="ru-RU" sz="3000" dirty="0">
-              <a:solidFill>
-                <a:schemeClr val="bg1"/>
-              </a:solidFill>
-            </a:endParaRPr>
-          </a:p>
-          <a:p>
-            <a:r>
-              <a:rPr lang="ru-RU" sz="4000" dirty="0">
-                <a:solidFill>
-                  <a:schemeClr val="bg1"/>
-                </a:solidFill>
-              </a:rPr>
-              <a:t>В контракте не упомянута возможность получения 429 статус-кода, как и наличие </a:t>
-            </a:r>
-            <a:r>
-              <a:rPr lang="en-US" sz="4000" dirty="0" err="1">
-                <a:solidFill>
-                  <a:schemeClr val="bg1"/>
-                </a:solidFill>
-              </a:rPr>
-              <a:t>RateLimiter</a:t>
-            </a:r>
-            <a:endParaRPr lang="en-US" sz="4000" dirty="0">
-              <a:solidFill>
-                <a:schemeClr val="bg1"/>
-              </a:solidFill>
-            </a:endParaRPr>
           </a:p>
         </p:txBody>
       </p:sp>
       <p:pic>
         <p:nvPicPr>
-          <p:cNvPr id="7" name="Picture 6">
-            <a:extLst>
-              <a:ext uri="{FF2B5EF4-FFF2-40B4-BE49-F238E27FC236}">
-                <a16:creationId xmlns:a16="http://schemas.microsoft.com/office/drawing/2014/main" id="{8FE57E3C-C8D7-4913-9A9A-48476B20046D}"/>
+          <p:cNvPr id="10" name="Picture 9">
+            <a:extLst>
+              <a:ext uri="{FF2B5EF4-FFF2-40B4-BE49-F238E27FC236}">
+                <a16:creationId xmlns:a16="http://schemas.microsoft.com/office/drawing/2014/main" id="{61CE6B98-ED80-4F2D-A821-F56DC79CD43C}"/>
               </a:ext>
             </a:extLst>
           </p:cNvPr>
@@ -4486,15 +4628,15 @@
           <p:nvPr/>
         </p:nvPicPr>
         <p:blipFill>
-          <a:blip r:embed="rId5"/>
+          <a:blip r:embed="rId4"/>
           <a:stretch>
             <a:fillRect/>
           </a:stretch>
         </p:blipFill>
         <p:spPr>
           <a:xfrm>
-            <a:off x="0" y="3429000"/>
-            <a:ext cx="12192000" cy="2542090"/>
+            <a:off x="0" y="2388839"/>
+            <a:ext cx="12192000" cy="3827235"/>
           </a:xfrm>
           <a:prstGeom prst="rect">
             <a:avLst/>
@@ -4504,7 +4646,7 @@
     </p:spTree>
     <p:extLst>
       <p:ext uri="{BB962C8B-B14F-4D97-AF65-F5344CB8AC3E}">
-        <p14:creationId xmlns:p14="http://schemas.microsoft.com/office/powerpoint/2010/main" val="2760662794"/>
+        <p14:creationId xmlns:p14="http://schemas.microsoft.com/office/powerpoint/2010/main" val="2938326689"/>
       </p:ext>
     </p:extLst>
   </p:cSld>
@@ -4603,25 +4745,8 @@
                 <a:latin typeface="Arial" panose="020B0604020202020204" pitchFamily="34" charset="0"/>
                 <a:cs typeface="Arial" panose="020B0604020202020204" pitchFamily="34" charset="0"/>
               </a:rPr>
-              <a:t>Интеграция </a:t>
-            </a:r>
-            <a:r>
-              <a:rPr lang="en-US" sz="4800" b="1" dirty="0">
-                <a:solidFill>
-                  <a:schemeClr val="bg1"/>
-                </a:solidFill>
-                <a:latin typeface="Arial" panose="020B0604020202020204" pitchFamily="34" charset="0"/>
-                <a:cs typeface="Arial" panose="020B0604020202020204" pitchFamily="34" charset="0"/>
-              </a:rPr>
-              <a:t>CI/CD</a:t>
-            </a:r>
-            <a:endParaRPr lang="ru-RU" sz="4800" b="1" dirty="0">
-              <a:solidFill>
-                <a:schemeClr val="bg1"/>
-              </a:solidFill>
-              <a:latin typeface="Arial" panose="020B0604020202020204" pitchFamily="34" charset="0"/>
-              <a:cs typeface="Arial" panose="020B0604020202020204" pitchFamily="34" charset="0"/>
-            </a:endParaRPr>
+              <a:t>Примеры уязвимостей</a:t>
+            </a:r>
           </a:p>
         </p:txBody>
       </p:sp>
@@ -4671,7 +4796,7 @@
         <p:spPr>
           <a:xfrm>
             <a:off x="353137" y="1278425"/>
-            <a:ext cx="11615950" cy="707886"/>
+            <a:ext cx="6097136" cy="553998"/>
           </a:xfrm>
           <a:prstGeom prst="rect">
             <a:avLst/>
@@ -4685,407 +4810,22 @@
           <a:lstStyle/>
           <a:p>
             <a:r>
-              <a:rPr lang="ru-RU" sz="4000" dirty="0">
-                <a:solidFill>
-                  <a:schemeClr val="bg1"/>
-                </a:solidFill>
-              </a:rPr>
-              <a:t>Пример - </a:t>
-            </a:r>
-            <a:r>
-              <a:rPr lang="en-US" sz="4000" dirty="0">
-                <a:solidFill>
-                  <a:schemeClr val="bg1"/>
-                </a:solidFill>
-              </a:rPr>
-              <a:t>jenkins.seag.pro</a:t>
-            </a:r>
-            <a:endParaRPr lang="ru-RU" sz="4000" dirty="0">
-              <a:solidFill>
-                <a:schemeClr val="bg1"/>
-              </a:solidFill>
-            </a:endParaRPr>
+              <a:rPr lang="en-US" sz="3000" dirty="0">
+                <a:solidFill>
+                  <a:schemeClr val="bg1"/>
+                </a:solidFill>
+              </a:rPr>
+              <a:t>https://vtb.seag.pro/</a:t>
+            </a:r>
           </a:p>
         </p:txBody>
       </p:sp>
       <p:pic>
         <p:nvPicPr>
-          <p:cNvPr id="9" name="Рисунок 4" descr="Изображение выглядит как снимок экрана, синий, Цвет электрик, Прямоугольник&#10;&#10;Содержимое, созданное искусственным интеллектом, может быть неверным.">
-            <a:extLst>
-              <a:ext uri="{FF2B5EF4-FFF2-40B4-BE49-F238E27FC236}">
-                <a16:creationId xmlns:a16="http://schemas.microsoft.com/office/drawing/2014/main" id="{77AF8683-00C2-4C31-B71D-6642A6BA30D9}"/>
-              </a:ext>
-            </a:extLst>
-          </p:cNvPr>
-          <p:cNvPicPr>
-            <a:picLocks noChangeAspect="1"/>
-          </p:cNvPicPr>
-          <p:nvPr/>
-        </p:nvPicPr>
-        <p:blipFill>
-          <a:blip r:embed="rId2"/>
-          <a:stretch>
-            <a:fillRect/>
-          </a:stretch>
-        </p:blipFill>
-        <p:spPr>
-          <a:xfrm>
-            <a:off x="-1076325" y="2526667"/>
-            <a:ext cx="7172325" cy="3772664"/>
-          </a:xfrm>
-          <a:prstGeom prst="rect">
-            <a:avLst/>
-          </a:prstGeom>
-        </p:spPr>
-      </p:pic>
-      <p:sp>
-        <p:nvSpPr>
-          <p:cNvPr id="10" name="TextBox 9">
-            <a:extLst>
-              <a:ext uri="{FF2B5EF4-FFF2-40B4-BE49-F238E27FC236}">
-                <a16:creationId xmlns:a16="http://schemas.microsoft.com/office/drawing/2014/main" id="{AAD6FE32-7225-4A64-8D19-3C2CF0601F58}"/>
-              </a:ext>
-            </a:extLst>
-          </p:cNvPr>
-          <p:cNvSpPr txBox="1"/>
-          <p:nvPr/>
-        </p:nvSpPr>
-        <p:spPr>
-          <a:xfrm>
-            <a:off x="58713" y="2526666"/>
-            <a:ext cx="5721114" cy="2939266"/>
-          </a:xfrm>
-          <a:prstGeom prst="rect">
-            <a:avLst/>
-          </a:prstGeom>
-          <a:noFill/>
-        </p:spPr>
-        <p:txBody>
-          <a:bodyPr wrap="square" rtlCol="0">
-            <a:spAutoFit/>
-          </a:bodyPr>
-          <a:lstStyle/>
-          <a:p>
-            <a:r>
-              <a:rPr lang="ru-RU" sz="2500" b="1" dirty="0">
-                <a:solidFill>
-                  <a:schemeClr val="bg1"/>
-                </a:solidFill>
-                <a:latin typeface="Arial" panose="020B0604020202020204" pitchFamily="34" charset="0"/>
-                <a:cs typeface="Arial" panose="020B0604020202020204" pitchFamily="34" charset="0"/>
-              </a:rPr>
-              <a:t>Интеграция доступна через</a:t>
-            </a:r>
-            <a:r>
-              <a:rPr lang="en-US" sz="2500" b="1" dirty="0">
-                <a:solidFill>
-                  <a:schemeClr val="bg1"/>
-                </a:solidFill>
-                <a:latin typeface="Arial" panose="020B0604020202020204" pitchFamily="34" charset="0"/>
-                <a:cs typeface="Arial" panose="020B0604020202020204" pitchFamily="34" charset="0"/>
-              </a:rPr>
-              <a:t>:</a:t>
-            </a:r>
-          </a:p>
-          <a:p>
-            <a:pPr marL="342900" indent="-342900">
-              <a:buFont typeface="Arial" panose="020B0604020202020204" pitchFamily="34" charset="0"/>
-              <a:buChar char="•"/>
-            </a:pPr>
-            <a:r>
-              <a:rPr lang="en-US" sz="2500" b="1" dirty="0">
-                <a:solidFill>
-                  <a:schemeClr val="bg1"/>
-                </a:solidFill>
-                <a:latin typeface="Arial" panose="020B0604020202020204" pitchFamily="34" charset="0"/>
-                <a:cs typeface="Arial" panose="020B0604020202020204" pitchFamily="34" charset="0"/>
-              </a:rPr>
-              <a:t>Rest API</a:t>
-            </a:r>
-          </a:p>
-          <a:p>
-            <a:pPr marL="342900" indent="-342900">
-              <a:buFont typeface="Arial" panose="020B0604020202020204" pitchFamily="34" charset="0"/>
-              <a:buChar char="•"/>
-            </a:pPr>
-            <a:r>
-              <a:rPr lang="en-US" sz="2500" b="1" dirty="0" err="1">
-                <a:solidFill>
-                  <a:schemeClr val="bg1"/>
-                </a:solidFill>
-                <a:latin typeface="Arial" panose="020B0604020202020204" pitchFamily="34" charset="0"/>
-                <a:cs typeface="Arial" panose="020B0604020202020204" pitchFamily="34" charset="0"/>
-              </a:rPr>
-              <a:t>ApiSecurityCli</a:t>
-            </a:r>
-            <a:endParaRPr lang="ru-RU" sz="2500" b="1" dirty="0">
-              <a:solidFill>
-                <a:schemeClr val="bg1"/>
-              </a:solidFill>
-              <a:latin typeface="Arial" panose="020B0604020202020204" pitchFamily="34" charset="0"/>
-              <a:cs typeface="Arial" panose="020B0604020202020204" pitchFamily="34" charset="0"/>
-            </a:endParaRPr>
-          </a:p>
-          <a:p>
-            <a:r>
-              <a:rPr lang="en-US" sz="1500" b="1" dirty="0" err="1">
-                <a:solidFill>
-                  <a:schemeClr val="bg1"/>
-                </a:solidFill>
-                <a:latin typeface="Arial" panose="020B0604020202020204" pitchFamily="34" charset="0"/>
-                <a:cs typeface="Arial" panose="020B0604020202020204" pitchFamily="34" charset="0"/>
-              </a:rPr>
-              <a:t>ApiSecurityCli</a:t>
-            </a:r>
-            <a:r>
-              <a:rPr lang="en-US" sz="1500" b="1" dirty="0">
-                <a:solidFill>
-                  <a:schemeClr val="bg1"/>
-                </a:solidFill>
-                <a:latin typeface="Arial" panose="020B0604020202020204" pitchFamily="34" charset="0"/>
-                <a:cs typeface="Arial" panose="020B0604020202020204" pitchFamily="34" charset="0"/>
-              </a:rPr>
-              <a:t> </a:t>
-            </a:r>
-            <a:r>
-              <a:rPr lang="ru-RU" sz="1500" b="1" dirty="0">
-                <a:solidFill>
-                  <a:schemeClr val="bg1"/>
-                </a:solidFill>
-                <a:latin typeface="Arial" panose="020B0604020202020204" pitchFamily="34" charset="0"/>
-                <a:cs typeface="Arial" panose="020B0604020202020204" pitchFamily="34" charset="0"/>
-              </a:rPr>
-              <a:t>в </a:t>
-            </a:r>
-            <a:r>
-              <a:rPr lang="ru-RU" sz="1500" b="1" dirty="0" err="1">
-                <a:solidFill>
-                  <a:schemeClr val="bg1"/>
-                </a:solidFill>
-                <a:latin typeface="Arial" panose="020B0604020202020204" pitchFamily="34" charset="0"/>
-                <a:cs typeface="Arial" panose="020B0604020202020204" pitchFamily="34" charset="0"/>
-              </a:rPr>
-              <a:t>стэйдже</a:t>
-            </a:r>
-            <a:r>
-              <a:rPr lang="ru-RU" sz="1500" b="1" dirty="0">
-                <a:solidFill>
-                  <a:schemeClr val="bg1"/>
-                </a:solidFill>
-                <a:latin typeface="Arial" panose="020B0604020202020204" pitchFamily="34" charset="0"/>
-                <a:cs typeface="Arial" panose="020B0604020202020204" pitchFamily="34" charset="0"/>
-              </a:rPr>
-              <a:t> </a:t>
-            </a:r>
-            <a:r>
-              <a:rPr lang="ru-RU" sz="1500" b="1" dirty="0" err="1">
-                <a:solidFill>
-                  <a:schemeClr val="bg1"/>
-                </a:solidFill>
-                <a:latin typeface="Arial" panose="020B0604020202020204" pitchFamily="34" charset="0"/>
-                <a:cs typeface="Arial" panose="020B0604020202020204" pitchFamily="34" charset="0"/>
-              </a:rPr>
-              <a:t>пайплайна</a:t>
-            </a:r>
-            <a:r>
-              <a:rPr lang="ru-RU" sz="1500" b="1" dirty="0">
-                <a:solidFill>
-                  <a:schemeClr val="bg1"/>
-                </a:solidFill>
-                <a:latin typeface="Arial" panose="020B0604020202020204" pitchFamily="34" charset="0"/>
-                <a:cs typeface="Arial" panose="020B0604020202020204" pitchFamily="34" charset="0"/>
-              </a:rPr>
-              <a:t> вызывается через скрипт </a:t>
-            </a:r>
-            <a:r>
-              <a:rPr lang="en-US" sz="1500" b="1" dirty="0">
-                <a:solidFill>
-                  <a:schemeClr val="bg1"/>
-                </a:solidFill>
-                <a:latin typeface="Arial" panose="020B0604020202020204" pitchFamily="34" charset="0"/>
-                <a:cs typeface="Arial" panose="020B0604020202020204" pitchFamily="34" charset="0"/>
-              </a:rPr>
-              <a:t>cli.sh</a:t>
-            </a:r>
-            <a:r>
-              <a:rPr lang="ru-RU" sz="1500" b="1" dirty="0">
-                <a:solidFill>
-                  <a:schemeClr val="bg1"/>
-                </a:solidFill>
-                <a:latin typeface="Arial" panose="020B0604020202020204" pitchFamily="34" charset="0"/>
-                <a:cs typeface="Arial" panose="020B0604020202020204" pitchFamily="34" charset="0"/>
-              </a:rPr>
-              <a:t> (пример справа), в перспективе – разработка отдельного исполняемого </a:t>
-            </a:r>
-            <a:r>
-              <a:rPr lang="en-US" sz="1500" b="1" dirty="0">
-                <a:solidFill>
-                  <a:schemeClr val="bg1"/>
-                </a:solidFill>
-                <a:latin typeface="Arial" panose="020B0604020202020204" pitchFamily="34" charset="0"/>
-                <a:cs typeface="Arial" panose="020B0604020202020204" pitchFamily="34" charset="0"/>
-              </a:rPr>
-              <a:t>CLI</a:t>
-            </a:r>
-            <a:r>
-              <a:rPr lang="ru-RU" sz="1500" b="1" dirty="0">
-                <a:solidFill>
-                  <a:schemeClr val="bg1"/>
-                </a:solidFill>
-                <a:latin typeface="Arial" panose="020B0604020202020204" pitchFamily="34" charset="0"/>
-                <a:cs typeface="Arial" panose="020B0604020202020204" pitchFamily="34" charset="0"/>
-              </a:rPr>
-              <a:t>-инструмента на </a:t>
-            </a:r>
-            <a:r>
-              <a:rPr lang="en-US" sz="1500" b="1" dirty="0" err="1">
-                <a:solidFill>
-                  <a:schemeClr val="bg1"/>
-                </a:solidFill>
-                <a:latin typeface="Arial" panose="020B0604020202020204" pitchFamily="34" charset="0"/>
-                <a:cs typeface="Arial" panose="020B0604020202020204" pitchFamily="34" charset="0"/>
-              </a:rPr>
-              <a:t>GoLang</a:t>
-            </a:r>
-            <a:endParaRPr lang="ru-RU" sz="1500" b="1" dirty="0">
-              <a:solidFill>
-                <a:schemeClr val="bg1"/>
-              </a:solidFill>
-              <a:latin typeface="Arial" panose="020B0604020202020204" pitchFamily="34" charset="0"/>
-              <a:cs typeface="Arial" panose="020B0604020202020204" pitchFamily="34" charset="0"/>
-            </a:endParaRPr>
-          </a:p>
-          <a:p>
-            <a:endParaRPr lang="ru-RU" sz="1500" b="1" dirty="0">
-              <a:solidFill>
-                <a:schemeClr val="bg1"/>
-              </a:solidFill>
-              <a:latin typeface="Arial" panose="020B0604020202020204" pitchFamily="34" charset="0"/>
-              <a:cs typeface="Arial" panose="020B0604020202020204" pitchFamily="34" charset="0"/>
-            </a:endParaRPr>
-          </a:p>
-          <a:p>
-            <a:r>
-              <a:rPr lang="ru-RU" sz="2500" b="1" dirty="0">
-                <a:solidFill>
-                  <a:schemeClr val="bg1"/>
-                </a:solidFill>
-                <a:latin typeface="Arial" panose="020B0604020202020204" pitchFamily="34" charset="0"/>
-                <a:cs typeface="Arial" panose="020B0604020202020204" pitchFamily="34" charset="0"/>
-              </a:rPr>
-              <a:t>Результат — проведенный поиск уязвимостей и ссылки на отчет</a:t>
-            </a:r>
-          </a:p>
-        </p:txBody>
-      </p:sp>
-      <p:sp>
-        <p:nvSpPr>
-          <p:cNvPr id="11" name="Rectangle 1">
-            <a:extLst>
-              <a:ext uri="{FF2B5EF4-FFF2-40B4-BE49-F238E27FC236}">
-                <a16:creationId xmlns:a16="http://schemas.microsoft.com/office/drawing/2014/main" id="{879FC0C0-F530-4314-8B3F-D19FEDEB2EA3}"/>
-              </a:ext>
-            </a:extLst>
-          </p:cNvPr>
-          <p:cNvSpPr>
-            <a:spLocks noChangeArrowheads="1"/>
-          </p:cNvSpPr>
-          <p:nvPr/>
-        </p:nvSpPr>
-        <p:spPr bwMode="auto">
-          <a:xfrm>
-            <a:off x="0" y="0"/>
-            <a:ext cx="12192000" cy="457200"/>
-          </a:xfrm>
-          <a:prstGeom prst="rect">
-            <a:avLst/>
-          </a:prstGeom>
-          <a:solidFill>
-            <a:srgbClr val="1E1F22"/>
-          </a:solidFill>
-          <a:ln>
-            <a:noFill/>
-          </a:ln>
-          <a:effectLst/>
-          <a:extLst>
-            <a:ext uri="{91240B29-F687-4F45-9708-019B960494DF}">
-              <a14:hiddenLine xmlns:a14="http://schemas.microsoft.com/office/drawing/2010/main" w="9525">
-                <a:solidFill>
-                  <a:schemeClr val="tx1"/>
-                </a:solidFill>
-                <a:miter lim="800000"/>
-                <a:headEnd/>
-                <a:tailEnd/>
-              </a14:hiddenLine>
-            </a:ext>
-            <a:ext uri="{AF507438-7753-43E0-B8FC-AC1667EBCBE1}">
-              <a14:hiddenEffects xmlns:a14="http://schemas.microsoft.com/office/drawing/2010/main">
-                <a:effectLst>
-                  <a:outerShdw dist="35921" dir="2700000" algn="ctr" rotWithShape="0">
-                    <a:schemeClr val="bg2"/>
-                  </a:outerShdw>
-                </a:effectLst>
-              </a14:hiddenEffects>
-            </a:ext>
-          </a:extLst>
-        </p:spPr>
-        <p:txBody>
-          <a:bodyPr vert="horz" wrap="none" lIns="91440" tIns="45720" rIns="91440" bIns="45720" numCol="1" anchor="ctr" anchorCtr="0" compatLnSpc="1">
-            <a:prstTxWarp prst="textNoShape">
-              <a:avLst/>
-            </a:prstTxWarp>
-            <a:spAutoFit/>
-          </a:bodyPr>
-          <a:lstStyle/>
-          <a:p>
-            <a:pPr marL="0" marR="0" lvl="0" indent="0" algn="l" defTabSz="914400" rtl="0" eaLnBrk="0" fontAlgn="base" latinLnBrk="0" hangingPunct="0">
-              <a:lnSpc>
-                <a:spcPct val="100000"/>
-              </a:lnSpc>
-              <a:spcBef>
-                <a:spcPct val="0"/>
-              </a:spcBef>
-              <a:spcAft>
-                <a:spcPct val="0"/>
-              </a:spcAft>
-              <a:buClrTx/>
-              <a:buSzTx/>
-              <a:buFontTx/>
-              <a:buNone/>
-              <a:tabLst/>
-            </a:pPr>
-            <a:r>
-              <a:rPr kumimoji="0" lang="en-US" altLang="en-US" sz="900" b="0" i="0" u="none" strike="noStrike" cap="none" normalizeH="0" baseline="0">
-                <a:ln>
-                  <a:noFill/>
-                </a:ln>
-                <a:solidFill>
-                  <a:srgbClr val="BCBEC4"/>
-                </a:solidFill>
-                <a:effectLst/>
-                <a:latin typeface="JetBrains Mono"/>
-              </a:rPr>
-              <a:t>ApiSecurityCli</a:t>
-            </a:r>
-            <a:endParaRPr kumimoji="0" lang="en-US" altLang="en-US" sz="1800" b="0" i="0" u="none" strike="noStrike" cap="none" normalizeH="0" baseline="0">
-              <a:ln>
-                <a:noFill/>
-              </a:ln>
-              <a:solidFill>
-                <a:schemeClr val="tx1"/>
-              </a:solidFill>
-              <a:effectLst/>
-              <a:latin typeface="Arial" panose="020B0604020202020204" pitchFamily="34" charset="0"/>
-            </a:endParaRPr>
-          </a:p>
-        </p:txBody>
-      </p:sp>
-      <p:pic>
-        <p:nvPicPr>
-          <p:cNvPr id="14" name="Picture 13">
-            <a:extLst>
-              <a:ext uri="{FF2B5EF4-FFF2-40B4-BE49-F238E27FC236}">
-                <a16:creationId xmlns:a16="http://schemas.microsoft.com/office/drawing/2014/main" id="{E40BAEB2-1385-4F6A-80E0-2B6C386FDA5A}"/>
+          <p:cNvPr id="4" name="Picture 3">
+            <a:extLst>
+              <a:ext uri="{FF2B5EF4-FFF2-40B4-BE49-F238E27FC236}">
+                <a16:creationId xmlns:a16="http://schemas.microsoft.com/office/drawing/2014/main" id="{D0E36C2C-79F6-4204-8368-C28FF00891A0}"/>
               </a:ext>
             </a:extLst>
           </p:cNvPr>
@@ -5102,194 +4842,18 @@
         </p:blipFill>
         <p:spPr>
           <a:xfrm>
-            <a:off x="6266512" y="1156750"/>
-            <a:ext cx="5765872" cy="5685697"/>
+            <a:off x="0" y="2517443"/>
+            <a:ext cx="12192000" cy="3864131"/>
           </a:xfrm>
           <a:prstGeom prst="rect">
             <a:avLst/>
           </a:prstGeom>
         </p:spPr>
       </p:pic>
-      <p:sp>
-        <p:nvSpPr>
-          <p:cNvPr id="15" name="Speech Bubble: Rectangle with Corners Rounded 14">
-            <a:extLst>
-              <a:ext uri="{FF2B5EF4-FFF2-40B4-BE49-F238E27FC236}">
-                <a16:creationId xmlns:a16="http://schemas.microsoft.com/office/drawing/2014/main" id="{C27527F2-1A30-4BF8-86C7-789E3C09113A}"/>
-              </a:ext>
-            </a:extLst>
-          </p:cNvPr>
-          <p:cNvSpPr/>
-          <p:nvPr/>
-        </p:nvSpPr>
-        <p:spPr>
-          <a:xfrm>
-            <a:off x="2973861" y="5636549"/>
-            <a:ext cx="2805966" cy="1026080"/>
-          </a:xfrm>
-          <a:prstGeom prst="wedgeRoundRectCallout">
-            <a:avLst/>
-          </a:prstGeom>
-          <a:solidFill>
-            <a:srgbClr val="FFFFF3"/>
-          </a:solidFill>
-        </p:spPr>
-        <p:style>
-          <a:lnRef idx="2">
-            <a:schemeClr val="accent1">
-              <a:shade val="50000"/>
-            </a:schemeClr>
-          </a:lnRef>
-          <a:fillRef idx="1">
-            <a:schemeClr val="accent1"/>
-          </a:fillRef>
-          <a:effectRef idx="0">
-            <a:schemeClr val="accent1"/>
-          </a:effectRef>
-          <a:fontRef idx="minor">
-            <a:schemeClr val="lt1"/>
-          </a:fontRef>
-        </p:style>
-        <p:txBody>
-          <a:bodyPr rtlCol="0" anchor="ctr"/>
-          <a:lstStyle/>
-          <a:p>
-            <a:pPr algn="ctr"/>
-            <a:r>
-              <a:rPr lang="ru-RU" dirty="0">
-                <a:solidFill>
-                  <a:schemeClr val="tx1"/>
-                </a:solidFill>
-              </a:rPr>
-              <a:t>Что будет если перейти по ссылке из </a:t>
-            </a:r>
-            <a:r>
-              <a:rPr lang="en-US" dirty="0">
-                <a:solidFill>
-                  <a:schemeClr val="tx1"/>
-                </a:solidFill>
-              </a:rPr>
-              <a:t>console output </a:t>
-            </a:r>
-            <a:r>
-              <a:rPr lang="ru-RU" dirty="0">
-                <a:solidFill>
-                  <a:schemeClr val="tx1"/>
-                </a:solidFill>
-              </a:rPr>
-              <a:t>в </a:t>
-            </a:r>
-            <a:r>
-              <a:rPr lang="en-US" dirty="0">
-                <a:solidFill>
-                  <a:schemeClr val="tx1"/>
-                </a:solidFill>
-              </a:rPr>
-              <a:t>Jenkins?</a:t>
-            </a:r>
-          </a:p>
-        </p:txBody>
-      </p:sp>
-      <p:sp>
-        <p:nvSpPr>
-          <p:cNvPr id="17" name="Rectangle: Rounded Corners 16">
-            <a:extLst>
-              <a:ext uri="{FF2B5EF4-FFF2-40B4-BE49-F238E27FC236}">
-                <a16:creationId xmlns:a16="http://schemas.microsoft.com/office/drawing/2014/main" id="{CFF1EA24-D208-438D-869F-2EE7BDDEB6F7}"/>
-              </a:ext>
-            </a:extLst>
-          </p:cNvPr>
-          <p:cNvSpPr/>
-          <p:nvPr/>
-        </p:nvSpPr>
-        <p:spPr>
-          <a:xfrm>
-            <a:off x="6434919" y="5561463"/>
-            <a:ext cx="5076043" cy="1207827"/>
-          </a:xfrm>
-          <a:prstGeom prst="roundRect">
-            <a:avLst/>
-          </a:prstGeom>
-          <a:noFill/>
-          <a:ln>
-            <a:solidFill>
-              <a:srgbClr val="FF0000"/>
-            </a:solidFill>
-          </a:ln>
-        </p:spPr>
-        <p:style>
-          <a:lnRef idx="2">
-            <a:schemeClr val="accent1">
-              <a:shade val="50000"/>
-            </a:schemeClr>
-          </a:lnRef>
-          <a:fillRef idx="1">
-            <a:schemeClr val="accent1"/>
-          </a:fillRef>
-          <a:effectRef idx="0">
-            <a:schemeClr val="accent1"/>
-          </a:effectRef>
-          <a:fontRef idx="minor">
-            <a:schemeClr val="lt1"/>
-          </a:fontRef>
-        </p:style>
-        <p:txBody>
-          <a:bodyPr rtlCol="0" anchor="ctr"/>
-          <a:lstStyle/>
-          <a:p>
-            <a:pPr algn="ctr"/>
-            <a:endParaRPr lang="en-US"/>
-          </a:p>
-        </p:txBody>
-      </p:sp>
-      <p:cxnSp>
-        <p:nvCxnSpPr>
-          <p:cNvPr id="19" name="Straight Arrow Connector 18">
-            <a:extLst>
-              <a:ext uri="{FF2B5EF4-FFF2-40B4-BE49-F238E27FC236}">
-                <a16:creationId xmlns:a16="http://schemas.microsoft.com/office/drawing/2014/main" id="{C2B90DB5-FC1F-4982-AA7F-CE9D97A883A6}"/>
-              </a:ext>
-            </a:extLst>
-          </p:cNvPr>
-          <p:cNvCxnSpPr>
-            <a:stCxn id="15" idx="3"/>
-          </p:cNvCxnSpPr>
-          <p:nvPr/>
-        </p:nvCxnSpPr>
-        <p:spPr>
-          <a:xfrm flipV="1">
-            <a:off x="5779827" y="5827594"/>
-            <a:ext cx="655092" cy="321995"/>
-          </a:xfrm>
-          <a:prstGeom prst="straightConnector1">
-            <a:avLst/>
-          </a:prstGeom>
-          <a:ln>
-            <a:solidFill>
-              <a:srgbClr val="FF0000"/>
-            </a:solidFill>
-            <a:tailEnd type="triangle"/>
-          </a:ln>
-        </p:spPr>
-        <p:style>
-          <a:lnRef idx="2">
-            <a:schemeClr val="accent1"/>
-          </a:lnRef>
-          <a:fillRef idx="0">
-            <a:schemeClr val="accent1"/>
-          </a:fillRef>
-          <a:effectRef idx="1">
-            <a:schemeClr val="accent1"/>
-          </a:effectRef>
-          <a:fontRef idx="minor">
-            <a:schemeClr val="tx1"/>
-          </a:fontRef>
-        </p:style>
-      </p:cxnSp>
     </p:spTree>
     <p:extLst>
       <p:ext uri="{BB962C8B-B14F-4D97-AF65-F5344CB8AC3E}">
-        <p14:creationId xmlns:p14="http://schemas.microsoft.com/office/powerpoint/2010/main" val="2208890552"/>
+        <p14:creationId xmlns:p14="http://schemas.microsoft.com/office/powerpoint/2010/main" val="3418775211"/>
       </p:ext>
     </p:extLst>
   </p:cSld>
@@ -5388,25 +4952,8 @@
                 <a:latin typeface="Arial" panose="020B0604020202020204" pitchFamily="34" charset="0"/>
                 <a:cs typeface="Arial" panose="020B0604020202020204" pitchFamily="34" charset="0"/>
               </a:rPr>
-              <a:t>Интеграция </a:t>
-            </a:r>
-            <a:r>
-              <a:rPr lang="en-US" sz="4800" b="1" dirty="0">
-                <a:solidFill>
-                  <a:schemeClr val="bg1"/>
-                </a:solidFill>
-                <a:latin typeface="Arial" panose="020B0604020202020204" pitchFamily="34" charset="0"/>
-                <a:cs typeface="Arial" panose="020B0604020202020204" pitchFamily="34" charset="0"/>
-              </a:rPr>
-              <a:t>CI/CD</a:t>
-            </a:r>
-            <a:endParaRPr lang="ru-RU" sz="4800" b="1" dirty="0">
-              <a:solidFill>
-                <a:schemeClr val="bg1"/>
-              </a:solidFill>
-              <a:latin typeface="Arial" panose="020B0604020202020204" pitchFamily="34" charset="0"/>
-              <a:cs typeface="Arial" panose="020B0604020202020204" pitchFamily="34" charset="0"/>
-            </a:endParaRPr>
+              <a:t>Примеры уязвимостей</a:t>
+            </a:r>
           </a:p>
         </p:txBody>
       </p:sp>
@@ -5456,7 +5003,7 @@
         <p:spPr>
           <a:xfrm>
             <a:off x="353137" y="1278425"/>
-            <a:ext cx="11615950" cy="707886"/>
+            <a:ext cx="11615950" cy="1785104"/>
           </a:xfrm>
           <a:prstGeom prst="rect">
             <a:avLst/>
@@ -5470,137 +5017,51 @@
           <a:lstStyle/>
           <a:p>
             <a:r>
-              <a:rPr lang="ru-RU" sz="4000" dirty="0">
-                <a:solidFill>
-                  <a:schemeClr val="bg1"/>
-                </a:solidFill>
-              </a:rPr>
-              <a:t>Что доступно по ссылке из отчета в </a:t>
-            </a:r>
-            <a:r>
-              <a:rPr lang="en-US" sz="4000" dirty="0">
-                <a:solidFill>
-                  <a:schemeClr val="bg1"/>
-                </a:solidFill>
-              </a:rPr>
-              <a:t>CI/CD ?</a:t>
-            </a:r>
-            <a:endParaRPr lang="ru-RU" sz="4000" dirty="0">
+              <a:rPr lang="en-US" sz="3000" dirty="0">
+                <a:solidFill>
+                  <a:schemeClr val="bg1"/>
+                </a:solidFill>
+                <a:hlinkClick r:id="rId4"/>
+              </a:rPr>
+              <a:t>https://vtb.seag.pro/</a:t>
+            </a:r>
+            <a:endParaRPr lang="ru-RU" sz="3000" dirty="0">
               <a:solidFill>
                 <a:schemeClr val="bg1"/>
               </a:solidFill>
             </a:endParaRPr>
           </a:p>
-        </p:txBody>
-      </p:sp>
-      <p:sp>
-        <p:nvSpPr>
-          <p:cNvPr id="11" name="Rectangle 1">
-            <a:extLst>
-              <a:ext uri="{FF2B5EF4-FFF2-40B4-BE49-F238E27FC236}">
-                <a16:creationId xmlns:a16="http://schemas.microsoft.com/office/drawing/2014/main" id="{879FC0C0-F530-4314-8B3F-D19FEDEB2EA3}"/>
-              </a:ext>
-            </a:extLst>
-          </p:cNvPr>
-          <p:cNvSpPr>
-            <a:spLocks noChangeArrowheads="1"/>
-          </p:cNvSpPr>
-          <p:nvPr/>
-        </p:nvSpPr>
-        <p:spPr bwMode="auto">
-          <a:xfrm>
-            <a:off x="0" y="0"/>
-            <a:ext cx="12192000" cy="457200"/>
-          </a:xfrm>
-          <a:prstGeom prst="rect">
-            <a:avLst/>
-          </a:prstGeom>
-          <a:solidFill>
-            <a:srgbClr val="1E1F22"/>
-          </a:solidFill>
-          <a:ln>
-            <a:noFill/>
-          </a:ln>
-          <a:effectLst/>
-          <a:extLst>
-            <a:ext uri="{91240B29-F687-4F45-9708-019B960494DF}">
-              <a14:hiddenLine xmlns:a14="http://schemas.microsoft.com/office/drawing/2010/main" w="9525">
-                <a:solidFill>
-                  <a:schemeClr val="tx1"/>
-                </a:solidFill>
-                <a:miter lim="800000"/>
-                <a:headEnd/>
-                <a:tailEnd/>
-              </a14:hiddenLine>
-            </a:ext>
-            <a:ext uri="{AF507438-7753-43E0-B8FC-AC1667EBCBE1}">
-              <a14:hiddenEffects xmlns:a14="http://schemas.microsoft.com/office/drawing/2010/main">
-                <a:effectLst>
-                  <a:outerShdw dist="35921" dir="2700000" algn="ctr" rotWithShape="0">
-                    <a:schemeClr val="bg2"/>
-                  </a:outerShdw>
-                </a:effectLst>
-              </a14:hiddenEffects>
-            </a:ext>
-          </a:extLst>
-        </p:spPr>
-        <p:txBody>
-          <a:bodyPr vert="horz" wrap="none" lIns="91440" tIns="45720" rIns="91440" bIns="45720" numCol="1" anchor="ctr" anchorCtr="0" compatLnSpc="1">
-            <a:prstTxWarp prst="textNoShape">
-              <a:avLst/>
-            </a:prstTxWarp>
-            <a:spAutoFit/>
-          </a:bodyPr>
-          <a:lstStyle/>
-          <a:p>
-            <a:pPr marL="0" marR="0" lvl="0" indent="0" algn="l" defTabSz="914400" rtl="0" eaLnBrk="0" fontAlgn="base" latinLnBrk="0" hangingPunct="0">
-              <a:lnSpc>
-                <a:spcPct val="100000"/>
-              </a:lnSpc>
-              <a:spcBef>
-                <a:spcPct val="0"/>
-              </a:spcBef>
-              <a:spcAft>
-                <a:spcPct val="0"/>
-              </a:spcAft>
-              <a:buClrTx/>
-              <a:buSzTx/>
-              <a:buFontTx/>
-              <a:buNone/>
-              <a:tabLst/>
-            </a:pPr>
-            <a:r>
-              <a:rPr kumimoji="0" lang="en-US" altLang="en-US" sz="900" b="0" i="0" u="none" strike="noStrike" cap="none" normalizeH="0" baseline="0">
-                <a:ln>
-                  <a:noFill/>
-                </a:ln>
-                <a:solidFill>
-                  <a:srgbClr val="BCBEC4"/>
-                </a:solidFill>
-                <a:effectLst/>
-                <a:latin typeface="JetBrains Mono"/>
-              </a:rPr>
-              <a:t>ApiSecurityCli</a:t>
-            </a:r>
-            <a:endParaRPr kumimoji="0" lang="en-US" altLang="en-US" sz="1800" b="0" i="0" u="none" strike="noStrike" cap="none" normalizeH="0" baseline="0">
-              <a:ln>
-                <a:noFill/>
-              </a:ln>
+          <a:p>
+            <a:r>
+              <a:rPr lang="ru-RU" sz="4000" dirty="0">
+                <a:solidFill>
+                  <a:schemeClr val="bg1"/>
+                </a:solidFill>
+              </a:rPr>
+              <a:t>В контракте не упомянута возможность получения 429 статус-кода, как и наличие </a:t>
+            </a:r>
+            <a:r>
+              <a:rPr lang="en-US" sz="4000" dirty="0" err="1">
+                <a:solidFill>
+                  <a:schemeClr val="bg1"/>
+                </a:solidFill>
+              </a:rPr>
+              <a:t>RateLimiter</a:t>
+            </a:r>
+            <a:endParaRPr lang="en-US" sz="4000" dirty="0">
               <a:solidFill>
-                <a:schemeClr val="tx1"/>
+                <a:schemeClr val="bg1"/>
               </a:solidFill>
-              <a:effectLst/>
-              <a:latin typeface="Arial" panose="020B0604020202020204" pitchFamily="34" charset="0"/>
             </a:endParaRPr>
           </a:p>
         </p:txBody>
       </p:sp>
       <p:pic>
         <p:nvPicPr>
-          <p:cNvPr id="4" name="Picture 3">
-            <a:extLst>
-              <a:ext uri="{FF2B5EF4-FFF2-40B4-BE49-F238E27FC236}">
-                <a16:creationId xmlns:a16="http://schemas.microsoft.com/office/drawing/2014/main" id="{9ED9C620-54C4-440D-BAE6-A6FBAF942564}"/>
+          <p:cNvPr id="7" name="Picture 6">
+            <a:extLst>
+              <a:ext uri="{FF2B5EF4-FFF2-40B4-BE49-F238E27FC236}">
+                <a16:creationId xmlns:a16="http://schemas.microsoft.com/office/drawing/2014/main" id="{8FE57E3C-C8D7-4913-9A9A-48476B20046D}"/>
               </a:ext>
             </a:extLst>
           </p:cNvPr>
@@ -5610,15 +5071,15 @@
           <p:nvPr/>
         </p:nvPicPr>
         <p:blipFill>
-          <a:blip r:embed="rId4"/>
+          <a:blip r:embed="rId5"/>
           <a:stretch>
             <a:fillRect/>
           </a:stretch>
         </p:blipFill>
         <p:spPr>
           <a:xfrm>
-            <a:off x="1903863" y="1948417"/>
-            <a:ext cx="8266706" cy="4909583"/>
+            <a:off x="0" y="3429000"/>
+            <a:ext cx="12192000" cy="2542090"/>
           </a:xfrm>
           <a:prstGeom prst="rect">
             <a:avLst/>
@@ -5628,7 +5089,7 @@
     </p:spTree>
     <p:extLst>
       <p:ext uri="{BB962C8B-B14F-4D97-AF65-F5344CB8AC3E}">
-        <p14:creationId xmlns:p14="http://schemas.microsoft.com/office/powerpoint/2010/main" val="1049884520"/>
+        <p14:creationId xmlns:p14="http://schemas.microsoft.com/office/powerpoint/2010/main" val="2760662794"/>
       </p:ext>
     </p:extLst>
   </p:cSld>
@@ -5727,7 +5188,7 @@
                 <a:latin typeface="Arial" panose="020B0604020202020204" pitchFamily="34" charset="0"/>
                 <a:cs typeface="Arial" panose="020B0604020202020204" pitchFamily="34" charset="0"/>
               </a:rPr>
-              <a:t>Форматы отчетов</a:t>
+              <a:t>Примеры уязвимостей</a:t>
             </a:r>
           </a:p>
         </p:txBody>
@@ -5778,7 +5239,7 @@
         <p:spPr>
           <a:xfrm>
             <a:off x="353137" y="1278425"/>
-            <a:ext cx="11615950" cy="2708434"/>
+            <a:ext cx="11615950" cy="1169551"/>
           </a:xfrm>
           <a:prstGeom prst="rect">
             <a:avLst/>
@@ -5808,73 +5269,36 @@
           </a:p>
           <a:p>
             <a:r>
-              <a:rPr lang="ru-RU" sz="3500" dirty="0" err="1">
-                <a:solidFill>
-                  <a:schemeClr val="bg1"/>
-                </a:solidFill>
-              </a:rPr>
-              <a:t>Поддеживаются</a:t>
-            </a:r>
-            <a:r>
-              <a:rPr lang="ru-RU" sz="3500" dirty="0">
-                <a:solidFill>
-                  <a:schemeClr val="bg1"/>
-                </a:solidFill>
-              </a:rPr>
-              <a:t> форматы </a:t>
-            </a:r>
-            <a:r>
-              <a:rPr lang="en-US" sz="3500" dirty="0" err="1">
-                <a:solidFill>
-                  <a:schemeClr val="bg1"/>
-                </a:solidFill>
-              </a:rPr>
-              <a:t>html,json,pdf</a:t>
-            </a:r>
-            <a:r>
-              <a:rPr lang="en-US" sz="3500" dirty="0">
-                <a:solidFill>
-                  <a:schemeClr val="bg1"/>
-                </a:solidFill>
-              </a:rPr>
-              <a:t>.</a:t>
-            </a:r>
-            <a:endParaRPr lang="ru-RU" sz="3500" dirty="0">
-              <a:solidFill>
-                <a:schemeClr val="bg1"/>
-              </a:solidFill>
-            </a:endParaRPr>
-          </a:p>
-          <a:p>
-            <a:endParaRPr lang="ru-RU" sz="3500" dirty="0">
-              <a:solidFill>
-                <a:schemeClr val="bg1"/>
-              </a:solidFill>
-            </a:endParaRPr>
-          </a:p>
-          <a:p>
-            <a:endParaRPr lang="ru-RU" sz="3500" dirty="0">
-              <a:solidFill>
-                <a:schemeClr val="bg1"/>
-              </a:solidFill>
-            </a:endParaRPr>
-          </a:p>
-          <a:p>
-            <a:r>
-              <a:rPr lang="ru-RU" sz="3500" dirty="0">
-                <a:solidFill>
-                  <a:schemeClr val="bg1"/>
-                </a:solidFill>
-              </a:rPr>
-              <a:t>Пример с </a:t>
-            </a:r>
-            <a:r>
-              <a:rPr lang="en-US" sz="3500" dirty="0">
-                <a:solidFill>
-                  <a:schemeClr val="bg1"/>
-                </a:solidFill>
-              </a:rPr>
-              <a:t>PDF:</a:t>
+              <a:rPr lang="ru-RU" sz="4000" dirty="0">
+                <a:solidFill>
+                  <a:schemeClr val="bg1"/>
+                </a:solidFill>
+              </a:rPr>
+              <a:t>Пользовательские проверки</a:t>
+            </a:r>
+            <a:r>
+              <a:rPr lang="en-US" sz="4000" dirty="0">
+                <a:solidFill>
+                  <a:schemeClr val="bg1"/>
+                </a:solidFill>
+              </a:rPr>
+              <a:t> (</a:t>
+            </a:r>
+            <a:r>
+              <a:rPr lang="ru-RU" sz="4000" dirty="0">
+                <a:solidFill>
+                  <a:schemeClr val="bg1"/>
+                </a:solidFill>
+              </a:rPr>
+              <a:t>новый этап</a:t>
+            </a:r>
+            <a:r>
+              <a:rPr lang="en-US" sz="4000" dirty="0">
+                <a:solidFill>
+                  <a:schemeClr val="bg1"/>
+                </a:solidFill>
+              </a:rPr>
+              <a:t>):</a:t>
             </a:r>
           </a:p>
         </p:txBody>
@@ -5884,7 +5308,7 @@
           <p:cNvPr id="4" name="Picture 3">
             <a:extLst>
               <a:ext uri="{FF2B5EF4-FFF2-40B4-BE49-F238E27FC236}">
-                <a16:creationId xmlns:a16="http://schemas.microsoft.com/office/drawing/2014/main" id="{35972AF4-F4D4-4CEB-B1B7-81649528FEF7}"/>
+                <a16:creationId xmlns:a16="http://schemas.microsoft.com/office/drawing/2014/main" id="{5C7B0AF3-88AE-43A0-8B71-8BF216994C55}"/>
               </a:ext>
             </a:extLst>
           </p:cNvPr>
@@ -5901,8 +5325,8 @@
         </p:blipFill>
         <p:spPr>
           <a:xfrm>
-            <a:off x="4053728" y="2590759"/>
-            <a:ext cx="4837015" cy="4267241"/>
+            <a:off x="1841863" y="2323918"/>
+            <a:ext cx="7190808" cy="4534082"/>
           </a:xfrm>
           <a:prstGeom prst="rect">
             <a:avLst/>
@@ -5912,7 +5336,7 @@
     </p:spTree>
     <p:extLst>
       <p:ext uri="{BB962C8B-B14F-4D97-AF65-F5344CB8AC3E}">
-        <p14:creationId xmlns:p14="http://schemas.microsoft.com/office/powerpoint/2010/main" val="3491224519"/>
+        <p14:creationId xmlns:p14="http://schemas.microsoft.com/office/powerpoint/2010/main" val="69623000"/>
       </p:ext>
     </p:extLst>
   </p:cSld>
@@ -6011,8 +5435,25 @@
                 <a:latin typeface="Arial" panose="020B0604020202020204" pitchFamily="34" charset="0"/>
                 <a:cs typeface="Arial" panose="020B0604020202020204" pitchFamily="34" charset="0"/>
               </a:rPr>
-              <a:t>Заключение</a:t>
-            </a:r>
+              <a:t>Интеграция </a:t>
+            </a:r>
+            <a:r>
+              <a:rPr lang="en-US" sz="4800" b="1" dirty="0">
+                <a:solidFill>
+                  <a:schemeClr val="bg1"/>
+                </a:solidFill>
+                <a:latin typeface="Arial" panose="020B0604020202020204" pitchFamily="34" charset="0"/>
+                <a:cs typeface="Arial" panose="020B0604020202020204" pitchFamily="34" charset="0"/>
+              </a:rPr>
+              <a:t>CI/CD</a:t>
+            </a:r>
+            <a:endParaRPr lang="ru-RU" sz="4800" b="1" dirty="0">
+              <a:solidFill>
+                <a:schemeClr val="bg1"/>
+              </a:solidFill>
+              <a:latin typeface="Arial" panose="020B0604020202020204" pitchFamily="34" charset="0"/>
+              <a:cs typeface="Arial" panose="020B0604020202020204" pitchFamily="34" charset="0"/>
+            </a:endParaRPr>
           </a:p>
         </p:txBody>
       </p:sp>
@@ -6062,7 +5503,7 @@
         <p:spPr>
           <a:xfrm>
             <a:off x="353137" y="1278425"/>
-            <a:ext cx="11615950" cy="4247317"/>
+            <a:ext cx="11615950" cy="707886"/>
           </a:xfrm>
           <a:prstGeom prst="rect">
             <a:avLst/>
@@ -6076,266 +5517,611 @@
           <a:lstStyle/>
           <a:p>
             <a:r>
-              <a:rPr lang="en-US" sz="3000" dirty="0">
-                <a:solidFill>
-                  <a:schemeClr val="bg1"/>
-                </a:solidFill>
-              </a:rPr>
-              <a:t>https://vtb.seag.pro</a:t>
-            </a:r>
-            <a:endParaRPr lang="ru-RU" sz="3000" dirty="0">
+              <a:rPr lang="ru-RU" sz="4000" dirty="0">
+                <a:solidFill>
+                  <a:schemeClr val="bg1"/>
+                </a:solidFill>
+              </a:rPr>
+              <a:t>Пример - </a:t>
+            </a:r>
+            <a:r>
+              <a:rPr lang="en-US" sz="4000" dirty="0">
+                <a:solidFill>
+                  <a:schemeClr val="bg1"/>
+                </a:solidFill>
+              </a:rPr>
+              <a:t>jenkins.seag.pro</a:t>
+            </a:r>
+            <a:endParaRPr lang="ru-RU" sz="4000" dirty="0">
               <a:solidFill>
                 <a:schemeClr val="bg1"/>
               </a:solidFill>
             </a:endParaRPr>
           </a:p>
-          <a:p>
-            <a:pPr marL="457200" indent="-457200">
+        </p:txBody>
+      </p:sp>
+      <p:pic>
+        <p:nvPicPr>
+          <p:cNvPr id="9" name="Рисунок 4" descr="Изображение выглядит как снимок экрана, синий, Цвет электрик, Прямоугольник&#10;&#10;Содержимое, созданное искусственным интеллектом, может быть неверным.">
+            <a:extLst>
+              <a:ext uri="{FF2B5EF4-FFF2-40B4-BE49-F238E27FC236}">
+                <a16:creationId xmlns:a16="http://schemas.microsoft.com/office/drawing/2014/main" id="{77AF8683-00C2-4C31-B71D-6642A6BA30D9}"/>
+              </a:ext>
+            </a:extLst>
+          </p:cNvPr>
+          <p:cNvPicPr>
+            <a:picLocks noChangeAspect="1"/>
+          </p:cNvPicPr>
+          <p:nvPr/>
+        </p:nvPicPr>
+        <p:blipFill>
+          <a:blip r:embed="rId2"/>
+          <a:stretch>
+            <a:fillRect/>
+          </a:stretch>
+        </p:blipFill>
+        <p:spPr>
+          <a:xfrm>
+            <a:off x="-1076325" y="2526667"/>
+            <a:ext cx="7172325" cy="3772664"/>
+          </a:xfrm>
+          <a:prstGeom prst="rect">
+            <a:avLst/>
+          </a:prstGeom>
+        </p:spPr>
+      </p:pic>
+      <p:sp>
+        <p:nvSpPr>
+          <p:cNvPr id="10" name="TextBox 9">
+            <a:extLst>
+              <a:ext uri="{FF2B5EF4-FFF2-40B4-BE49-F238E27FC236}">
+                <a16:creationId xmlns:a16="http://schemas.microsoft.com/office/drawing/2014/main" id="{AAD6FE32-7225-4A64-8D19-3C2CF0601F58}"/>
+              </a:ext>
+            </a:extLst>
+          </p:cNvPr>
+          <p:cNvSpPr txBox="1"/>
+          <p:nvPr/>
+        </p:nvSpPr>
+        <p:spPr>
+          <a:xfrm>
+            <a:off x="58713" y="2526666"/>
+            <a:ext cx="5721114" cy="2939266"/>
+          </a:xfrm>
+          <a:prstGeom prst="rect">
+            <a:avLst/>
+          </a:prstGeom>
+          <a:noFill/>
+        </p:spPr>
+        <p:txBody>
+          <a:bodyPr wrap="square" rtlCol="0">
+            <a:spAutoFit/>
+          </a:bodyPr>
+          <a:lstStyle/>
+          <a:p>
+            <a:r>
+              <a:rPr lang="ru-RU" sz="2500" b="1" dirty="0">
+                <a:solidFill>
+                  <a:schemeClr val="bg1"/>
+                </a:solidFill>
+                <a:latin typeface="Arial" panose="020B0604020202020204" pitchFamily="34" charset="0"/>
+                <a:cs typeface="Arial" panose="020B0604020202020204" pitchFamily="34" charset="0"/>
+              </a:rPr>
+              <a:t>Интеграция доступна через</a:t>
+            </a:r>
+            <a:r>
+              <a:rPr lang="en-US" sz="2500" b="1" dirty="0">
+                <a:solidFill>
+                  <a:schemeClr val="bg1"/>
+                </a:solidFill>
+                <a:latin typeface="Arial" panose="020B0604020202020204" pitchFamily="34" charset="0"/>
+                <a:cs typeface="Arial" panose="020B0604020202020204" pitchFamily="34" charset="0"/>
+              </a:rPr>
+              <a:t>:</a:t>
+            </a:r>
+          </a:p>
+          <a:p>
+            <a:pPr marL="342900" indent="-342900">
               <a:buFont typeface="Arial" panose="020B0604020202020204" pitchFamily="34" charset="0"/>
               <a:buChar char="•"/>
             </a:pPr>
-            <a:endParaRPr lang="en-US" sz="3000" dirty="0">
+            <a:r>
+              <a:rPr lang="en-US" sz="2500" b="1" dirty="0">
+                <a:solidFill>
+                  <a:schemeClr val="bg1"/>
+                </a:solidFill>
+                <a:latin typeface="Arial" panose="020B0604020202020204" pitchFamily="34" charset="0"/>
+                <a:cs typeface="Arial" panose="020B0604020202020204" pitchFamily="34" charset="0"/>
+              </a:rPr>
+              <a:t>Rest API</a:t>
+            </a:r>
+          </a:p>
+          <a:p>
+            <a:pPr marL="342900" indent="-342900">
+              <a:buFont typeface="Arial" panose="020B0604020202020204" pitchFamily="34" charset="0"/>
+              <a:buChar char="•"/>
+            </a:pPr>
+            <a:r>
+              <a:rPr lang="en-US" sz="2500" b="1" dirty="0" err="1">
+                <a:solidFill>
+                  <a:schemeClr val="bg1"/>
+                </a:solidFill>
+                <a:latin typeface="Arial" panose="020B0604020202020204" pitchFamily="34" charset="0"/>
+                <a:cs typeface="Arial" panose="020B0604020202020204" pitchFamily="34" charset="0"/>
+              </a:rPr>
+              <a:t>ApiSecurityCli</a:t>
+            </a:r>
+            <a:endParaRPr lang="ru-RU" sz="2500" b="1" dirty="0">
               <a:solidFill>
                 <a:schemeClr val="bg1"/>
               </a:solidFill>
+              <a:latin typeface="Arial" panose="020B0604020202020204" pitchFamily="34" charset="0"/>
+              <a:cs typeface="Arial" panose="020B0604020202020204" pitchFamily="34" charset="0"/>
             </a:endParaRPr>
           </a:p>
           <a:p>
-            <a:pPr marL="457200" indent="-457200">
-              <a:buFont typeface="Arial" panose="020B0604020202020204" pitchFamily="34" charset="0"/>
-              <a:buChar char="•"/>
-            </a:pPr>
-            <a:r>
-              <a:rPr lang="ru-RU" sz="2500" dirty="0">
-                <a:solidFill>
-                  <a:schemeClr val="bg1"/>
-                </a:solidFill>
-              </a:rPr>
-              <a:t>Решение универсально</a:t>
-            </a:r>
-          </a:p>
-          <a:p>
-            <a:pPr marL="457200" indent="-457200">
-              <a:buFont typeface="Arial" panose="020B0604020202020204" pitchFamily="34" charset="0"/>
-              <a:buChar char="•"/>
-            </a:pPr>
-            <a:r>
-              <a:rPr lang="ru-RU" sz="2500" dirty="0">
-                <a:solidFill>
-                  <a:schemeClr val="bg1"/>
-                </a:solidFill>
-              </a:rPr>
-              <a:t>Результаты разных способов поиска уязвимостей </a:t>
-            </a:r>
-            <a:r>
-              <a:rPr lang="ru-RU" sz="2500" dirty="0" err="1">
-                <a:solidFill>
-                  <a:schemeClr val="bg1"/>
-                </a:solidFill>
-              </a:rPr>
-              <a:t>агрегируются</a:t>
-            </a:r>
-            <a:r>
-              <a:rPr lang="ru-RU" sz="2500" dirty="0">
-                <a:solidFill>
-                  <a:schemeClr val="bg1"/>
-                </a:solidFill>
-              </a:rPr>
-              <a:t> в один отчет</a:t>
-            </a:r>
-          </a:p>
-          <a:p>
-            <a:pPr marL="457200" indent="-457200">
-              <a:buFont typeface="Arial" panose="020B0604020202020204" pitchFamily="34" charset="0"/>
-              <a:buChar char="•"/>
-            </a:pPr>
-            <a:r>
-              <a:rPr lang="ru-RU" sz="2500" dirty="0">
-                <a:solidFill>
-                  <a:schemeClr val="bg1"/>
-                </a:solidFill>
-              </a:rPr>
-              <a:t>Поддержка разных форматов отчетов – </a:t>
-            </a:r>
-            <a:r>
-              <a:rPr lang="en-US" sz="2500" dirty="0">
-                <a:solidFill>
-                  <a:schemeClr val="bg1"/>
-                </a:solidFill>
-              </a:rPr>
-              <a:t>json/html/PDF</a:t>
-            </a:r>
-          </a:p>
-          <a:p>
-            <a:pPr marL="457200" indent="-457200">
-              <a:buFont typeface="Arial" panose="020B0604020202020204" pitchFamily="34" charset="0"/>
-              <a:buChar char="•"/>
-            </a:pPr>
-            <a:r>
-              <a:rPr lang="ru-RU" sz="2500" dirty="0">
-                <a:solidFill>
-                  <a:schemeClr val="bg1"/>
-                </a:solidFill>
-              </a:rPr>
-              <a:t>Интеграция с </a:t>
-            </a:r>
-            <a:r>
-              <a:rPr lang="en-US" sz="2500" dirty="0">
-                <a:solidFill>
-                  <a:schemeClr val="bg1"/>
-                </a:solidFill>
-              </a:rPr>
-              <a:t>CI/CD</a:t>
-            </a:r>
-            <a:r>
-              <a:rPr lang="ru-RU" sz="2500" dirty="0">
-                <a:solidFill>
-                  <a:schemeClr val="bg1"/>
-                </a:solidFill>
-              </a:rPr>
-              <a:t> (на примере </a:t>
-            </a:r>
-            <a:r>
-              <a:rPr lang="en-US" sz="2500" dirty="0">
-                <a:solidFill>
-                  <a:schemeClr val="bg1"/>
-                </a:solidFill>
-              </a:rPr>
-              <a:t>Jenkins)</a:t>
-            </a:r>
-            <a:r>
-              <a:rPr lang="ru-RU" sz="2500" dirty="0">
-                <a:solidFill>
-                  <a:schemeClr val="bg1"/>
-                </a:solidFill>
-              </a:rPr>
-              <a:t> через </a:t>
-            </a:r>
-            <a:r>
-              <a:rPr lang="en-US" sz="2500" dirty="0" err="1">
-                <a:solidFill>
-                  <a:schemeClr val="bg1"/>
-                </a:solidFill>
-              </a:rPr>
-              <a:t>RestAPI</a:t>
-            </a:r>
-            <a:r>
-              <a:rPr lang="en-US" sz="2500" dirty="0">
-                <a:solidFill>
-                  <a:schemeClr val="bg1"/>
-                </a:solidFill>
+            <a:r>
+              <a:rPr lang="en-US" sz="1500" b="1" dirty="0" err="1">
+                <a:solidFill>
+                  <a:schemeClr val="bg1"/>
+                </a:solidFill>
+                <a:latin typeface="Arial" panose="020B0604020202020204" pitchFamily="34" charset="0"/>
+                <a:cs typeface="Arial" panose="020B0604020202020204" pitchFamily="34" charset="0"/>
+              </a:rPr>
+              <a:t>ApiSecurityCli</a:t>
+            </a:r>
+            <a:r>
+              <a:rPr lang="en-US" sz="1500" b="1" dirty="0">
+                <a:solidFill>
+                  <a:schemeClr val="bg1"/>
+                </a:solidFill>
+                <a:latin typeface="Arial" panose="020B0604020202020204" pitchFamily="34" charset="0"/>
+                <a:cs typeface="Arial" panose="020B0604020202020204" pitchFamily="34" charset="0"/>
               </a:rPr>
               <a:t> </a:t>
             </a:r>
             <a:r>
-              <a:rPr lang="ru-RU" sz="2500" dirty="0">
-                <a:solidFill>
-                  <a:schemeClr val="bg1"/>
-                </a:solidFill>
-              </a:rPr>
-              <a:t>или </a:t>
-            </a:r>
-            <a:r>
-              <a:rPr lang="en-US" sz="2500" dirty="0">
-                <a:solidFill>
-                  <a:schemeClr val="bg1"/>
-                </a:solidFill>
+              <a:rPr lang="ru-RU" sz="1500" b="1" dirty="0">
+                <a:solidFill>
+                  <a:schemeClr val="bg1"/>
+                </a:solidFill>
+                <a:latin typeface="Arial" panose="020B0604020202020204" pitchFamily="34" charset="0"/>
+                <a:cs typeface="Arial" panose="020B0604020202020204" pitchFamily="34" charset="0"/>
+              </a:rPr>
+              <a:t>в </a:t>
+            </a:r>
+            <a:r>
+              <a:rPr lang="ru-RU" sz="1500" b="1" dirty="0" err="1">
+                <a:solidFill>
+                  <a:schemeClr val="bg1"/>
+                </a:solidFill>
+                <a:latin typeface="Arial" panose="020B0604020202020204" pitchFamily="34" charset="0"/>
+                <a:cs typeface="Arial" panose="020B0604020202020204" pitchFamily="34" charset="0"/>
+              </a:rPr>
+              <a:t>стэйдже</a:t>
+            </a:r>
+            <a:r>
+              <a:rPr lang="ru-RU" sz="1500" b="1" dirty="0">
+                <a:solidFill>
+                  <a:schemeClr val="bg1"/>
+                </a:solidFill>
+                <a:latin typeface="Arial" panose="020B0604020202020204" pitchFamily="34" charset="0"/>
+                <a:cs typeface="Arial" panose="020B0604020202020204" pitchFamily="34" charset="0"/>
+              </a:rPr>
+              <a:t> </a:t>
+            </a:r>
+            <a:r>
+              <a:rPr lang="ru-RU" sz="1500" b="1" dirty="0" err="1">
+                <a:solidFill>
+                  <a:schemeClr val="bg1"/>
+                </a:solidFill>
+                <a:latin typeface="Arial" panose="020B0604020202020204" pitchFamily="34" charset="0"/>
+                <a:cs typeface="Arial" panose="020B0604020202020204" pitchFamily="34" charset="0"/>
+              </a:rPr>
+              <a:t>пайплайна</a:t>
+            </a:r>
+            <a:r>
+              <a:rPr lang="ru-RU" sz="1500" b="1" dirty="0">
+                <a:solidFill>
+                  <a:schemeClr val="bg1"/>
+                </a:solidFill>
+                <a:latin typeface="Arial" panose="020B0604020202020204" pitchFamily="34" charset="0"/>
+                <a:cs typeface="Arial" panose="020B0604020202020204" pitchFamily="34" charset="0"/>
+              </a:rPr>
+              <a:t> вызывается через скрипт </a:t>
+            </a:r>
+            <a:r>
+              <a:rPr lang="en-US" sz="1500" b="1" dirty="0">
+                <a:solidFill>
+                  <a:schemeClr val="bg1"/>
+                </a:solidFill>
+                <a:latin typeface="Arial" panose="020B0604020202020204" pitchFamily="34" charset="0"/>
+                <a:cs typeface="Arial" panose="020B0604020202020204" pitchFamily="34" charset="0"/>
+              </a:rPr>
+              <a:t>cli.sh</a:t>
+            </a:r>
+            <a:r>
+              <a:rPr lang="ru-RU" sz="1500" b="1" dirty="0">
+                <a:solidFill>
+                  <a:schemeClr val="bg1"/>
+                </a:solidFill>
+                <a:latin typeface="Arial" panose="020B0604020202020204" pitchFamily="34" charset="0"/>
+                <a:cs typeface="Arial" panose="020B0604020202020204" pitchFamily="34" charset="0"/>
+              </a:rPr>
+              <a:t> (пример справа), в перспективе – разработка отдельного исполняемого </a:t>
+            </a:r>
+            <a:r>
+              <a:rPr lang="en-US" sz="1500" b="1" dirty="0">
+                <a:solidFill>
+                  <a:schemeClr val="bg1"/>
+                </a:solidFill>
+                <a:latin typeface="Arial" panose="020B0604020202020204" pitchFamily="34" charset="0"/>
+                <a:cs typeface="Arial" panose="020B0604020202020204" pitchFamily="34" charset="0"/>
               </a:rPr>
               <a:t>CLI</a:t>
             </a:r>
             <a:r>
-              <a:rPr lang="ru-RU" sz="2500" dirty="0">
-                <a:solidFill>
-                  <a:schemeClr val="bg1"/>
-                </a:solidFill>
-              </a:rPr>
-              <a:t> (пока скрипт</a:t>
-            </a:r>
-            <a:r>
-              <a:rPr lang="en-US" sz="2500" dirty="0">
-                <a:solidFill>
-                  <a:schemeClr val="bg1"/>
-                </a:solidFill>
-              </a:rPr>
-              <a:t>-&gt;ApiSecurityCli.java</a:t>
-            </a:r>
-            <a:r>
-              <a:rPr lang="ru-RU" sz="2500" dirty="0">
-                <a:solidFill>
-                  <a:schemeClr val="bg1"/>
-                </a:solidFill>
-              </a:rPr>
-              <a:t>, в перспективе — исполняемый файл, разработанный на </a:t>
-            </a:r>
-            <a:r>
-              <a:rPr lang="en-US" sz="2500" dirty="0" err="1">
-                <a:solidFill>
-                  <a:schemeClr val="bg1"/>
-                </a:solidFill>
+              <a:rPr lang="ru-RU" sz="1500" b="1" dirty="0">
+                <a:solidFill>
+                  <a:schemeClr val="bg1"/>
+                </a:solidFill>
+                <a:latin typeface="Arial" panose="020B0604020202020204" pitchFamily="34" charset="0"/>
+                <a:cs typeface="Arial" panose="020B0604020202020204" pitchFamily="34" charset="0"/>
+              </a:rPr>
+              <a:t>-инструмента на </a:t>
+            </a:r>
+            <a:r>
+              <a:rPr lang="en-US" sz="1500" b="1" dirty="0" err="1">
+                <a:solidFill>
+                  <a:schemeClr val="bg1"/>
+                </a:solidFill>
+                <a:latin typeface="Arial" panose="020B0604020202020204" pitchFamily="34" charset="0"/>
+                <a:cs typeface="Arial" panose="020B0604020202020204" pitchFamily="34" charset="0"/>
               </a:rPr>
               <a:t>GoLang</a:t>
             </a:r>
-            <a:r>
-              <a:rPr lang="ru-RU" sz="2500" dirty="0">
-                <a:solidFill>
-                  <a:schemeClr val="bg1"/>
-                </a:solidFill>
-              </a:rPr>
-              <a:t>) </a:t>
-            </a:r>
-            <a:endParaRPr lang="en-US" sz="2500" dirty="0">
+            <a:endParaRPr lang="ru-RU" sz="1500" b="1" dirty="0">
               <a:solidFill>
                 <a:schemeClr val="bg1"/>
               </a:solidFill>
+              <a:latin typeface="Arial" panose="020B0604020202020204" pitchFamily="34" charset="0"/>
+              <a:cs typeface="Arial" panose="020B0604020202020204" pitchFamily="34" charset="0"/>
             </a:endParaRPr>
           </a:p>
           <a:p>
-            <a:pPr marL="457200" indent="-457200">
-              <a:buFont typeface="Arial" panose="020B0604020202020204" pitchFamily="34" charset="0"/>
-              <a:buChar char="•"/>
-            </a:pPr>
-            <a:r>
-              <a:rPr lang="ru-RU" sz="2500" dirty="0">
-                <a:solidFill>
-                  <a:schemeClr val="bg1"/>
-                </a:solidFill>
-              </a:rPr>
-              <a:t>Результат анализа в </a:t>
-            </a:r>
-            <a:r>
-              <a:rPr lang="en-US" sz="2500" dirty="0">
-                <a:solidFill>
-                  <a:schemeClr val="bg1"/>
-                </a:solidFill>
-              </a:rPr>
-              <a:t>CI/CD — </a:t>
-            </a:r>
-            <a:r>
-              <a:rPr lang="ru-RU" sz="2500" dirty="0">
-                <a:solidFill>
-                  <a:schemeClr val="bg1"/>
-                </a:solidFill>
-              </a:rPr>
-              <a:t>ссылки на опубликованные отчеты</a:t>
-            </a:r>
-          </a:p>
-          <a:p>
-            <a:pPr marL="457200" indent="-457200">
-              <a:buFont typeface="Arial" panose="020B0604020202020204" pitchFamily="34" charset="0"/>
-              <a:buChar char="•"/>
-            </a:pPr>
-            <a:endParaRPr lang="en-US" sz="3500" dirty="0">
+            <a:endParaRPr lang="ru-RU" sz="1500" b="1" dirty="0">
               <a:solidFill>
                 <a:schemeClr val="bg1"/>
               </a:solidFill>
+              <a:latin typeface="Arial" panose="020B0604020202020204" pitchFamily="34" charset="0"/>
+              <a:cs typeface="Arial" panose="020B0604020202020204" pitchFamily="34" charset="0"/>
             </a:endParaRPr>
           </a:p>
-        </p:txBody>
-      </p:sp>
+          <a:p>
+            <a:r>
+              <a:rPr lang="ru-RU" sz="2500" b="1" dirty="0">
+                <a:solidFill>
+                  <a:schemeClr val="bg1"/>
+                </a:solidFill>
+                <a:latin typeface="Arial" panose="020B0604020202020204" pitchFamily="34" charset="0"/>
+                <a:cs typeface="Arial" panose="020B0604020202020204" pitchFamily="34" charset="0"/>
+              </a:rPr>
+              <a:t>Результат — проведенный поиск уязвимостей и ссылки на отчет</a:t>
+            </a:r>
+          </a:p>
+        </p:txBody>
+      </p:sp>
+      <p:sp>
+        <p:nvSpPr>
+          <p:cNvPr id="11" name="Rectangle 1">
+            <a:extLst>
+              <a:ext uri="{FF2B5EF4-FFF2-40B4-BE49-F238E27FC236}">
+                <a16:creationId xmlns:a16="http://schemas.microsoft.com/office/drawing/2014/main" id="{879FC0C0-F530-4314-8B3F-D19FEDEB2EA3}"/>
+              </a:ext>
+            </a:extLst>
+          </p:cNvPr>
+          <p:cNvSpPr>
+            <a:spLocks noChangeArrowheads="1"/>
+          </p:cNvSpPr>
+          <p:nvPr/>
+        </p:nvSpPr>
+        <p:spPr bwMode="auto">
+          <a:xfrm>
+            <a:off x="0" y="0"/>
+            <a:ext cx="12192000" cy="457200"/>
+          </a:xfrm>
+          <a:prstGeom prst="rect">
+            <a:avLst/>
+          </a:prstGeom>
+          <a:solidFill>
+            <a:srgbClr val="1E1F22"/>
+          </a:solidFill>
+          <a:ln>
+            <a:noFill/>
+          </a:ln>
+          <a:effectLst/>
+          <a:extLst>
+            <a:ext uri="{91240B29-F687-4F45-9708-019B960494DF}">
+              <a14:hiddenLine xmlns:a14="http://schemas.microsoft.com/office/drawing/2010/main" w="9525">
+                <a:solidFill>
+                  <a:schemeClr val="tx1"/>
+                </a:solidFill>
+                <a:miter lim="800000"/>
+                <a:headEnd/>
+                <a:tailEnd/>
+              </a14:hiddenLine>
+            </a:ext>
+            <a:ext uri="{AF507438-7753-43E0-B8FC-AC1667EBCBE1}">
+              <a14:hiddenEffects xmlns:a14="http://schemas.microsoft.com/office/drawing/2010/main">
+                <a:effectLst>
+                  <a:outerShdw dist="35921" dir="2700000" algn="ctr" rotWithShape="0">
+                    <a:schemeClr val="bg2"/>
+                  </a:outerShdw>
+                </a:effectLst>
+              </a14:hiddenEffects>
+            </a:ext>
+          </a:extLst>
+        </p:spPr>
+        <p:txBody>
+          <a:bodyPr vert="horz" wrap="none" lIns="91440" tIns="45720" rIns="91440" bIns="45720" numCol="1" anchor="ctr" anchorCtr="0" compatLnSpc="1">
+            <a:prstTxWarp prst="textNoShape">
+              <a:avLst/>
+            </a:prstTxWarp>
+            <a:spAutoFit/>
+          </a:bodyPr>
+          <a:lstStyle/>
+          <a:p>
+            <a:pPr marL="0" marR="0" lvl="0" indent="0" algn="l" defTabSz="914400" rtl="0" eaLnBrk="0" fontAlgn="base" latinLnBrk="0" hangingPunct="0">
+              <a:lnSpc>
+                <a:spcPct val="100000"/>
+              </a:lnSpc>
+              <a:spcBef>
+                <a:spcPct val="0"/>
+              </a:spcBef>
+              <a:spcAft>
+                <a:spcPct val="0"/>
+              </a:spcAft>
+              <a:buClrTx/>
+              <a:buSzTx/>
+              <a:buFontTx/>
+              <a:buNone/>
+              <a:tabLst/>
+            </a:pPr>
+            <a:r>
+              <a:rPr kumimoji="0" lang="en-US" altLang="en-US" sz="900" b="0" i="0" u="none" strike="noStrike" cap="none" normalizeH="0" baseline="0">
+                <a:ln>
+                  <a:noFill/>
+                </a:ln>
+                <a:solidFill>
+                  <a:srgbClr val="BCBEC4"/>
+                </a:solidFill>
+                <a:effectLst/>
+                <a:latin typeface="JetBrains Mono"/>
+              </a:rPr>
+              <a:t>ApiSecurityCli</a:t>
+            </a:r>
+            <a:endParaRPr kumimoji="0" lang="en-US" altLang="en-US" sz="1800" b="0" i="0" u="none" strike="noStrike" cap="none" normalizeH="0" baseline="0">
+              <a:ln>
+                <a:noFill/>
+              </a:ln>
+              <a:solidFill>
+                <a:schemeClr val="tx1"/>
+              </a:solidFill>
+              <a:effectLst/>
+              <a:latin typeface="Arial" panose="020B0604020202020204" pitchFamily="34" charset="0"/>
+            </a:endParaRPr>
+          </a:p>
+        </p:txBody>
+      </p:sp>
+      <p:pic>
+        <p:nvPicPr>
+          <p:cNvPr id="14" name="Picture 13">
+            <a:extLst>
+              <a:ext uri="{FF2B5EF4-FFF2-40B4-BE49-F238E27FC236}">
+                <a16:creationId xmlns:a16="http://schemas.microsoft.com/office/drawing/2014/main" id="{E40BAEB2-1385-4F6A-80E0-2B6C386FDA5A}"/>
+              </a:ext>
+            </a:extLst>
+          </p:cNvPr>
+          <p:cNvPicPr>
+            <a:picLocks noChangeAspect="1"/>
+          </p:cNvPicPr>
+          <p:nvPr/>
+        </p:nvPicPr>
+        <p:blipFill>
+          <a:blip r:embed="rId4"/>
+          <a:stretch>
+            <a:fillRect/>
+          </a:stretch>
+        </p:blipFill>
+        <p:spPr>
+          <a:xfrm>
+            <a:off x="6266512" y="1156750"/>
+            <a:ext cx="5765872" cy="5685697"/>
+          </a:xfrm>
+          <a:prstGeom prst="rect">
+            <a:avLst/>
+          </a:prstGeom>
+        </p:spPr>
+      </p:pic>
+      <p:sp>
+        <p:nvSpPr>
+          <p:cNvPr id="15" name="Speech Bubble: Rectangle with Corners Rounded 14">
+            <a:extLst>
+              <a:ext uri="{FF2B5EF4-FFF2-40B4-BE49-F238E27FC236}">
+                <a16:creationId xmlns:a16="http://schemas.microsoft.com/office/drawing/2014/main" id="{C27527F2-1A30-4BF8-86C7-789E3C09113A}"/>
+              </a:ext>
+            </a:extLst>
+          </p:cNvPr>
+          <p:cNvSpPr/>
+          <p:nvPr/>
+        </p:nvSpPr>
+        <p:spPr>
+          <a:xfrm>
+            <a:off x="2973861" y="5636549"/>
+            <a:ext cx="2805966" cy="1026080"/>
+          </a:xfrm>
+          <a:prstGeom prst="wedgeRoundRectCallout">
+            <a:avLst/>
+          </a:prstGeom>
+          <a:solidFill>
+            <a:srgbClr val="FFFFF3"/>
+          </a:solidFill>
+        </p:spPr>
+        <p:style>
+          <a:lnRef idx="2">
+            <a:schemeClr val="accent1">
+              <a:shade val="50000"/>
+            </a:schemeClr>
+          </a:lnRef>
+          <a:fillRef idx="1">
+            <a:schemeClr val="accent1"/>
+          </a:fillRef>
+          <a:effectRef idx="0">
+            <a:schemeClr val="accent1"/>
+          </a:effectRef>
+          <a:fontRef idx="minor">
+            <a:schemeClr val="lt1"/>
+          </a:fontRef>
+        </p:style>
+        <p:txBody>
+          <a:bodyPr rtlCol="0" anchor="ctr"/>
+          <a:lstStyle/>
+          <a:p>
+            <a:pPr algn="ctr"/>
+            <a:r>
+              <a:rPr lang="ru-RU" dirty="0">
+                <a:solidFill>
+                  <a:schemeClr val="tx1"/>
+                </a:solidFill>
+              </a:rPr>
+              <a:t>Что будет если перейти по ссылке из </a:t>
+            </a:r>
+            <a:r>
+              <a:rPr lang="en-US" dirty="0">
+                <a:solidFill>
+                  <a:schemeClr val="tx1"/>
+                </a:solidFill>
+              </a:rPr>
+              <a:t>console output </a:t>
+            </a:r>
+            <a:r>
+              <a:rPr lang="ru-RU" dirty="0">
+                <a:solidFill>
+                  <a:schemeClr val="tx1"/>
+                </a:solidFill>
+              </a:rPr>
+              <a:t>в </a:t>
+            </a:r>
+            <a:r>
+              <a:rPr lang="en-US" dirty="0">
+                <a:solidFill>
+                  <a:schemeClr val="tx1"/>
+                </a:solidFill>
+              </a:rPr>
+              <a:t>Jenkins?</a:t>
+            </a:r>
+          </a:p>
+        </p:txBody>
+      </p:sp>
+      <p:sp>
+        <p:nvSpPr>
+          <p:cNvPr id="17" name="Rectangle: Rounded Corners 16">
+            <a:extLst>
+              <a:ext uri="{FF2B5EF4-FFF2-40B4-BE49-F238E27FC236}">
+                <a16:creationId xmlns:a16="http://schemas.microsoft.com/office/drawing/2014/main" id="{CFF1EA24-D208-438D-869F-2EE7BDDEB6F7}"/>
+              </a:ext>
+            </a:extLst>
+          </p:cNvPr>
+          <p:cNvSpPr/>
+          <p:nvPr/>
+        </p:nvSpPr>
+        <p:spPr>
+          <a:xfrm>
+            <a:off x="6434919" y="5561463"/>
+            <a:ext cx="5076043" cy="1207827"/>
+          </a:xfrm>
+          <a:prstGeom prst="roundRect">
+            <a:avLst/>
+          </a:prstGeom>
+          <a:noFill/>
+          <a:ln>
+            <a:solidFill>
+              <a:srgbClr val="FF0000"/>
+            </a:solidFill>
+          </a:ln>
+        </p:spPr>
+        <p:style>
+          <a:lnRef idx="2">
+            <a:schemeClr val="accent1">
+              <a:shade val="50000"/>
+            </a:schemeClr>
+          </a:lnRef>
+          <a:fillRef idx="1">
+            <a:schemeClr val="accent1"/>
+          </a:fillRef>
+          <a:effectRef idx="0">
+            <a:schemeClr val="accent1"/>
+          </a:effectRef>
+          <a:fontRef idx="minor">
+            <a:schemeClr val="lt1"/>
+          </a:fontRef>
+        </p:style>
+        <p:txBody>
+          <a:bodyPr rtlCol="0" anchor="ctr"/>
+          <a:lstStyle/>
+          <a:p>
+            <a:pPr algn="ctr"/>
+            <a:endParaRPr lang="en-US"/>
+          </a:p>
+        </p:txBody>
+      </p:sp>
+      <p:cxnSp>
+        <p:nvCxnSpPr>
+          <p:cNvPr id="19" name="Straight Arrow Connector 18">
+            <a:extLst>
+              <a:ext uri="{FF2B5EF4-FFF2-40B4-BE49-F238E27FC236}">
+                <a16:creationId xmlns:a16="http://schemas.microsoft.com/office/drawing/2014/main" id="{C2B90DB5-FC1F-4982-AA7F-CE9D97A883A6}"/>
+              </a:ext>
+            </a:extLst>
+          </p:cNvPr>
+          <p:cNvCxnSpPr>
+            <a:stCxn id="15" idx="3"/>
+          </p:cNvCxnSpPr>
+          <p:nvPr/>
+        </p:nvCxnSpPr>
+        <p:spPr>
+          <a:xfrm flipV="1">
+            <a:off x="5779827" y="5827594"/>
+            <a:ext cx="655092" cy="321995"/>
+          </a:xfrm>
+          <a:prstGeom prst="straightConnector1">
+            <a:avLst/>
+          </a:prstGeom>
+          <a:ln>
+            <a:solidFill>
+              <a:srgbClr val="FF0000"/>
+            </a:solidFill>
+            <a:tailEnd type="triangle"/>
+          </a:ln>
+        </p:spPr>
+        <p:style>
+          <a:lnRef idx="2">
+            <a:schemeClr val="accent1"/>
+          </a:lnRef>
+          <a:fillRef idx="0">
+            <a:schemeClr val="accent1"/>
+          </a:fillRef>
+          <a:effectRef idx="1">
+            <a:schemeClr val="accent1"/>
+          </a:effectRef>
+          <a:fontRef idx="minor">
+            <a:schemeClr val="tx1"/>
+          </a:fontRef>
+        </p:style>
+      </p:cxnSp>
     </p:spTree>
     <p:extLst>
       <p:ext uri="{BB962C8B-B14F-4D97-AF65-F5344CB8AC3E}">
-        <p14:creationId xmlns:p14="http://schemas.microsoft.com/office/powerpoint/2010/main" val="2438306394"/>
+        <p14:creationId xmlns:p14="http://schemas.microsoft.com/office/powerpoint/2010/main" val="2208890552"/>
       </p:ext>
     </p:extLst>
   </p:cSld>
@@ -6434,7 +6220,7 @@
                 <a:latin typeface="Arial" panose="020B0604020202020204" pitchFamily="34" charset="0"/>
                 <a:cs typeface="Arial" panose="020B0604020202020204" pitchFamily="34" charset="0"/>
               </a:rPr>
-              <a:t>И на последок</a:t>
+              <a:t>Интеграция </a:t>
             </a:r>
             <a:r>
               <a:rPr lang="en-US" sz="4800" b="1" dirty="0">
@@ -6444,7 +6230,7 @@
                 <a:latin typeface="Arial" panose="020B0604020202020204" pitchFamily="34" charset="0"/>
                 <a:cs typeface="Arial" panose="020B0604020202020204" pitchFamily="34" charset="0"/>
               </a:rPr>
-              <a:t>:</a:t>
+              <a:t>CI/CD</a:t>
             </a:r>
             <a:endParaRPr lang="ru-RU" sz="4800" b="1" dirty="0">
               <a:solidFill>
@@ -6487,12 +6273,166 @@
           </a:prstGeom>
         </p:spPr>
       </p:pic>
+      <p:sp>
+        <p:nvSpPr>
+          <p:cNvPr id="8" name="TextBox 7">
+            <a:extLst>
+              <a:ext uri="{FF2B5EF4-FFF2-40B4-BE49-F238E27FC236}">
+                <a16:creationId xmlns:a16="http://schemas.microsoft.com/office/drawing/2014/main" id="{CB97A419-BFA9-4559-A4E7-ED690CFF73C8}"/>
+              </a:ext>
+            </a:extLst>
+          </p:cNvPr>
+          <p:cNvSpPr txBox="1"/>
+          <p:nvPr/>
+        </p:nvSpPr>
+        <p:spPr>
+          <a:xfrm>
+            <a:off x="353137" y="1278425"/>
+            <a:ext cx="11615950" cy="707886"/>
+          </a:xfrm>
+          <a:prstGeom prst="rect">
+            <a:avLst/>
+          </a:prstGeom>
+          <a:noFill/>
+        </p:spPr>
+        <p:txBody>
+          <a:bodyPr wrap="square">
+            <a:spAutoFit/>
+          </a:bodyPr>
+          <a:lstStyle/>
+          <a:p>
+            <a:r>
+              <a:rPr lang="ru-RU" sz="4000" dirty="0">
+                <a:solidFill>
+                  <a:schemeClr val="bg1"/>
+                </a:solidFill>
+              </a:rPr>
+              <a:t>Что доступно по ссылке из отчета в </a:t>
+            </a:r>
+            <a:r>
+              <a:rPr lang="en-US" sz="4000" dirty="0">
+                <a:solidFill>
+                  <a:schemeClr val="bg1"/>
+                </a:solidFill>
+              </a:rPr>
+              <a:t>CI/CD ?</a:t>
+            </a:r>
+            <a:endParaRPr lang="ru-RU" sz="4000" dirty="0">
+              <a:solidFill>
+                <a:schemeClr val="bg1"/>
+              </a:solidFill>
+            </a:endParaRPr>
+          </a:p>
+        </p:txBody>
+      </p:sp>
+      <p:sp>
+        <p:nvSpPr>
+          <p:cNvPr id="11" name="Rectangle 1">
+            <a:extLst>
+              <a:ext uri="{FF2B5EF4-FFF2-40B4-BE49-F238E27FC236}">
+                <a16:creationId xmlns:a16="http://schemas.microsoft.com/office/drawing/2014/main" id="{879FC0C0-F530-4314-8B3F-D19FEDEB2EA3}"/>
+              </a:ext>
+            </a:extLst>
+          </p:cNvPr>
+          <p:cNvSpPr>
+            <a:spLocks noChangeArrowheads="1"/>
+          </p:cNvSpPr>
+          <p:nvPr/>
+        </p:nvSpPr>
+        <p:spPr bwMode="auto">
+          <a:xfrm>
+            <a:off x="0" y="0"/>
+            <a:ext cx="12192000" cy="457200"/>
+          </a:xfrm>
+          <a:prstGeom prst="rect">
+            <a:avLst/>
+          </a:prstGeom>
+          <a:solidFill>
+            <a:srgbClr val="1E1F22"/>
+          </a:solidFill>
+          <a:ln>
+            <a:noFill/>
+          </a:ln>
+          <a:effectLst/>
+          <a:extLst>
+            <a:ext uri="{91240B29-F687-4F45-9708-019B960494DF}">
+              <a14:hiddenLine xmlns:a14="http://schemas.microsoft.com/office/drawing/2010/main" w="9525">
+                <a:solidFill>
+                  <a:schemeClr val="tx1"/>
+                </a:solidFill>
+                <a:miter lim="800000"/>
+                <a:headEnd/>
+                <a:tailEnd/>
+              </a14:hiddenLine>
+            </a:ext>
+            <a:ext uri="{AF507438-7753-43E0-B8FC-AC1667EBCBE1}">
+              <a14:hiddenEffects xmlns:a14="http://schemas.microsoft.com/office/drawing/2010/main">
+                <a:effectLst>
+                  <a:outerShdw dist="35921" dir="2700000" algn="ctr" rotWithShape="0">
+                    <a:schemeClr val="bg2"/>
+                  </a:outerShdw>
+                </a:effectLst>
+              </a14:hiddenEffects>
+            </a:ext>
+          </a:extLst>
+        </p:spPr>
+        <p:txBody>
+          <a:bodyPr vert="horz" wrap="none" lIns="91440" tIns="45720" rIns="91440" bIns="45720" numCol="1" anchor="ctr" anchorCtr="0" compatLnSpc="1">
+            <a:prstTxWarp prst="textNoShape">
+              <a:avLst/>
+            </a:prstTxWarp>
+            <a:spAutoFit/>
+          </a:bodyPr>
+          <a:lstStyle/>
+          <a:p>
+            <a:pPr marL="0" marR="0" lvl="0" indent="0" algn="l" defTabSz="914400" rtl="0" eaLnBrk="0" fontAlgn="base" latinLnBrk="0" hangingPunct="0">
+              <a:lnSpc>
+                <a:spcPct val="100000"/>
+              </a:lnSpc>
+              <a:spcBef>
+                <a:spcPct val="0"/>
+              </a:spcBef>
+              <a:spcAft>
+                <a:spcPct val="0"/>
+              </a:spcAft>
+              <a:buClrTx/>
+              <a:buSzTx/>
+              <a:buFontTx/>
+              <a:buNone/>
+              <a:tabLst/>
+            </a:pPr>
+            <a:r>
+              <a:rPr kumimoji="0" lang="en-US" altLang="en-US" sz="900" b="0" i="0" u="none" strike="noStrike" cap="none" normalizeH="0" baseline="0">
+                <a:ln>
+                  <a:noFill/>
+                </a:ln>
+                <a:solidFill>
+                  <a:srgbClr val="BCBEC4"/>
+                </a:solidFill>
+                <a:effectLst/>
+                <a:latin typeface="JetBrains Mono"/>
+              </a:rPr>
+              <a:t>ApiSecurityCli</a:t>
+            </a:r>
+            <a:endParaRPr kumimoji="0" lang="en-US" altLang="en-US" sz="1800" b="0" i="0" u="none" strike="noStrike" cap="none" normalizeH="0" baseline="0">
+              <a:ln>
+                <a:noFill/>
+              </a:ln>
+              <a:solidFill>
+                <a:schemeClr val="tx1"/>
+              </a:solidFill>
+              <a:effectLst/>
+              <a:latin typeface="Arial" panose="020B0604020202020204" pitchFamily="34" charset="0"/>
+            </a:endParaRPr>
+          </a:p>
+        </p:txBody>
+      </p:sp>
       <p:pic>
         <p:nvPicPr>
-          <p:cNvPr id="7" name="Рисунок 10" descr="Изображение выглядит как снимок экрана, синий, Цвет электрик, Прямоугольник&#10;&#10;Содержимое, созданное искусственным интеллектом, может быть неверным.">
-            <a:extLst>
-              <a:ext uri="{FF2B5EF4-FFF2-40B4-BE49-F238E27FC236}">
-                <a16:creationId xmlns:a16="http://schemas.microsoft.com/office/drawing/2014/main" id="{5EA35797-7A5F-42B6-84A3-1612AC4CD33E}"/>
+          <p:cNvPr id="4" name="Picture 3">
+            <a:extLst>
+              <a:ext uri="{FF2B5EF4-FFF2-40B4-BE49-F238E27FC236}">
+                <a16:creationId xmlns:a16="http://schemas.microsoft.com/office/drawing/2014/main" id="{9ED9C620-54C4-440D-BAE6-A6FBAF942564}"/>
               </a:ext>
             </a:extLst>
           </p:cNvPr>
@@ -6509,248 +6449,18 @@
         </p:blipFill>
         <p:spPr>
           <a:xfrm>
-            <a:off x="9102847" y="3836372"/>
-            <a:ext cx="2022415" cy="439526"/>
+            <a:off x="1903863" y="1948417"/>
+            <a:ext cx="8266706" cy="4909583"/>
           </a:xfrm>
           <a:prstGeom prst="rect">
             <a:avLst/>
           </a:prstGeom>
         </p:spPr>
       </p:pic>
-      <p:sp>
-        <p:nvSpPr>
-          <p:cNvPr id="9" name="TextBox 8">
-            <a:extLst>
-              <a:ext uri="{FF2B5EF4-FFF2-40B4-BE49-F238E27FC236}">
-                <a16:creationId xmlns:a16="http://schemas.microsoft.com/office/drawing/2014/main" id="{DF917BA8-86C4-4DE1-B727-102A351D4C1E}"/>
-              </a:ext>
-            </a:extLst>
-          </p:cNvPr>
-          <p:cNvSpPr txBox="1"/>
-          <p:nvPr/>
-        </p:nvSpPr>
-        <p:spPr>
-          <a:xfrm>
-            <a:off x="9216972" y="3862659"/>
-            <a:ext cx="1908290" cy="369332"/>
-          </a:xfrm>
-          <a:prstGeom prst="rect">
-            <a:avLst/>
-          </a:prstGeom>
-          <a:noFill/>
-        </p:spPr>
-        <p:txBody>
-          <a:bodyPr wrap="square" rtlCol="0">
-            <a:spAutoFit/>
-          </a:bodyPr>
-          <a:lstStyle/>
-          <a:p>
-            <a:r>
-              <a:rPr lang="ru-RU" b="1" dirty="0">
-                <a:solidFill>
-                  <a:schemeClr val="bg1"/>
-                </a:solidFill>
-                <a:latin typeface="Arial" panose="020B0604020202020204" pitchFamily="34" charset="0"/>
-                <a:cs typeface="Arial" panose="020B0604020202020204" pitchFamily="34" charset="0"/>
-              </a:rPr>
-              <a:t>Алексей Чайка</a:t>
-            </a:r>
-          </a:p>
-        </p:txBody>
-      </p:sp>
-      <p:sp>
-        <p:nvSpPr>
-          <p:cNvPr id="10" name="TextBox 9">
-            <a:extLst>
-              <a:ext uri="{FF2B5EF4-FFF2-40B4-BE49-F238E27FC236}">
-                <a16:creationId xmlns:a16="http://schemas.microsoft.com/office/drawing/2014/main" id="{D264D346-BDC7-4FCE-82FA-3723D5EF6917}"/>
-              </a:ext>
-            </a:extLst>
-          </p:cNvPr>
-          <p:cNvSpPr txBox="1"/>
-          <p:nvPr/>
-        </p:nvSpPr>
-        <p:spPr>
-          <a:xfrm>
-            <a:off x="8908868" y="4376013"/>
-            <a:ext cx="3236648" cy="369332"/>
-          </a:xfrm>
-          <a:prstGeom prst="rect">
-            <a:avLst/>
-          </a:prstGeom>
-          <a:noFill/>
-        </p:spPr>
-        <p:txBody>
-          <a:bodyPr wrap="square" rtlCol="0">
-            <a:spAutoFit/>
-          </a:bodyPr>
-          <a:lstStyle/>
-          <a:p>
-            <a:r>
-              <a:rPr lang="ru-RU" dirty="0">
-                <a:solidFill>
-                  <a:schemeClr val="bg1"/>
-                </a:solidFill>
-                <a:latin typeface="Arial" panose="020B0604020202020204" pitchFamily="34" charset="0"/>
-                <a:cs typeface="Arial" panose="020B0604020202020204" pitchFamily="34" charset="0"/>
-              </a:rPr>
-              <a:t>Капитан-разработчик</a:t>
-            </a:r>
-          </a:p>
-        </p:txBody>
-      </p:sp>
-      <p:sp>
-        <p:nvSpPr>
-          <p:cNvPr id="11" name="Овал 21">
-            <a:extLst>
-              <a:ext uri="{FF2B5EF4-FFF2-40B4-BE49-F238E27FC236}">
-                <a16:creationId xmlns:a16="http://schemas.microsoft.com/office/drawing/2014/main" id="{27B26304-5A2C-444A-B0A0-FFC33B7D2390}"/>
-              </a:ext>
-            </a:extLst>
-          </p:cNvPr>
-          <p:cNvSpPr/>
-          <p:nvPr/>
-        </p:nvSpPr>
-        <p:spPr>
-          <a:xfrm>
-            <a:off x="9159909" y="1687788"/>
-            <a:ext cx="1908290" cy="1909523"/>
-          </a:xfrm>
-          <a:prstGeom prst="ellipse">
-            <a:avLst/>
-          </a:prstGeom>
-          <a:blipFill>
-            <a:blip r:embed="rId5"/>
-            <a:stretch>
-              <a:fillRect/>
-            </a:stretch>
-          </a:blipFill>
-          <a:ln w="57150">
-            <a:solidFill>
-              <a:srgbClr val="05AEFF"/>
-            </a:solidFill>
-          </a:ln>
-        </p:spPr>
-        <p:style>
-          <a:lnRef idx="2">
-            <a:schemeClr val="accent1">
-              <a:shade val="15000"/>
-            </a:schemeClr>
-          </a:lnRef>
-          <a:fillRef idx="1">
-            <a:schemeClr val="accent1"/>
-          </a:fillRef>
-          <a:effectRef idx="0">
-            <a:schemeClr val="accent1"/>
-          </a:effectRef>
-          <a:fontRef idx="minor">
-            <a:schemeClr val="lt1"/>
-          </a:fontRef>
-        </p:style>
-        <p:txBody>
-          <a:bodyPr rtlCol="0" anchor="ctr"/>
-          <a:lstStyle/>
-          <a:p>
-            <a:pPr algn="ctr"/>
-            <a:endParaRPr lang="ru-RU" dirty="0"/>
-          </a:p>
-        </p:txBody>
-      </p:sp>
-      <p:sp>
-        <p:nvSpPr>
-          <p:cNvPr id="13" name="TextBox 12">
-            <a:extLst>
-              <a:ext uri="{FF2B5EF4-FFF2-40B4-BE49-F238E27FC236}">
-                <a16:creationId xmlns:a16="http://schemas.microsoft.com/office/drawing/2014/main" id="{2C47DE70-D674-4C3E-8E83-DA0DC77DA724}"/>
-              </a:ext>
-            </a:extLst>
-          </p:cNvPr>
-          <p:cNvSpPr txBox="1"/>
-          <p:nvPr/>
-        </p:nvSpPr>
-        <p:spPr>
-          <a:xfrm>
-            <a:off x="528048" y="3597311"/>
-            <a:ext cx="6172575" cy="1785104"/>
-          </a:xfrm>
-          <a:prstGeom prst="rect">
-            <a:avLst/>
-          </a:prstGeom>
-          <a:noFill/>
-        </p:spPr>
-        <p:txBody>
-          <a:bodyPr wrap="square" rtlCol="0">
-            <a:spAutoFit/>
-          </a:bodyPr>
-          <a:lstStyle/>
-          <a:p>
-            <a:r>
-              <a:rPr lang="ru-RU" sz="2000" b="1" dirty="0">
-                <a:solidFill>
-                  <a:schemeClr val="bg1"/>
-                </a:solidFill>
-                <a:latin typeface="Arial" panose="020B0604020202020204" pitchFamily="34" charset="0"/>
-                <a:cs typeface="Arial" panose="020B0604020202020204" pitchFamily="34" charset="0"/>
-              </a:rPr>
-              <a:t>Решение полностью работает</a:t>
-            </a:r>
-          </a:p>
-          <a:p>
-            <a:r>
-              <a:rPr lang="ru-RU" sz="2000" b="1" dirty="0">
-                <a:solidFill>
-                  <a:schemeClr val="bg1"/>
-                </a:solidFill>
-                <a:latin typeface="Arial" panose="020B0604020202020204" pitchFamily="34" charset="0"/>
-                <a:cs typeface="Arial" panose="020B0604020202020204" pitchFamily="34" charset="0"/>
-              </a:rPr>
-              <a:t>и размещено на</a:t>
-            </a:r>
-            <a:r>
-              <a:rPr lang="en-US" sz="2000" b="1" dirty="0">
-                <a:solidFill>
-                  <a:schemeClr val="bg1"/>
-                </a:solidFill>
-                <a:latin typeface="Arial" panose="020B0604020202020204" pitchFamily="34" charset="0"/>
-                <a:cs typeface="Arial" panose="020B0604020202020204" pitchFamily="34" charset="0"/>
-              </a:rPr>
-              <a:t>:</a:t>
-            </a:r>
-          </a:p>
-          <a:p>
-            <a:endParaRPr lang="en-US" sz="3500" b="1" dirty="0">
-              <a:solidFill>
-                <a:schemeClr val="bg1"/>
-              </a:solidFill>
-              <a:latin typeface="Arial" panose="020B0604020202020204" pitchFamily="34" charset="0"/>
-              <a:cs typeface="Arial" panose="020B0604020202020204" pitchFamily="34" charset="0"/>
-            </a:endParaRPr>
-          </a:p>
-          <a:p>
-            <a:r>
-              <a:rPr lang="en-US" sz="3500" b="1" dirty="0">
-                <a:solidFill>
-                  <a:schemeClr val="bg1"/>
-                </a:solidFill>
-                <a:latin typeface="Arial" panose="020B0604020202020204" pitchFamily="34" charset="0"/>
-                <a:cs typeface="Arial" panose="020B0604020202020204" pitchFamily="34" charset="0"/>
-              </a:rPr>
-              <a:t>https://vtb.seag.pro</a:t>
-            </a:r>
-            <a:endParaRPr lang="ru-RU" sz="2000" b="1" dirty="0">
-              <a:solidFill>
-                <a:schemeClr val="bg1"/>
-              </a:solidFill>
-              <a:latin typeface="Arial" panose="020B0604020202020204" pitchFamily="34" charset="0"/>
-              <a:cs typeface="Arial" panose="020B0604020202020204" pitchFamily="34" charset="0"/>
-            </a:endParaRPr>
-          </a:p>
-        </p:txBody>
-      </p:sp>
     </p:spTree>
     <p:extLst>
       <p:ext uri="{BB962C8B-B14F-4D97-AF65-F5344CB8AC3E}">
-        <p14:creationId xmlns:p14="http://schemas.microsoft.com/office/powerpoint/2010/main" val="1562320173"/>
+        <p14:creationId xmlns:p14="http://schemas.microsoft.com/office/powerpoint/2010/main" val="1049884520"/>
       </p:ext>
     </p:extLst>
   </p:cSld>
@@ -6805,7 +6515,7 @@
         </p:blipFill>
         <p:spPr>
           <a:xfrm>
-            <a:off x="2097116" y="3024135"/>
+            <a:off x="414338" y="335526"/>
             <a:ext cx="7172325" cy="942899"/>
           </a:xfrm>
           <a:prstGeom prst="rect">
@@ -6827,8 +6537,8 @@
         </p:nvSpPr>
         <p:spPr>
           <a:xfrm>
-            <a:off x="2854567" y="3075057"/>
-            <a:ext cx="8766501" cy="707886"/>
+            <a:off x="923409" y="384754"/>
+            <a:ext cx="8766501" cy="830997"/>
           </a:xfrm>
           <a:prstGeom prst="rect">
             <a:avLst/>
@@ -6842,14 +6552,14 @@
           <a:lstStyle/>
           <a:p>
             <a:r>
-              <a:rPr lang="ru-RU" sz="4000" b="1" dirty="0">
+              <a:rPr lang="ru-RU" sz="4800" b="1" dirty="0">
                 <a:solidFill>
                   <a:schemeClr val="bg1"/>
                 </a:solidFill>
                 <a:latin typeface="Arial" panose="020B0604020202020204" pitchFamily="34" charset="0"/>
                 <a:cs typeface="Arial" panose="020B0604020202020204" pitchFamily="34" charset="0"/>
               </a:rPr>
-              <a:t>Спасибо за внимание!</a:t>
+              <a:t>Форматы отчетов</a:t>
             </a:r>
           </a:p>
         </p:txBody>
@@ -6885,10 +6595,769 @@
           </a:prstGeom>
         </p:spPr>
       </p:pic>
+      <p:sp>
+        <p:nvSpPr>
+          <p:cNvPr id="8" name="TextBox 7">
+            <a:extLst>
+              <a:ext uri="{FF2B5EF4-FFF2-40B4-BE49-F238E27FC236}">
+                <a16:creationId xmlns:a16="http://schemas.microsoft.com/office/drawing/2014/main" id="{CB97A419-BFA9-4559-A4E7-ED690CFF73C8}"/>
+              </a:ext>
+            </a:extLst>
+          </p:cNvPr>
+          <p:cNvSpPr txBox="1"/>
+          <p:nvPr/>
+        </p:nvSpPr>
+        <p:spPr>
+          <a:xfrm>
+            <a:off x="353137" y="1278425"/>
+            <a:ext cx="11615950" cy="2708434"/>
+          </a:xfrm>
+          <a:prstGeom prst="rect">
+            <a:avLst/>
+          </a:prstGeom>
+          <a:noFill/>
+        </p:spPr>
+        <p:txBody>
+          <a:bodyPr wrap="square">
+            <a:spAutoFit/>
+          </a:bodyPr>
+          <a:lstStyle/>
+          <a:p>
+            <a:r>
+              <a:rPr lang="en-US" sz="3000" dirty="0">
+                <a:solidFill>
+                  <a:schemeClr val="bg1"/>
+                </a:solidFill>
+                <a:hlinkClick r:id="rId4"/>
+              </a:rPr>
+              <a:t>https://vtb.seag.pro/</a:t>
+            </a:r>
+            <a:endParaRPr lang="ru-RU" sz="3000" dirty="0">
+              <a:solidFill>
+                <a:schemeClr val="bg1"/>
+              </a:solidFill>
+            </a:endParaRPr>
+          </a:p>
+          <a:p>
+            <a:r>
+              <a:rPr lang="ru-RU" sz="3500" dirty="0" err="1">
+                <a:solidFill>
+                  <a:schemeClr val="bg1"/>
+                </a:solidFill>
+              </a:rPr>
+              <a:t>Поддеживаются</a:t>
+            </a:r>
+            <a:r>
+              <a:rPr lang="ru-RU" sz="3500" dirty="0">
+                <a:solidFill>
+                  <a:schemeClr val="bg1"/>
+                </a:solidFill>
+              </a:rPr>
+              <a:t> форматы </a:t>
+            </a:r>
+            <a:r>
+              <a:rPr lang="en-US" sz="3500" dirty="0" err="1">
+                <a:solidFill>
+                  <a:schemeClr val="bg1"/>
+                </a:solidFill>
+              </a:rPr>
+              <a:t>html,json,pdf</a:t>
+            </a:r>
+            <a:r>
+              <a:rPr lang="en-US" sz="3500" dirty="0">
+                <a:solidFill>
+                  <a:schemeClr val="bg1"/>
+                </a:solidFill>
+              </a:rPr>
+              <a:t>.</a:t>
+            </a:r>
+            <a:endParaRPr lang="ru-RU" sz="3500" dirty="0">
+              <a:solidFill>
+                <a:schemeClr val="bg1"/>
+              </a:solidFill>
+            </a:endParaRPr>
+          </a:p>
+          <a:p>
+            <a:endParaRPr lang="ru-RU" sz="3500" dirty="0">
+              <a:solidFill>
+                <a:schemeClr val="bg1"/>
+              </a:solidFill>
+            </a:endParaRPr>
+          </a:p>
+          <a:p>
+            <a:endParaRPr lang="ru-RU" sz="3500" dirty="0">
+              <a:solidFill>
+                <a:schemeClr val="bg1"/>
+              </a:solidFill>
+            </a:endParaRPr>
+          </a:p>
+          <a:p>
+            <a:r>
+              <a:rPr lang="ru-RU" sz="3500" dirty="0">
+                <a:solidFill>
+                  <a:schemeClr val="bg1"/>
+                </a:solidFill>
+              </a:rPr>
+              <a:t>Пример с </a:t>
+            </a:r>
+            <a:r>
+              <a:rPr lang="en-US" sz="3500" dirty="0">
+                <a:solidFill>
+                  <a:schemeClr val="bg1"/>
+                </a:solidFill>
+              </a:rPr>
+              <a:t>PDF:</a:t>
+            </a:r>
+          </a:p>
+        </p:txBody>
+      </p:sp>
+      <p:pic>
+        <p:nvPicPr>
+          <p:cNvPr id="4" name="Picture 3">
+            <a:extLst>
+              <a:ext uri="{FF2B5EF4-FFF2-40B4-BE49-F238E27FC236}">
+                <a16:creationId xmlns:a16="http://schemas.microsoft.com/office/drawing/2014/main" id="{35972AF4-F4D4-4CEB-B1B7-81649528FEF7}"/>
+              </a:ext>
+            </a:extLst>
+          </p:cNvPr>
+          <p:cNvPicPr>
+            <a:picLocks noChangeAspect="1"/>
+          </p:cNvPicPr>
+          <p:nvPr/>
+        </p:nvPicPr>
+        <p:blipFill>
+          <a:blip r:embed="rId5"/>
+          <a:stretch>
+            <a:fillRect/>
+          </a:stretch>
+        </p:blipFill>
+        <p:spPr>
+          <a:xfrm>
+            <a:off x="4053728" y="2590759"/>
+            <a:ext cx="4837015" cy="4267241"/>
+          </a:xfrm>
+          <a:prstGeom prst="rect">
+            <a:avLst/>
+          </a:prstGeom>
+        </p:spPr>
+      </p:pic>
     </p:spTree>
     <p:extLst>
       <p:ext uri="{BB962C8B-B14F-4D97-AF65-F5344CB8AC3E}">
-        <p14:creationId xmlns:p14="http://schemas.microsoft.com/office/powerpoint/2010/main" val="1099022153"/>
+        <p14:creationId xmlns:p14="http://schemas.microsoft.com/office/powerpoint/2010/main" val="3491224519"/>
+      </p:ext>
+    </p:extLst>
+  </p:cSld>
+  <p:clrMapOvr>
+    <a:masterClrMapping/>
+  </p:clrMapOvr>
+</p:sld>
+</file>
+
+<file path=ppt/slides/slide19.xml><?xml version="1.0" encoding="utf-8"?>
+<p:sld xmlns:a="http://schemas.openxmlformats.org/drawingml/2006/main" xmlns:r="http://schemas.openxmlformats.org/officeDocument/2006/relationships" xmlns:p="http://schemas.openxmlformats.org/presentationml/2006/main">
+  <p:cSld>
+    <p:spTree>
+      <p:nvGrpSpPr>
+        <p:cNvPr id="1" name="">
+          <a:extLst>
+            <a:ext uri="{FF2B5EF4-FFF2-40B4-BE49-F238E27FC236}">
+              <a16:creationId xmlns:a16="http://schemas.microsoft.com/office/drawing/2014/main" id="{B6B9C626-63EA-9FE6-C2E5-0D15C0FF4B66}"/>
+            </a:ext>
+          </a:extLst>
+        </p:cNvPr>
+        <p:cNvGrpSpPr/>
+        <p:nvPr/>
+      </p:nvGrpSpPr>
+      <p:grpSpPr>
+        <a:xfrm>
+          <a:off x="0" y="0"/>
+          <a:ext cx="0" cy="0"/>
+          <a:chOff x="0" y="0"/>
+          <a:chExt cx="0" cy="0"/>
+        </a:xfrm>
+      </p:grpSpPr>
+      <p:pic>
+        <p:nvPicPr>
+          <p:cNvPr id="5" name="Рисунок 4" descr="Изображение выглядит как снимок экрана, синий, Цвет электрик, Прямоугольник&#10;&#10;Содержимое, созданное искусственным интеллектом, может быть неверным.">
+            <a:extLst>
+              <a:ext uri="{FF2B5EF4-FFF2-40B4-BE49-F238E27FC236}">
+                <a16:creationId xmlns:a16="http://schemas.microsoft.com/office/drawing/2014/main" id="{96BBD7B2-DAA0-C602-1DDB-D19DF0C13EC8}"/>
+              </a:ext>
+            </a:extLst>
+          </p:cNvPr>
+          <p:cNvPicPr>
+            <a:picLocks noChangeAspect="1"/>
+          </p:cNvPicPr>
+          <p:nvPr/>
+        </p:nvPicPr>
+        <p:blipFill>
+          <a:blip r:embed="rId2"/>
+          <a:stretch>
+            <a:fillRect/>
+          </a:stretch>
+        </p:blipFill>
+        <p:spPr>
+          <a:xfrm>
+            <a:off x="414338" y="335526"/>
+            <a:ext cx="7172325" cy="942899"/>
+          </a:xfrm>
+          <a:prstGeom prst="rect">
+            <a:avLst/>
+          </a:prstGeom>
+        </p:spPr>
+      </p:pic>
+      <p:sp>
+        <p:nvSpPr>
+          <p:cNvPr id="6" name="TextBox 5">
+            <a:extLst>
+              <a:ext uri="{FF2B5EF4-FFF2-40B4-BE49-F238E27FC236}">
+                <a16:creationId xmlns:a16="http://schemas.microsoft.com/office/drawing/2014/main" id="{5CA09478-E726-F2C1-1294-C885963040B1}"/>
+              </a:ext>
+            </a:extLst>
+          </p:cNvPr>
+          <p:cNvSpPr txBox="1"/>
+          <p:nvPr/>
+        </p:nvSpPr>
+        <p:spPr>
+          <a:xfrm>
+            <a:off x="923409" y="384754"/>
+            <a:ext cx="8766501" cy="830997"/>
+          </a:xfrm>
+          <a:prstGeom prst="rect">
+            <a:avLst/>
+          </a:prstGeom>
+          <a:noFill/>
+        </p:spPr>
+        <p:txBody>
+          <a:bodyPr wrap="square" rtlCol="0">
+            <a:spAutoFit/>
+          </a:bodyPr>
+          <a:lstStyle/>
+          <a:p>
+            <a:r>
+              <a:rPr lang="ru-RU" sz="4800" b="1" dirty="0">
+                <a:solidFill>
+                  <a:schemeClr val="bg1"/>
+                </a:solidFill>
+                <a:latin typeface="Arial" panose="020B0604020202020204" pitchFamily="34" charset="0"/>
+                <a:cs typeface="Arial" panose="020B0604020202020204" pitchFamily="34" charset="0"/>
+              </a:rPr>
+              <a:t>Заключение</a:t>
+            </a:r>
+          </a:p>
+        </p:txBody>
+      </p:sp>
+      <p:pic>
+        <p:nvPicPr>
+          <p:cNvPr id="2" name="Рисунок 1" descr="Изображение выглядит как текст, Шрифт, снимок экрана, Графика&#10;&#10;Содержимое, созданное искусственным интеллектом, может быть неверным.">
+            <a:extLst>
+              <a:ext uri="{FF2B5EF4-FFF2-40B4-BE49-F238E27FC236}">
+                <a16:creationId xmlns:a16="http://schemas.microsoft.com/office/drawing/2014/main" id="{4760AD37-9C1F-D933-5FAB-72ADFC8F697F}"/>
+              </a:ext>
+            </a:extLst>
+          </p:cNvPr>
+          <p:cNvPicPr>
+            <a:picLocks noChangeAspect="1"/>
+          </p:cNvPicPr>
+          <p:nvPr/>
+        </p:nvPicPr>
+        <p:blipFill>
+          <a:blip r:embed="rId3"/>
+          <a:srcRect b="42849"/>
+          <a:stretch>
+            <a:fillRect/>
+          </a:stretch>
+        </p:blipFill>
+        <p:spPr>
+          <a:xfrm>
+            <a:off x="9242922" y="476426"/>
+            <a:ext cx="2268040" cy="661098"/>
+          </a:xfrm>
+          <a:prstGeom prst="rect">
+            <a:avLst/>
+          </a:prstGeom>
+        </p:spPr>
+      </p:pic>
+      <p:sp>
+        <p:nvSpPr>
+          <p:cNvPr id="8" name="TextBox 7">
+            <a:extLst>
+              <a:ext uri="{FF2B5EF4-FFF2-40B4-BE49-F238E27FC236}">
+                <a16:creationId xmlns:a16="http://schemas.microsoft.com/office/drawing/2014/main" id="{CB97A419-BFA9-4559-A4E7-ED690CFF73C8}"/>
+              </a:ext>
+            </a:extLst>
+          </p:cNvPr>
+          <p:cNvSpPr txBox="1"/>
+          <p:nvPr/>
+        </p:nvSpPr>
+        <p:spPr>
+          <a:xfrm>
+            <a:off x="353137" y="1278425"/>
+            <a:ext cx="8766501" cy="5786199"/>
+          </a:xfrm>
+          <a:prstGeom prst="rect">
+            <a:avLst/>
+          </a:prstGeom>
+          <a:noFill/>
+        </p:spPr>
+        <p:txBody>
+          <a:bodyPr wrap="square">
+            <a:spAutoFit/>
+          </a:bodyPr>
+          <a:lstStyle/>
+          <a:p>
+            <a:r>
+              <a:rPr lang="en-US" sz="3000" dirty="0">
+                <a:solidFill>
+                  <a:schemeClr val="bg1"/>
+                </a:solidFill>
+              </a:rPr>
+              <a:t>https://vtb.seag.pro</a:t>
+            </a:r>
+            <a:endParaRPr lang="ru-RU" sz="3000" dirty="0">
+              <a:solidFill>
+                <a:schemeClr val="bg1"/>
+              </a:solidFill>
+            </a:endParaRPr>
+          </a:p>
+          <a:p>
+            <a:pPr marL="457200" indent="-457200">
+              <a:buFont typeface="Arial" panose="020B0604020202020204" pitchFamily="34" charset="0"/>
+              <a:buChar char="•"/>
+            </a:pPr>
+            <a:endParaRPr lang="en-US" sz="3000" dirty="0">
+              <a:solidFill>
+                <a:schemeClr val="bg1"/>
+              </a:solidFill>
+            </a:endParaRPr>
+          </a:p>
+          <a:p>
+            <a:pPr marL="457200" indent="-457200">
+              <a:buFont typeface="Arial" panose="020B0604020202020204" pitchFamily="34" charset="0"/>
+              <a:buChar char="•"/>
+            </a:pPr>
+            <a:r>
+              <a:rPr lang="ru-RU" sz="2500" dirty="0">
+                <a:solidFill>
+                  <a:schemeClr val="bg1"/>
+                </a:solidFill>
+              </a:rPr>
+              <a:t>Решение универсально</a:t>
+            </a:r>
+          </a:p>
+          <a:p>
+            <a:pPr marL="457200" indent="-457200">
+              <a:buFont typeface="Arial" panose="020B0604020202020204" pitchFamily="34" charset="0"/>
+              <a:buChar char="•"/>
+            </a:pPr>
+            <a:r>
+              <a:rPr lang="ru-RU" sz="2500" dirty="0">
+                <a:solidFill>
+                  <a:schemeClr val="bg1"/>
+                </a:solidFill>
+              </a:rPr>
+              <a:t>Результаты разных способов поиска уязвимостей </a:t>
+            </a:r>
+            <a:r>
+              <a:rPr lang="ru-RU" sz="2500" dirty="0" err="1">
+                <a:solidFill>
+                  <a:schemeClr val="bg1"/>
+                </a:solidFill>
+              </a:rPr>
+              <a:t>агрегируются</a:t>
+            </a:r>
+            <a:r>
+              <a:rPr lang="ru-RU" sz="2500" dirty="0">
+                <a:solidFill>
+                  <a:schemeClr val="bg1"/>
+                </a:solidFill>
+              </a:rPr>
+              <a:t> в один отчет</a:t>
+            </a:r>
+          </a:p>
+          <a:p>
+            <a:pPr marL="457200" indent="-457200">
+              <a:buFont typeface="Arial" panose="020B0604020202020204" pitchFamily="34" charset="0"/>
+              <a:buChar char="•"/>
+            </a:pPr>
+            <a:r>
+              <a:rPr lang="ru-RU" sz="2500" dirty="0">
+                <a:solidFill>
+                  <a:schemeClr val="bg1"/>
+                </a:solidFill>
+              </a:rPr>
+              <a:t>Поддержка разных форматов отчетов – </a:t>
+            </a:r>
+            <a:r>
+              <a:rPr lang="en-US" sz="2500" dirty="0">
+                <a:solidFill>
+                  <a:schemeClr val="bg1"/>
+                </a:solidFill>
+              </a:rPr>
+              <a:t>json/html/PDF</a:t>
+            </a:r>
+          </a:p>
+          <a:p>
+            <a:pPr marL="457200" indent="-457200">
+              <a:buFont typeface="Arial" panose="020B0604020202020204" pitchFamily="34" charset="0"/>
+              <a:buChar char="•"/>
+            </a:pPr>
+            <a:r>
+              <a:rPr lang="ru-RU" sz="2500" dirty="0">
+                <a:solidFill>
+                  <a:schemeClr val="bg1"/>
+                </a:solidFill>
+              </a:rPr>
+              <a:t>Интеграция с </a:t>
+            </a:r>
+            <a:r>
+              <a:rPr lang="en-US" sz="2500" dirty="0">
+                <a:solidFill>
+                  <a:schemeClr val="bg1"/>
+                </a:solidFill>
+              </a:rPr>
+              <a:t>CI/CD</a:t>
+            </a:r>
+            <a:r>
+              <a:rPr lang="ru-RU" sz="2500" dirty="0">
+                <a:solidFill>
+                  <a:schemeClr val="bg1"/>
+                </a:solidFill>
+              </a:rPr>
+              <a:t> (на примере </a:t>
+            </a:r>
+            <a:r>
+              <a:rPr lang="en-US" sz="2500" dirty="0">
+                <a:solidFill>
+                  <a:schemeClr val="bg1"/>
+                </a:solidFill>
+              </a:rPr>
+              <a:t>Jenkins)</a:t>
+            </a:r>
+            <a:r>
+              <a:rPr lang="ru-RU" sz="2500" dirty="0">
+                <a:solidFill>
+                  <a:schemeClr val="bg1"/>
+                </a:solidFill>
+              </a:rPr>
+              <a:t> через </a:t>
+            </a:r>
+            <a:r>
+              <a:rPr lang="en-US" sz="2500" dirty="0" err="1">
+                <a:solidFill>
+                  <a:schemeClr val="bg1"/>
+                </a:solidFill>
+              </a:rPr>
+              <a:t>RestAPI</a:t>
+            </a:r>
+            <a:r>
+              <a:rPr lang="en-US" sz="2500" dirty="0">
+                <a:solidFill>
+                  <a:schemeClr val="bg1"/>
+                </a:solidFill>
+              </a:rPr>
+              <a:t> </a:t>
+            </a:r>
+            <a:r>
+              <a:rPr lang="ru-RU" sz="2500" dirty="0">
+                <a:solidFill>
+                  <a:schemeClr val="bg1"/>
+                </a:solidFill>
+              </a:rPr>
+              <a:t>или </a:t>
+            </a:r>
+            <a:r>
+              <a:rPr lang="en-US" sz="2500" dirty="0">
+                <a:solidFill>
+                  <a:schemeClr val="bg1"/>
+                </a:solidFill>
+              </a:rPr>
+              <a:t>CLI</a:t>
+            </a:r>
+            <a:r>
+              <a:rPr lang="ru-RU" sz="2500" dirty="0">
+                <a:solidFill>
+                  <a:schemeClr val="bg1"/>
+                </a:solidFill>
+              </a:rPr>
+              <a:t> (пока скрипт</a:t>
+            </a:r>
+            <a:r>
+              <a:rPr lang="en-US" sz="2500" dirty="0">
+                <a:solidFill>
+                  <a:schemeClr val="bg1"/>
+                </a:solidFill>
+              </a:rPr>
+              <a:t>-&gt;ApiSecurityCli.java</a:t>
+            </a:r>
+            <a:r>
+              <a:rPr lang="ru-RU" sz="2500" dirty="0">
+                <a:solidFill>
+                  <a:schemeClr val="bg1"/>
+                </a:solidFill>
+              </a:rPr>
+              <a:t>, в перспективе — исполняемый файл, разработанный на </a:t>
+            </a:r>
+            <a:r>
+              <a:rPr lang="en-US" sz="2500" dirty="0" err="1">
+                <a:solidFill>
+                  <a:schemeClr val="bg1"/>
+                </a:solidFill>
+              </a:rPr>
+              <a:t>GoLang</a:t>
+            </a:r>
+            <a:r>
+              <a:rPr lang="ru-RU" sz="2500" dirty="0">
+                <a:solidFill>
+                  <a:schemeClr val="bg1"/>
+                </a:solidFill>
+              </a:rPr>
+              <a:t>) </a:t>
+            </a:r>
+            <a:endParaRPr lang="en-US" sz="2500" dirty="0">
+              <a:solidFill>
+                <a:schemeClr val="bg1"/>
+              </a:solidFill>
+            </a:endParaRPr>
+          </a:p>
+          <a:p>
+            <a:pPr marL="457200" indent="-457200">
+              <a:buFont typeface="Arial" panose="020B0604020202020204" pitchFamily="34" charset="0"/>
+              <a:buChar char="•"/>
+            </a:pPr>
+            <a:r>
+              <a:rPr lang="ru-RU" sz="2500" dirty="0">
+                <a:solidFill>
+                  <a:schemeClr val="bg1"/>
+                </a:solidFill>
+              </a:rPr>
+              <a:t>Результат анализа в </a:t>
+            </a:r>
+            <a:r>
+              <a:rPr lang="en-US" sz="2500" dirty="0">
+                <a:solidFill>
+                  <a:schemeClr val="bg1"/>
+                </a:solidFill>
+              </a:rPr>
+              <a:t>CI/CD — </a:t>
+            </a:r>
+            <a:r>
+              <a:rPr lang="ru-RU" sz="2500" dirty="0">
+                <a:solidFill>
+                  <a:schemeClr val="bg1"/>
+                </a:solidFill>
+              </a:rPr>
+              <a:t>ссылки на опубликованные отчеты</a:t>
+            </a:r>
+          </a:p>
+          <a:p>
+            <a:pPr marL="457200" indent="-457200">
+              <a:buFont typeface="Arial" panose="020B0604020202020204" pitchFamily="34" charset="0"/>
+              <a:buChar char="•"/>
+            </a:pPr>
+            <a:r>
+              <a:rPr lang="ru-RU" sz="2500" b="1" dirty="0">
+                <a:solidFill>
+                  <a:schemeClr val="bg1"/>
+                </a:solidFill>
+                <a:effectLst>
+                  <a:outerShdw blurRad="38100" dist="38100" dir="2700000" algn="tl">
+                    <a:srgbClr val="000000">
+                      <a:alpha val="43137"/>
+                    </a:srgbClr>
+                  </a:outerShdw>
+                </a:effectLst>
+              </a:rPr>
+              <a:t>Новый этап — возможность расширения проверок пользовательскими</a:t>
+            </a:r>
+          </a:p>
+          <a:p>
+            <a:pPr marL="457200" indent="-457200">
+              <a:buFont typeface="Arial" panose="020B0604020202020204" pitchFamily="34" charset="0"/>
+              <a:buChar char="•"/>
+            </a:pPr>
+            <a:endParaRPr lang="en-US" sz="3500" dirty="0">
+              <a:solidFill>
+                <a:schemeClr val="bg1"/>
+              </a:solidFill>
+            </a:endParaRPr>
+          </a:p>
+        </p:txBody>
+      </p:sp>
+      <p:pic>
+        <p:nvPicPr>
+          <p:cNvPr id="7" name="Рисунок 10" descr="Изображение выглядит как снимок экрана, синий, Цвет электрик, Прямоугольник&#10;&#10;Содержимое, созданное искусственным интеллектом, может быть неверным.">
+            <a:extLst>
+              <a:ext uri="{FF2B5EF4-FFF2-40B4-BE49-F238E27FC236}">
+                <a16:creationId xmlns:a16="http://schemas.microsoft.com/office/drawing/2014/main" id="{03FF6ABE-DC87-46E4-93F6-80D90CFB154C}"/>
+              </a:ext>
+            </a:extLst>
+          </p:cNvPr>
+          <p:cNvPicPr>
+            <a:picLocks noChangeAspect="1"/>
+          </p:cNvPicPr>
+          <p:nvPr/>
+        </p:nvPicPr>
+        <p:blipFill>
+          <a:blip r:embed="rId4"/>
+          <a:stretch>
+            <a:fillRect/>
+          </a:stretch>
+        </p:blipFill>
+        <p:spPr>
+          <a:xfrm>
+            <a:off x="9102847" y="3836372"/>
+            <a:ext cx="2022415" cy="439526"/>
+          </a:xfrm>
+          <a:prstGeom prst="rect">
+            <a:avLst/>
+          </a:prstGeom>
+        </p:spPr>
+      </p:pic>
+      <p:sp>
+        <p:nvSpPr>
+          <p:cNvPr id="9" name="TextBox 8">
+            <a:extLst>
+              <a:ext uri="{FF2B5EF4-FFF2-40B4-BE49-F238E27FC236}">
+                <a16:creationId xmlns:a16="http://schemas.microsoft.com/office/drawing/2014/main" id="{B4B4DFB9-074E-455C-8D92-FBCFA735525C}"/>
+              </a:ext>
+            </a:extLst>
+          </p:cNvPr>
+          <p:cNvSpPr txBox="1"/>
+          <p:nvPr/>
+        </p:nvSpPr>
+        <p:spPr>
+          <a:xfrm>
+            <a:off x="9216972" y="3862659"/>
+            <a:ext cx="1908290" cy="369332"/>
+          </a:xfrm>
+          <a:prstGeom prst="rect">
+            <a:avLst/>
+          </a:prstGeom>
+          <a:noFill/>
+        </p:spPr>
+        <p:txBody>
+          <a:bodyPr wrap="square" rtlCol="0">
+            <a:spAutoFit/>
+          </a:bodyPr>
+          <a:lstStyle/>
+          <a:p>
+            <a:r>
+              <a:rPr lang="ru-RU" b="1" dirty="0">
+                <a:solidFill>
+                  <a:schemeClr val="bg1"/>
+                </a:solidFill>
+                <a:latin typeface="Arial" panose="020B0604020202020204" pitchFamily="34" charset="0"/>
+                <a:cs typeface="Arial" panose="020B0604020202020204" pitchFamily="34" charset="0"/>
+              </a:rPr>
+              <a:t>Алексей Чайка</a:t>
+            </a:r>
+          </a:p>
+        </p:txBody>
+      </p:sp>
+      <p:sp>
+        <p:nvSpPr>
+          <p:cNvPr id="10" name="TextBox 9">
+            <a:extLst>
+              <a:ext uri="{FF2B5EF4-FFF2-40B4-BE49-F238E27FC236}">
+                <a16:creationId xmlns:a16="http://schemas.microsoft.com/office/drawing/2014/main" id="{9E3EB680-9E59-4E44-A4BA-CECFD8467EF1}"/>
+              </a:ext>
+            </a:extLst>
+          </p:cNvPr>
+          <p:cNvSpPr txBox="1"/>
+          <p:nvPr/>
+        </p:nvSpPr>
+        <p:spPr>
+          <a:xfrm>
+            <a:off x="8908868" y="4376013"/>
+            <a:ext cx="3236648" cy="369332"/>
+          </a:xfrm>
+          <a:prstGeom prst="rect">
+            <a:avLst/>
+          </a:prstGeom>
+          <a:noFill/>
+        </p:spPr>
+        <p:txBody>
+          <a:bodyPr wrap="square" rtlCol="0">
+            <a:spAutoFit/>
+          </a:bodyPr>
+          <a:lstStyle/>
+          <a:p>
+            <a:r>
+              <a:rPr lang="ru-RU" dirty="0">
+                <a:solidFill>
+                  <a:schemeClr val="bg1"/>
+                </a:solidFill>
+                <a:latin typeface="Arial" panose="020B0604020202020204" pitchFamily="34" charset="0"/>
+                <a:cs typeface="Arial" panose="020B0604020202020204" pitchFamily="34" charset="0"/>
+              </a:rPr>
+              <a:t>Капитан-разработчик</a:t>
+            </a:r>
+          </a:p>
+        </p:txBody>
+      </p:sp>
+      <p:sp>
+        <p:nvSpPr>
+          <p:cNvPr id="11" name="Овал 21">
+            <a:extLst>
+              <a:ext uri="{FF2B5EF4-FFF2-40B4-BE49-F238E27FC236}">
+                <a16:creationId xmlns:a16="http://schemas.microsoft.com/office/drawing/2014/main" id="{5188AA8E-CEC7-429E-A1E7-A01692367AAC}"/>
+              </a:ext>
+            </a:extLst>
+          </p:cNvPr>
+          <p:cNvSpPr/>
+          <p:nvPr/>
+        </p:nvSpPr>
+        <p:spPr>
+          <a:xfrm>
+            <a:off x="9159909" y="1687788"/>
+            <a:ext cx="1908290" cy="1909523"/>
+          </a:xfrm>
+          <a:prstGeom prst="ellipse">
+            <a:avLst/>
+          </a:prstGeom>
+          <a:blipFill>
+            <a:blip r:embed="rId5"/>
+            <a:stretch>
+              <a:fillRect/>
+            </a:stretch>
+          </a:blipFill>
+          <a:ln w="57150">
+            <a:solidFill>
+              <a:srgbClr val="05AEFF"/>
+            </a:solidFill>
+          </a:ln>
+        </p:spPr>
+        <p:style>
+          <a:lnRef idx="2">
+            <a:schemeClr val="accent1">
+              <a:shade val="15000"/>
+            </a:schemeClr>
+          </a:lnRef>
+          <a:fillRef idx="1">
+            <a:schemeClr val="accent1"/>
+          </a:fillRef>
+          <a:effectRef idx="0">
+            <a:schemeClr val="accent1"/>
+          </a:effectRef>
+          <a:fontRef idx="minor">
+            <a:schemeClr val="lt1"/>
+          </a:fontRef>
+        </p:style>
+        <p:txBody>
+          <a:bodyPr rtlCol="0" anchor="ctr"/>
+          <a:lstStyle/>
+          <a:p>
+            <a:pPr algn="ctr"/>
+            <a:endParaRPr lang="ru-RU" dirty="0"/>
+          </a:p>
+        </p:txBody>
+      </p:sp>
+    </p:spTree>
+    <p:extLst>
+      <p:ext uri="{BB962C8B-B14F-4D97-AF65-F5344CB8AC3E}">
+        <p14:creationId xmlns:p14="http://schemas.microsoft.com/office/powerpoint/2010/main" val="2438306394"/>
       </p:ext>
     </p:extLst>
   </p:cSld>
@@ -7764,6 +8233,144 @@
 </p:sld>
 </file>
 
+<file path=ppt/slides/slide20.xml><?xml version="1.0" encoding="utf-8"?>
+<p:sld xmlns:a="http://schemas.openxmlformats.org/drawingml/2006/main" xmlns:r="http://schemas.openxmlformats.org/officeDocument/2006/relationships" xmlns:p="http://schemas.openxmlformats.org/presentationml/2006/main">
+  <p:cSld>
+    <p:spTree>
+      <p:nvGrpSpPr>
+        <p:cNvPr id="1" name="">
+          <a:extLst>
+            <a:ext uri="{FF2B5EF4-FFF2-40B4-BE49-F238E27FC236}">
+              <a16:creationId xmlns:a16="http://schemas.microsoft.com/office/drawing/2014/main" id="{B6B9C626-63EA-9FE6-C2E5-0D15C0FF4B66}"/>
+            </a:ext>
+          </a:extLst>
+        </p:cNvPr>
+        <p:cNvGrpSpPr/>
+        <p:nvPr/>
+      </p:nvGrpSpPr>
+      <p:grpSpPr>
+        <a:xfrm>
+          <a:off x="0" y="0"/>
+          <a:ext cx="0" cy="0"/>
+          <a:chOff x="0" y="0"/>
+          <a:chExt cx="0" cy="0"/>
+        </a:xfrm>
+      </p:grpSpPr>
+      <p:pic>
+        <p:nvPicPr>
+          <p:cNvPr id="5" name="Рисунок 4" descr="Изображение выглядит как снимок экрана, синий, Цвет электрик, Прямоугольник&#10;&#10;Содержимое, созданное искусственным интеллектом, может быть неверным.">
+            <a:extLst>
+              <a:ext uri="{FF2B5EF4-FFF2-40B4-BE49-F238E27FC236}">
+                <a16:creationId xmlns:a16="http://schemas.microsoft.com/office/drawing/2014/main" id="{96BBD7B2-DAA0-C602-1DDB-D19DF0C13EC8}"/>
+              </a:ext>
+            </a:extLst>
+          </p:cNvPr>
+          <p:cNvPicPr>
+            <a:picLocks noChangeAspect="1"/>
+          </p:cNvPicPr>
+          <p:nvPr/>
+        </p:nvPicPr>
+        <p:blipFill>
+          <a:blip r:embed="rId2"/>
+          <a:stretch>
+            <a:fillRect/>
+          </a:stretch>
+        </p:blipFill>
+        <p:spPr>
+          <a:xfrm>
+            <a:off x="2097116" y="3024135"/>
+            <a:ext cx="7172325" cy="942899"/>
+          </a:xfrm>
+          <a:prstGeom prst="rect">
+            <a:avLst/>
+          </a:prstGeom>
+        </p:spPr>
+      </p:pic>
+      <p:sp>
+        <p:nvSpPr>
+          <p:cNvPr id="6" name="TextBox 5">
+            <a:extLst>
+              <a:ext uri="{FF2B5EF4-FFF2-40B4-BE49-F238E27FC236}">
+                <a16:creationId xmlns:a16="http://schemas.microsoft.com/office/drawing/2014/main" id="{5CA09478-E726-F2C1-1294-C885963040B1}"/>
+              </a:ext>
+            </a:extLst>
+          </p:cNvPr>
+          <p:cNvSpPr txBox="1"/>
+          <p:nvPr/>
+        </p:nvSpPr>
+        <p:spPr>
+          <a:xfrm>
+            <a:off x="2854567" y="3075057"/>
+            <a:ext cx="8766501" cy="707886"/>
+          </a:xfrm>
+          <a:prstGeom prst="rect">
+            <a:avLst/>
+          </a:prstGeom>
+          <a:noFill/>
+        </p:spPr>
+        <p:txBody>
+          <a:bodyPr wrap="square" rtlCol="0">
+            <a:spAutoFit/>
+          </a:bodyPr>
+          <a:lstStyle/>
+          <a:p>
+            <a:r>
+              <a:rPr lang="ru-RU" sz="4000" b="1" dirty="0">
+                <a:solidFill>
+                  <a:schemeClr val="bg1"/>
+                </a:solidFill>
+                <a:latin typeface="Arial" panose="020B0604020202020204" pitchFamily="34" charset="0"/>
+                <a:cs typeface="Arial" panose="020B0604020202020204" pitchFamily="34" charset="0"/>
+              </a:rPr>
+              <a:t>Спасибо за внимание!</a:t>
+            </a:r>
+          </a:p>
+        </p:txBody>
+      </p:sp>
+      <p:pic>
+        <p:nvPicPr>
+          <p:cNvPr id="2" name="Рисунок 1" descr="Изображение выглядит как текст, Шрифт, снимок экрана, Графика&#10;&#10;Содержимое, созданное искусственным интеллектом, может быть неверным.">
+            <a:extLst>
+              <a:ext uri="{FF2B5EF4-FFF2-40B4-BE49-F238E27FC236}">
+                <a16:creationId xmlns:a16="http://schemas.microsoft.com/office/drawing/2014/main" id="{4760AD37-9C1F-D933-5FAB-72ADFC8F697F}"/>
+              </a:ext>
+            </a:extLst>
+          </p:cNvPr>
+          <p:cNvPicPr>
+            <a:picLocks noChangeAspect="1"/>
+          </p:cNvPicPr>
+          <p:nvPr/>
+        </p:nvPicPr>
+        <p:blipFill>
+          <a:blip r:embed="rId3"/>
+          <a:srcRect b="42849"/>
+          <a:stretch>
+            <a:fillRect/>
+          </a:stretch>
+        </p:blipFill>
+        <p:spPr>
+          <a:xfrm>
+            <a:off x="9242922" y="476426"/>
+            <a:ext cx="2268040" cy="661098"/>
+          </a:xfrm>
+          <a:prstGeom prst="rect">
+            <a:avLst/>
+          </a:prstGeom>
+        </p:spPr>
+      </p:pic>
+    </p:spTree>
+    <p:extLst>
+      <p:ext uri="{BB962C8B-B14F-4D97-AF65-F5344CB8AC3E}">
+        <p14:creationId xmlns:p14="http://schemas.microsoft.com/office/powerpoint/2010/main" val="1099022153"/>
+      </p:ext>
+    </p:extLst>
+  </p:cSld>
+  <p:clrMapOvr>
+    <a:masterClrMapping/>
+  </p:clrMapOvr>
+</p:sld>
+</file>
+
 <file path=ppt/slides/slide3.xml><?xml version="1.0" encoding="utf-8"?>
 <p:sld xmlns:a="http://schemas.openxmlformats.org/drawingml/2006/main" xmlns:r="http://schemas.openxmlformats.org/officeDocument/2006/relationships" xmlns:p="http://schemas.openxmlformats.org/presentationml/2006/main">
   <p:cSld>
@@ -8063,7 +8670,7 @@
                 <a:latin typeface="Arial" panose="020B0604020202020204" pitchFamily="34" charset="0"/>
                 <a:cs typeface="Arial" panose="020B0604020202020204" pitchFamily="34" charset="0"/>
               </a:rPr>
-              <a:t>Расширенный набор всех проверок</a:t>
+              <a:t>Расширенный набор всех проверок за раз</a:t>
             </a:r>
             <a:endParaRPr lang="en-US" sz="2500" b="1" dirty="0">
               <a:solidFill>
@@ -8396,10 +9003,10 @@
       </p:sp>
       <p:pic>
         <p:nvPicPr>
-          <p:cNvPr id="10" name="Picture 9">
-            <a:extLst>
-              <a:ext uri="{FF2B5EF4-FFF2-40B4-BE49-F238E27FC236}">
-                <a16:creationId xmlns:a16="http://schemas.microsoft.com/office/drawing/2014/main" id="{150EEEA7-3399-4A28-A7BF-BCD8B8A157C7}"/>
+          <p:cNvPr id="4" name="Picture 3">
+            <a:extLst>
+              <a:ext uri="{FF2B5EF4-FFF2-40B4-BE49-F238E27FC236}">
+                <a16:creationId xmlns:a16="http://schemas.microsoft.com/office/drawing/2014/main" id="{4BDE0EAD-0FFE-413D-8704-6A3656FEC8D9}"/>
               </a:ext>
             </a:extLst>
           </p:cNvPr>
@@ -8416,18 +9023,140 @@
         </p:blipFill>
         <p:spPr>
           <a:xfrm>
-            <a:off x="0" y="2614684"/>
-            <a:ext cx="12192000" cy="3048000"/>
+            <a:off x="0" y="2230720"/>
+            <a:ext cx="12192000" cy="2710070"/>
           </a:xfrm>
           <a:prstGeom prst="rect">
             <a:avLst/>
           </a:prstGeom>
         </p:spPr>
       </p:pic>
+      <p:sp>
+        <p:nvSpPr>
+          <p:cNvPr id="7" name="Rectangle: Rounded Corners 6">
+            <a:extLst>
+              <a:ext uri="{FF2B5EF4-FFF2-40B4-BE49-F238E27FC236}">
+                <a16:creationId xmlns:a16="http://schemas.microsoft.com/office/drawing/2014/main" id="{E9BFFD56-D3A8-426D-8CBF-2606D201E858}"/>
+              </a:ext>
+            </a:extLst>
+          </p:cNvPr>
+          <p:cNvSpPr/>
+          <p:nvPr/>
+        </p:nvSpPr>
+        <p:spPr>
+          <a:xfrm>
+            <a:off x="1340722" y="5218611"/>
+            <a:ext cx="5319556" cy="1303863"/>
+          </a:xfrm>
+          <a:prstGeom prst="roundRect">
+            <a:avLst/>
+          </a:prstGeom>
+        </p:spPr>
+        <p:style>
+          <a:lnRef idx="2">
+            <a:schemeClr val="accent1">
+              <a:shade val="50000"/>
+            </a:schemeClr>
+          </a:lnRef>
+          <a:fillRef idx="1">
+            <a:schemeClr val="accent1"/>
+          </a:fillRef>
+          <a:effectRef idx="0">
+            <a:schemeClr val="accent1"/>
+          </a:effectRef>
+          <a:fontRef idx="minor">
+            <a:schemeClr val="lt1"/>
+          </a:fontRef>
+        </p:style>
+        <p:txBody>
+          <a:bodyPr rtlCol="0" anchor="ctr"/>
+          <a:lstStyle/>
+          <a:p>
+            <a:pPr algn="ctr"/>
+            <a:r>
+              <a:rPr lang="ru-RU" sz="1800" b="1" dirty="0">
+                <a:solidFill>
+                  <a:schemeClr val="bg1"/>
+                </a:solidFill>
+              </a:rPr>
+              <a:t>Новый этап (по замечаниям экспертов)</a:t>
+            </a:r>
+            <a:r>
+              <a:rPr lang="en-US" sz="1800" b="1" dirty="0">
+                <a:solidFill>
+                  <a:schemeClr val="bg1"/>
+                </a:solidFill>
+              </a:rPr>
+              <a:t>:</a:t>
+            </a:r>
+            <a:br>
+              <a:rPr lang="en-US" sz="1800" dirty="0">
+                <a:solidFill>
+                  <a:schemeClr val="bg1"/>
+                </a:solidFill>
+              </a:rPr>
+            </a:br>
+            <a:r>
+              <a:rPr lang="ru-RU" sz="1800" dirty="0">
+                <a:solidFill>
+                  <a:schemeClr val="bg1"/>
+                </a:solidFill>
+              </a:rPr>
+              <a:t>Возможность расширения за счет пользовательских проверок</a:t>
+            </a:r>
+            <a:endParaRPr lang="en-US" sz="1800" dirty="0">
+              <a:solidFill>
+                <a:schemeClr val="bg1"/>
+              </a:solidFill>
+            </a:endParaRPr>
+          </a:p>
+        </p:txBody>
+      </p:sp>
+      <p:cxnSp>
+        <p:nvCxnSpPr>
+          <p:cNvPr id="11" name="Straight Arrow Connector 10">
+            <a:extLst>
+              <a:ext uri="{FF2B5EF4-FFF2-40B4-BE49-F238E27FC236}">
+                <a16:creationId xmlns:a16="http://schemas.microsoft.com/office/drawing/2014/main" id="{869D0C09-D300-4B3F-833C-0F353234580D}"/>
+              </a:ext>
+            </a:extLst>
+          </p:cNvPr>
+          <p:cNvCxnSpPr>
+            <a:stCxn id="7" idx="3"/>
+          </p:cNvCxnSpPr>
+          <p:nvPr/>
+        </p:nvCxnSpPr>
+        <p:spPr>
+          <a:xfrm flipV="1">
+            <a:off x="6660278" y="4852851"/>
+            <a:ext cx="1693419" cy="1017692"/>
+          </a:xfrm>
+          <a:prstGeom prst="straightConnector1">
+            <a:avLst/>
+          </a:prstGeom>
+          <a:ln>
+            <a:tailEnd type="triangle"/>
+          </a:ln>
+        </p:spPr>
+        <p:style>
+          <a:lnRef idx="2">
+            <a:schemeClr val="dk1"/>
+          </a:lnRef>
+          <a:fillRef idx="0">
+            <a:schemeClr val="dk1"/>
+          </a:fillRef>
+          <a:effectRef idx="1">
+            <a:schemeClr val="dk1"/>
+          </a:effectRef>
+          <a:fontRef idx="minor">
+            <a:schemeClr val="tx1"/>
+          </a:fontRef>
+        </p:style>
+      </p:cxnSp>
     </p:spTree>
     <p:extLst>
       <p:ext uri="{BB962C8B-B14F-4D97-AF65-F5344CB8AC3E}">
-        <p14:creationId xmlns:p14="http://schemas.microsoft.com/office/powerpoint/2010/main" val="3291257413"/>
+        <p14:creationId xmlns:p14="http://schemas.microsoft.com/office/powerpoint/2010/main" val="3760636017"/>
       </p:ext>
     </p:extLst>
   </p:cSld>
@@ -8445,7 +9174,7 @@
         <p:cNvPr id="1" name="">
           <a:extLst>
             <a:ext uri="{FF2B5EF4-FFF2-40B4-BE49-F238E27FC236}">
-              <a16:creationId xmlns:a16="http://schemas.microsoft.com/office/drawing/2014/main" id="{B6B9C626-63EA-9FE6-C2E5-0D15C0FF4B66}"/>
+              <a16:creationId xmlns:a16="http://schemas.microsoft.com/office/drawing/2014/main" id="{33416F2C-CF96-061A-E99A-160E32EF15C0}"/>
             </a:ext>
           </a:extLst>
         </p:cNvPr>
@@ -8465,7 +9194,7 @@
           <p:cNvPr id="5" name="Рисунок 4" descr="Изображение выглядит как снимок экрана, синий, Цвет электрик, Прямоугольник&#10;&#10;Содержимое, созданное искусственным интеллектом, может быть неверным.">
             <a:extLst>
               <a:ext uri="{FF2B5EF4-FFF2-40B4-BE49-F238E27FC236}">
-                <a16:creationId xmlns:a16="http://schemas.microsoft.com/office/drawing/2014/main" id="{96BBD7B2-DAA0-C602-1DDB-D19DF0C13EC8}"/>
+                <a16:creationId xmlns:a16="http://schemas.microsoft.com/office/drawing/2014/main" id="{7FC79E97-B000-7924-D876-95ED6BB2FDE8}"/>
               </a:ext>
             </a:extLst>
           </p:cNvPr>
@@ -8495,7 +9224,7 @@
           <p:cNvPr id="6" name="TextBox 5">
             <a:extLst>
               <a:ext uri="{FF2B5EF4-FFF2-40B4-BE49-F238E27FC236}">
-                <a16:creationId xmlns:a16="http://schemas.microsoft.com/office/drawing/2014/main" id="{5CA09478-E726-F2C1-1294-C885963040B1}"/>
+                <a16:creationId xmlns:a16="http://schemas.microsoft.com/office/drawing/2014/main" id="{F354C0F8-34CC-778B-5E2C-FD042010B7DD}"/>
               </a:ext>
             </a:extLst>
           </p:cNvPr>
@@ -8505,7 +9234,7 @@
         <p:spPr>
           <a:xfrm>
             <a:off x="923409" y="384754"/>
-            <a:ext cx="5172591" cy="830997"/>
+            <a:ext cx="6514621" cy="830997"/>
           </a:xfrm>
           <a:prstGeom prst="rect">
             <a:avLst/>
@@ -8519,15 +9248,32 @@
           <a:lstStyle/>
           <a:p>
             <a:r>
-              <a:rPr lang="ru-RU" sz="4800" b="1" dirty="0">
+              <a:rPr lang="en-US" sz="4800" b="1" dirty="0">
                 <a:solidFill>
                   <a:schemeClr val="bg1"/>
                 </a:solidFill>
                 <a:latin typeface="Arial" panose="020B0604020202020204" pitchFamily="34" charset="0"/>
                 <a:cs typeface="Arial" panose="020B0604020202020204" pitchFamily="34" charset="0"/>
               </a:rPr>
-              <a:t>Начало работы</a:t>
-            </a:r>
+              <a:t>API Security </a:t>
+            </a:r>
+            <a:r>
+              <a:rPr lang="en-US" sz="4800" b="1" dirty="0" err="1">
+                <a:solidFill>
+                  <a:schemeClr val="bg1"/>
+                </a:solidFill>
+                <a:latin typeface="Arial" panose="020B0604020202020204" pitchFamily="34" charset="0"/>
+                <a:cs typeface="Arial" panose="020B0604020202020204" pitchFamily="34" charset="0"/>
+              </a:rPr>
+              <a:t>Analizr</a:t>
+            </a:r>
+            <a:endParaRPr lang="ru-RU" sz="4800" b="1" dirty="0">
+              <a:solidFill>
+                <a:schemeClr val="bg1"/>
+              </a:solidFill>
+              <a:latin typeface="Arial" panose="020B0604020202020204" pitchFamily="34" charset="0"/>
+              <a:cs typeface="Arial" panose="020B0604020202020204" pitchFamily="34" charset="0"/>
+            </a:endParaRPr>
           </a:p>
         </p:txBody>
       </p:sp>
@@ -8536,7 +9282,7 @@
           <p:cNvPr id="2" name="Рисунок 1" descr="Изображение выглядит как текст, Шрифт, снимок экрана, Графика&#10;&#10;Содержимое, созданное искусственным интеллектом, может быть неверным.">
             <a:extLst>
               <a:ext uri="{FF2B5EF4-FFF2-40B4-BE49-F238E27FC236}">
-                <a16:creationId xmlns:a16="http://schemas.microsoft.com/office/drawing/2014/main" id="{4760AD37-9C1F-D933-5FAB-72ADFC8F697F}"/>
+                <a16:creationId xmlns:a16="http://schemas.microsoft.com/office/drawing/2014/main" id="{A1E8545E-2D46-E37F-F20B-84DE30598C2A}"/>
               </a:ext>
             </a:extLst>
           </p:cNvPr>
@@ -8564,10 +9310,10 @@
       </p:pic>
       <p:sp>
         <p:nvSpPr>
-          <p:cNvPr id="8" name="TextBox 7">
-            <a:extLst>
-              <a:ext uri="{FF2B5EF4-FFF2-40B4-BE49-F238E27FC236}">
-                <a16:creationId xmlns:a16="http://schemas.microsoft.com/office/drawing/2014/main" id="{CB97A419-BFA9-4559-A4E7-ED690CFF73C8}"/>
+          <p:cNvPr id="13" name="TextBox 12">
+            <a:extLst>
+              <a:ext uri="{FF2B5EF4-FFF2-40B4-BE49-F238E27FC236}">
+                <a16:creationId xmlns:a16="http://schemas.microsoft.com/office/drawing/2014/main" id="{6331E280-9A68-42DB-B637-1E9FDA5E250D}"/>
               </a:ext>
             </a:extLst>
           </p:cNvPr>
@@ -8576,8 +9322,8 @@
         </p:nvSpPr>
         <p:spPr>
           <a:xfrm>
-            <a:off x="353137" y="1278425"/>
-            <a:ext cx="6097136" cy="553998"/>
+            <a:off x="578324" y="1422358"/>
+            <a:ext cx="6097136" cy="369332"/>
           </a:xfrm>
           <a:prstGeom prst="rect">
             <a:avLst/>
@@ -8591,63 +9337,22 @@
           <a:lstStyle/>
           <a:p>
             <a:r>
-              <a:rPr lang="en-US" sz="3000" dirty="0">
+              <a:rPr lang="en-US" sz="1800" dirty="0">
                 <a:solidFill>
                   <a:schemeClr val="bg1"/>
                 </a:solidFill>
               </a:rPr>
               <a:t>https://vtb.seag.pro/</a:t>
-            </a:r>
-          </a:p>
-        </p:txBody>
-      </p:sp>
-      <p:sp>
-        <p:nvSpPr>
-          <p:cNvPr id="10" name="TextBox 9">
-            <a:extLst>
-              <a:ext uri="{FF2B5EF4-FFF2-40B4-BE49-F238E27FC236}">
-                <a16:creationId xmlns:a16="http://schemas.microsoft.com/office/drawing/2014/main" id="{C92D7052-FC8B-4AF9-9AEB-2F49C67D9F26}"/>
-              </a:ext>
-            </a:extLst>
-          </p:cNvPr>
-          <p:cNvSpPr txBox="1"/>
-          <p:nvPr/>
-        </p:nvSpPr>
-        <p:spPr>
-          <a:xfrm>
-            <a:off x="6450273" y="3566388"/>
-            <a:ext cx="5172591" cy="1708160"/>
-          </a:xfrm>
-          <a:prstGeom prst="rect">
-            <a:avLst/>
-          </a:prstGeom>
-          <a:noFill/>
-        </p:spPr>
-        <p:txBody>
-          <a:bodyPr wrap="square" rtlCol="0">
-            <a:spAutoFit/>
-          </a:bodyPr>
-          <a:lstStyle/>
-          <a:p>
-            <a:r>
-              <a:rPr lang="ru-RU" sz="3500" b="1" dirty="0">
-                <a:solidFill>
-                  <a:schemeClr val="bg1"/>
-                </a:solidFill>
-                <a:latin typeface="Arial" panose="020B0604020202020204" pitchFamily="34" charset="0"/>
-                <a:cs typeface="Arial" panose="020B0604020202020204" pitchFamily="34" charset="0"/>
-              </a:rPr>
-              <a:t>1. Выберите банк из списка имеющихся конфигураций</a:t>
             </a:r>
           </a:p>
         </p:txBody>
       </p:sp>
       <p:pic>
         <p:nvPicPr>
-          <p:cNvPr id="12" name="Picture 11">
-            <a:extLst>
-              <a:ext uri="{FF2B5EF4-FFF2-40B4-BE49-F238E27FC236}">
-                <a16:creationId xmlns:a16="http://schemas.microsoft.com/office/drawing/2014/main" id="{8C320EB1-96A1-45C1-B312-4725817581F1}"/>
+          <p:cNvPr id="8" name="Picture 7">
+            <a:extLst>
+              <a:ext uri="{FF2B5EF4-FFF2-40B4-BE49-F238E27FC236}">
+                <a16:creationId xmlns:a16="http://schemas.microsoft.com/office/drawing/2014/main" id="{48903563-CDAC-4DB1-B5D6-D99710783EFA}"/>
               </a:ext>
             </a:extLst>
           </p:cNvPr>
@@ -8664,8 +9369,8 @@
         </p:blipFill>
         <p:spPr>
           <a:xfrm>
-            <a:off x="1113730" y="2048985"/>
-            <a:ext cx="3709766" cy="4851778"/>
+            <a:off x="3592797" y="1137524"/>
+            <a:ext cx="6249034" cy="5720476"/>
           </a:xfrm>
           <a:prstGeom prst="rect">
             <a:avLst/>
@@ -8675,7 +9380,7 @@
     </p:spTree>
     <p:extLst>
       <p:ext uri="{BB962C8B-B14F-4D97-AF65-F5344CB8AC3E}">
-        <p14:creationId xmlns:p14="http://schemas.microsoft.com/office/powerpoint/2010/main" val="183924892"/>
+        <p14:creationId xmlns:p14="http://schemas.microsoft.com/office/powerpoint/2010/main" val="1680306984"/>
       </p:ext>
     </p:extLst>
   </p:cSld>
@@ -8863,8 +9568,8 @@
         </p:nvSpPr>
         <p:spPr>
           <a:xfrm>
-            <a:off x="0" y="2017749"/>
-            <a:ext cx="4306507" cy="4478149"/>
+            <a:off x="6450273" y="3566388"/>
+            <a:ext cx="5172591" cy="1708160"/>
           </a:xfrm>
           <a:prstGeom prst="rect">
             <a:avLst/>
@@ -8878,152 +9583,24 @@
           <a:lstStyle/>
           <a:p>
             <a:r>
-              <a:rPr lang="ru-RU" sz="3000" b="1" dirty="0">
+              <a:rPr lang="ru-RU" sz="3500" b="1" dirty="0">
                 <a:solidFill>
                   <a:schemeClr val="bg1"/>
                 </a:solidFill>
                 <a:latin typeface="Arial" panose="020B0604020202020204" pitchFamily="34" charset="0"/>
                 <a:cs typeface="Arial" panose="020B0604020202020204" pitchFamily="34" charset="0"/>
               </a:rPr>
-              <a:t>Выберите методы анализа</a:t>
-            </a:r>
-            <a:r>
-              <a:rPr lang="en-US" sz="3000" b="1" dirty="0">
-                <a:solidFill>
-                  <a:schemeClr val="bg1"/>
-                </a:solidFill>
-                <a:latin typeface="Arial" panose="020B0604020202020204" pitchFamily="34" charset="0"/>
-                <a:cs typeface="Arial" panose="020B0604020202020204" pitchFamily="34" charset="0"/>
-              </a:rPr>
-              <a:t>:</a:t>
-            </a:r>
-            <a:endParaRPr lang="ru-RU" sz="3000" b="1" dirty="0">
-              <a:solidFill>
-                <a:schemeClr val="bg1"/>
-              </a:solidFill>
-              <a:latin typeface="Arial" panose="020B0604020202020204" pitchFamily="34" charset="0"/>
-              <a:cs typeface="Arial" panose="020B0604020202020204" pitchFamily="34" charset="0"/>
-            </a:endParaRPr>
-          </a:p>
-          <a:p>
-            <a:pPr marL="342900" indent="-342900">
-              <a:buFont typeface="Arial" panose="020B0604020202020204" pitchFamily="34" charset="0"/>
-              <a:buChar char="•"/>
-            </a:pPr>
-            <a:r>
-              <a:rPr lang="ru-RU" sz="2500" b="1" dirty="0">
-                <a:solidFill>
-                  <a:schemeClr val="bg1"/>
-                </a:solidFill>
-                <a:latin typeface="Arial" panose="020B0604020202020204" pitchFamily="34" charset="0"/>
-                <a:cs typeface="Arial" panose="020B0604020202020204" pitchFamily="34" charset="0"/>
-              </a:rPr>
-              <a:t>статический анализ спецификации</a:t>
-            </a:r>
-          </a:p>
-          <a:p>
-            <a:pPr marL="342900" indent="-342900">
-              <a:buFont typeface="Arial" panose="020B0604020202020204" pitchFamily="34" charset="0"/>
-              <a:buChar char="•"/>
-            </a:pPr>
-            <a:r>
-              <a:rPr lang="ru-RU" sz="2500" b="1" dirty="0">
-                <a:solidFill>
-                  <a:schemeClr val="bg1"/>
-                </a:solidFill>
-                <a:latin typeface="Arial" panose="020B0604020202020204" pitchFamily="34" charset="0"/>
-                <a:cs typeface="Arial" panose="020B0604020202020204" pitchFamily="34" charset="0"/>
-              </a:rPr>
-              <a:t>динамическое тестирование (на </a:t>
-            </a:r>
-            <a:r>
-              <a:rPr lang="en-US" sz="2500" b="1" dirty="0">
-                <a:solidFill>
-                  <a:schemeClr val="bg1"/>
-                </a:solidFill>
-                <a:latin typeface="Arial" panose="020B0604020202020204" pitchFamily="34" charset="0"/>
-                <a:cs typeface="Arial" panose="020B0604020202020204" pitchFamily="34" charset="0"/>
-              </a:rPr>
-              <a:t>API </a:t>
-            </a:r>
-            <a:r>
-              <a:rPr lang="ru-RU" sz="2500" b="1" dirty="0">
-                <a:solidFill>
-                  <a:schemeClr val="bg1"/>
-                </a:solidFill>
-                <a:latin typeface="Arial" panose="020B0604020202020204" pitchFamily="34" charset="0"/>
-                <a:cs typeface="Arial" panose="020B0604020202020204" pitchFamily="34" charset="0"/>
-              </a:rPr>
-              <a:t>шлются реальные запросы для поиска уязвимостей)</a:t>
-            </a:r>
-          </a:p>
-          <a:p>
-            <a:pPr marL="342900" indent="-342900">
-              <a:buFont typeface="Arial" panose="020B0604020202020204" pitchFamily="34" charset="0"/>
-              <a:buChar char="•"/>
-            </a:pPr>
-            <a:r>
-              <a:rPr lang="ru-RU" sz="2500" b="1" dirty="0">
-                <a:solidFill>
-                  <a:schemeClr val="bg1"/>
-                </a:solidFill>
-                <a:latin typeface="Arial" panose="020B0604020202020204" pitchFamily="34" charset="0"/>
-                <a:cs typeface="Arial" panose="020B0604020202020204" pitchFamily="34" charset="0"/>
-              </a:rPr>
-              <a:t>Валидация контракта</a:t>
-            </a:r>
-          </a:p>
-          <a:p>
-            <a:pPr marL="342900" indent="-342900">
-              <a:buFont typeface="Arial" panose="020B0604020202020204" pitchFamily="34" charset="0"/>
-              <a:buChar char="•"/>
-            </a:pPr>
-            <a:r>
-              <a:rPr lang="en-US" sz="2500" b="1" dirty="0">
-                <a:solidFill>
-                  <a:schemeClr val="bg1"/>
-                </a:solidFill>
-                <a:latin typeface="Arial" panose="020B0604020202020204" pitchFamily="34" charset="0"/>
-                <a:cs typeface="Arial" panose="020B0604020202020204" pitchFamily="34" charset="0"/>
-              </a:rPr>
-              <a:t>AI </a:t>
-            </a:r>
-            <a:r>
-              <a:rPr lang="ru-RU" sz="2500" b="1" dirty="0">
-                <a:solidFill>
-                  <a:schemeClr val="bg1"/>
-                </a:solidFill>
-                <a:latin typeface="Arial" panose="020B0604020202020204" pitchFamily="34" charset="0"/>
-                <a:cs typeface="Arial" panose="020B0604020202020204" pitchFamily="34" charset="0"/>
-              </a:rPr>
-              <a:t>анализ </a:t>
-            </a:r>
-            <a:r>
-              <a:rPr lang="ru-RU" sz="2500" b="1" dirty="0" err="1">
-                <a:solidFill>
-                  <a:schemeClr val="bg1"/>
-                </a:solidFill>
-                <a:latin typeface="Arial" panose="020B0604020202020204" pitchFamily="34" charset="0"/>
-                <a:cs typeface="Arial" panose="020B0604020202020204" pitchFamily="34" charset="0"/>
-              </a:rPr>
-              <a:t>уязимостей</a:t>
-            </a:r>
-            <a:endParaRPr lang="ru-RU" sz="2500" b="1" dirty="0">
-              <a:solidFill>
-                <a:schemeClr val="bg1"/>
-              </a:solidFill>
-              <a:latin typeface="Arial" panose="020B0604020202020204" pitchFamily="34" charset="0"/>
-              <a:cs typeface="Arial" panose="020B0604020202020204" pitchFamily="34" charset="0"/>
-            </a:endParaRPr>
+              <a:t>1. Выберите банк из списка имеющихся конфигураций</a:t>
+            </a:r>
           </a:p>
         </p:txBody>
       </p:sp>
       <p:pic>
         <p:nvPicPr>
-          <p:cNvPr id="4" name="Picture 3">
-            <a:extLst>
-              <a:ext uri="{FF2B5EF4-FFF2-40B4-BE49-F238E27FC236}">
-                <a16:creationId xmlns:a16="http://schemas.microsoft.com/office/drawing/2014/main" id="{0D976F3A-C3AC-4FE2-AA7E-7424D11C5A84}"/>
+          <p:cNvPr id="12" name="Picture 11">
+            <a:extLst>
+              <a:ext uri="{FF2B5EF4-FFF2-40B4-BE49-F238E27FC236}">
+                <a16:creationId xmlns:a16="http://schemas.microsoft.com/office/drawing/2014/main" id="{8C320EB1-96A1-45C1-B312-4725817581F1}"/>
               </a:ext>
             </a:extLst>
           </p:cNvPr>
@@ -9040,8 +9617,8 @@
         </p:blipFill>
         <p:spPr>
           <a:xfrm>
-            <a:off x="4306507" y="2080423"/>
-            <a:ext cx="7783011" cy="4667901"/>
+            <a:off x="1113730" y="2048985"/>
+            <a:ext cx="3709766" cy="4851778"/>
           </a:xfrm>
           <a:prstGeom prst="rect">
             <a:avLst/>
@@ -9051,7 +9628,7 @@
     </p:spTree>
     <p:extLst>
       <p:ext uri="{BB962C8B-B14F-4D97-AF65-F5344CB8AC3E}">
-        <p14:creationId xmlns:p14="http://schemas.microsoft.com/office/powerpoint/2010/main" val="3168353698"/>
+        <p14:creationId xmlns:p14="http://schemas.microsoft.com/office/powerpoint/2010/main" val="183924892"/>
       </p:ext>
     </p:extLst>
   </p:cSld>
@@ -9129,7 +9706,7 @@
         <p:spPr>
           <a:xfrm>
             <a:off x="923409" y="384754"/>
-            <a:ext cx="8766501" cy="830997"/>
+            <a:ext cx="5172591" cy="830997"/>
           </a:xfrm>
           <a:prstGeom prst="rect">
             <a:avLst/>
@@ -9150,7 +9727,7 @@
                 <a:latin typeface="Arial" panose="020B0604020202020204" pitchFamily="34" charset="0"/>
                 <a:cs typeface="Arial" panose="020B0604020202020204" pitchFamily="34" charset="0"/>
               </a:rPr>
-              <a:t>Дождитесь результатов</a:t>
+              <a:t>Начало работы</a:t>
             </a:r>
           </a:p>
         </p:txBody>
@@ -9201,7 +9778,7 @@
         <p:spPr>
           <a:xfrm>
             <a:off x="353137" y="1278425"/>
-            <a:ext cx="6097136" cy="707886"/>
+            <a:ext cx="6097136" cy="553998"/>
           </a:xfrm>
           <a:prstGeom prst="rect">
             <a:avLst/>
@@ -9215,22 +9792,191 @@
           <a:lstStyle/>
           <a:p>
             <a:r>
-              <a:rPr lang="en-US" sz="4000" dirty="0">
+              <a:rPr lang="en-US" sz="3000" dirty="0">
                 <a:solidFill>
                   <a:schemeClr val="bg1"/>
                 </a:solidFill>
               </a:rPr>
               <a:t>https://vtb.seag.pro/</a:t>
             </a:r>
+          </a:p>
+        </p:txBody>
+      </p:sp>
+      <p:sp>
+        <p:nvSpPr>
+          <p:cNvPr id="10" name="TextBox 9">
+            <a:extLst>
+              <a:ext uri="{FF2B5EF4-FFF2-40B4-BE49-F238E27FC236}">
+                <a16:creationId xmlns:a16="http://schemas.microsoft.com/office/drawing/2014/main" id="{C92D7052-FC8B-4AF9-9AEB-2F49C67D9F26}"/>
+              </a:ext>
+            </a:extLst>
+          </p:cNvPr>
+          <p:cNvSpPr txBox="1"/>
+          <p:nvPr/>
+        </p:nvSpPr>
+        <p:spPr>
+          <a:xfrm>
+            <a:off x="0" y="2017749"/>
+            <a:ext cx="4306507" cy="4478149"/>
+          </a:xfrm>
+          <a:prstGeom prst="rect">
+            <a:avLst/>
+          </a:prstGeom>
+          <a:noFill/>
+        </p:spPr>
+        <p:txBody>
+          <a:bodyPr wrap="square" rtlCol="0">
+            <a:spAutoFit/>
+          </a:bodyPr>
+          <a:lstStyle/>
+          <a:p>
+            <a:r>
+              <a:rPr lang="ru-RU" sz="3000" b="1" dirty="0">
+                <a:solidFill>
+                  <a:schemeClr val="bg1"/>
+                </a:solidFill>
+                <a:latin typeface="Arial" panose="020B0604020202020204" pitchFamily="34" charset="0"/>
+                <a:cs typeface="Arial" panose="020B0604020202020204" pitchFamily="34" charset="0"/>
+              </a:rPr>
+              <a:t>Выберите методы анализа</a:t>
+            </a:r>
+            <a:r>
+              <a:rPr lang="en-US" sz="3000" b="1" dirty="0">
+                <a:solidFill>
+                  <a:schemeClr val="bg1"/>
+                </a:solidFill>
+                <a:latin typeface="Arial" panose="020B0604020202020204" pitchFamily="34" charset="0"/>
+                <a:cs typeface="Arial" panose="020B0604020202020204" pitchFamily="34" charset="0"/>
+              </a:rPr>
+              <a:t>:</a:t>
+            </a:r>
+            <a:endParaRPr lang="ru-RU" sz="3000" b="1" dirty="0">
+              <a:solidFill>
+                <a:schemeClr val="bg1"/>
+              </a:solidFill>
+              <a:latin typeface="Arial" panose="020B0604020202020204" pitchFamily="34" charset="0"/>
+              <a:cs typeface="Arial" panose="020B0604020202020204" pitchFamily="34" charset="0"/>
+            </a:endParaRPr>
+          </a:p>
+          <a:p>
+            <a:pPr marL="342900" indent="-342900">
+              <a:buFont typeface="Arial" panose="020B0604020202020204" pitchFamily="34" charset="0"/>
+              <a:buChar char="•"/>
+            </a:pPr>
+            <a:r>
+              <a:rPr lang="ru-RU" sz="2500" b="1" dirty="0">
+                <a:solidFill>
+                  <a:schemeClr val="bg1"/>
+                </a:solidFill>
+                <a:latin typeface="Arial" panose="020B0604020202020204" pitchFamily="34" charset="0"/>
+                <a:cs typeface="Arial" panose="020B0604020202020204" pitchFamily="34" charset="0"/>
+              </a:rPr>
+              <a:t>статический анализ спецификации</a:t>
+            </a:r>
+          </a:p>
+          <a:p>
+            <a:pPr marL="342900" indent="-342900">
+              <a:buFont typeface="Arial" panose="020B0604020202020204" pitchFamily="34" charset="0"/>
+              <a:buChar char="•"/>
+            </a:pPr>
+            <a:r>
+              <a:rPr lang="ru-RU" sz="2500" b="1" dirty="0">
+                <a:solidFill>
+                  <a:schemeClr val="bg1"/>
+                </a:solidFill>
+                <a:latin typeface="Arial" panose="020B0604020202020204" pitchFamily="34" charset="0"/>
+                <a:cs typeface="Arial" panose="020B0604020202020204" pitchFamily="34" charset="0"/>
+              </a:rPr>
+              <a:t>динамическое тестирование (на </a:t>
+            </a:r>
+            <a:r>
+              <a:rPr lang="en-US" sz="2500" b="1" dirty="0">
+                <a:solidFill>
+                  <a:schemeClr val="bg1"/>
+                </a:solidFill>
+                <a:latin typeface="Arial" panose="020B0604020202020204" pitchFamily="34" charset="0"/>
+                <a:cs typeface="Arial" panose="020B0604020202020204" pitchFamily="34" charset="0"/>
+              </a:rPr>
+              <a:t>API </a:t>
+            </a:r>
+            <a:r>
+              <a:rPr lang="ru-RU" sz="2500" b="1" dirty="0">
+                <a:solidFill>
+                  <a:schemeClr val="bg1"/>
+                </a:solidFill>
+                <a:latin typeface="Arial" panose="020B0604020202020204" pitchFamily="34" charset="0"/>
+                <a:cs typeface="Arial" panose="020B0604020202020204" pitchFamily="34" charset="0"/>
+              </a:rPr>
+              <a:t>шлются реальные запросы для поиска уязвимостей)</a:t>
+            </a:r>
+          </a:p>
+          <a:p>
+            <a:pPr marL="342900" indent="-342900">
+              <a:buFont typeface="Arial" panose="020B0604020202020204" pitchFamily="34" charset="0"/>
+              <a:buChar char="•"/>
+            </a:pPr>
+            <a:r>
+              <a:rPr lang="ru-RU" sz="2500" b="1" dirty="0">
+                <a:solidFill>
+                  <a:schemeClr val="bg1"/>
+                </a:solidFill>
+                <a:latin typeface="Arial" panose="020B0604020202020204" pitchFamily="34" charset="0"/>
+                <a:cs typeface="Arial" panose="020B0604020202020204" pitchFamily="34" charset="0"/>
+              </a:rPr>
+              <a:t>Валидация контракта</a:t>
+            </a:r>
+          </a:p>
+          <a:p>
+            <a:pPr marL="342900" indent="-342900">
+              <a:buFont typeface="Arial" panose="020B0604020202020204" pitchFamily="34" charset="0"/>
+              <a:buChar char="•"/>
+            </a:pPr>
+            <a:r>
+              <a:rPr lang="en-US" sz="2500" b="1" dirty="0">
+                <a:solidFill>
+                  <a:schemeClr val="bg1"/>
+                </a:solidFill>
+                <a:latin typeface="Arial" panose="020B0604020202020204" pitchFamily="34" charset="0"/>
+                <a:cs typeface="Arial" panose="020B0604020202020204" pitchFamily="34" charset="0"/>
+              </a:rPr>
+              <a:t>AI </a:t>
+            </a:r>
+            <a:r>
+              <a:rPr lang="ru-RU" sz="2500" b="1" dirty="0">
+                <a:solidFill>
+                  <a:schemeClr val="bg1"/>
+                </a:solidFill>
+                <a:latin typeface="Arial" panose="020B0604020202020204" pitchFamily="34" charset="0"/>
+                <a:cs typeface="Arial" panose="020B0604020202020204" pitchFamily="34" charset="0"/>
+              </a:rPr>
+              <a:t>анализ </a:t>
+            </a:r>
+            <a:r>
+              <a:rPr lang="ru-RU" sz="2500" b="1" dirty="0" err="1">
+                <a:solidFill>
+                  <a:schemeClr val="bg1"/>
+                </a:solidFill>
+                <a:latin typeface="Arial" panose="020B0604020202020204" pitchFamily="34" charset="0"/>
+                <a:cs typeface="Arial" panose="020B0604020202020204" pitchFamily="34" charset="0"/>
+              </a:rPr>
+              <a:t>уязимостей</a:t>
+            </a:r>
+            <a:endParaRPr lang="ru-RU" sz="2500" b="1" dirty="0">
+              <a:solidFill>
+                <a:schemeClr val="bg1"/>
+              </a:solidFill>
+              <a:latin typeface="Arial" panose="020B0604020202020204" pitchFamily="34" charset="0"/>
+              <a:cs typeface="Arial" panose="020B0604020202020204" pitchFamily="34" charset="0"/>
+            </a:endParaRPr>
           </a:p>
         </p:txBody>
       </p:sp>
       <p:pic>
         <p:nvPicPr>
-          <p:cNvPr id="7" name="Picture 6">
-            <a:extLst>
-              <a:ext uri="{FF2B5EF4-FFF2-40B4-BE49-F238E27FC236}">
-                <a16:creationId xmlns:a16="http://schemas.microsoft.com/office/drawing/2014/main" id="{B5A98BDD-8FE9-4027-923D-F1CF5D867D44}"/>
+          <p:cNvPr id="4" name="Picture 3">
+            <a:extLst>
+              <a:ext uri="{FF2B5EF4-FFF2-40B4-BE49-F238E27FC236}">
+                <a16:creationId xmlns:a16="http://schemas.microsoft.com/office/drawing/2014/main" id="{0D976F3A-C3AC-4FE2-AA7E-7424D11C5A84}"/>
               </a:ext>
             </a:extLst>
           </p:cNvPr>
@@ -9247,38 +9993,8 @@
         </p:blipFill>
         <p:spPr>
           <a:xfrm>
-            <a:off x="0" y="2504552"/>
-            <a:ext cx="12192000" cy="1412167"/>
-          </a:xfrm>
-          <a:prstGeom prst="rect">
-            <a:avLst/>
-          </a:prstGeom>
-        </p:spPr>
-      </p:pic>
-      <p:pic>
-        <p:nvPicPr>
-          <p:cNvPr id="13" name="Picture 12">
-            <a:extLst>
-              <a:ext uri="{FF2B5EF4-FFF2-40B4-BE49-F238E27FC236}">
-                <a16:creationId xmlns:a16="http://schemas.microsoft.com/office/drawing/2014/main" id="{420A32D3-4B02-4680-BC0D-A33905D970E8}"/>
-              </a:ext>
-            </a:extLst>
-          </p:cNvPr>
-          <p:cNvPicPr>
-            <a:picLocks noChangeAspect="1"/>
-          </p:cNvPicPr>
-          <p:nvPr/>
-        </p:nvPicPr>
-        <p:blipFill>
-          <a:blip r:embed="rId5"/>
-          <a:stretch>
-            <a:fillRect/>
-          </a:stretch>
-        </p:blipFill>
-        <p:spPr>
-          <a:xfrm>
-            <a:off x="669987" y="4759742"/>
-            <a:ext cx="10592718" cy="1577477"/>
+            <a:off x="4306507" y="2080423"/>
+            <a:ext cx="7783011" cy="4667901"/>
           </a:xfrm>
           <a:prstGeom prst="rect">
             <a:avLst/>
@@ -9288,7 +10004,7 @@
     </p:spTree>
     <p:extLst>
       <p:ext uri="{BB962C8B-B14F-4D97-AF65-F5344CB8AC3E}">
-        <p14:creationId xmlns:p14="http://schemas.microsoft.com/office/powerpoint/2010/main" val="4124136491"/>
+        <p14:creationId xmlns:p14="http://schemas.microsoft.com/office/powerpoint/2010/main" val="3168353698"/>
       </p:ext>
     </p:extLst>
   </p:cSld>
@@ -9366,7 +10082,7 @@
         <p:spPr>
           <a:xfrm>
             <a:off x="923409" y="384754"/>
-            <a:ext cx="8766501" cy="830997"/>
+            <a:ext cx="5172591" cy="830997"/>
           </a:xfrm>
           <a:prstGeom prst="rect">
             <a:avLst/>
@@ -9387,7 +10103,7 @@
                 <a:latin typeface="Arial" panose="020B0604020202020204" pitchFamily="34" charset="0"/>
                 <a:cs typeface="Arial" panose="020B0604020202020204" pitchFamily="34" charset="0"/>
               </a:rPr>
-              <a:t>Изучите результаты</a:t>
+              <a:t>Начало работы</a:t>
             </a:r>
           </a:p>
         </p:txBody>
@@ -9462,12 +10178,70 @@
           </a:p>
         </p:txBody>
       </p:sp>
+      <p:sp>
+        <p:nvSpPr>
+          <p:cNvPr id="10" name="TextBox 9">
+            <a:extLst>
+              <a:ext uri="{FF2B5EF4-FFF2-40B4-BE49-F238E27FC236}">
+                <a16:creationId xmlns:a16="http://schemas.microsoft.com/office/drawing/2014/main" id="{C92D7052-FC8B-4AF9-9AEB-2F49C67D9F26}"/>
+              </a:ext>
+            </a:extLst>
+          </p:cNvPr>
+          <p:cNvSpPr txBox="1"/>
+          <p:nvPr/>
+        </p:nvSpPr>
+        <p:spPr>
+          <a:xfrm>
+            <a:off x="0" y="2017749"/>
+            <a:ext cx="4306507" cy="1938992"/>
+          </a:xfrm>
+          <a:prstGeom prst="rect">
+            <a:avLst/>
+          </a:prstGeom>
+          <a:noFill/>
+        </p:spPr>
+        <p:txBody>
+          <a:bodyPr wrap="square" rtlCol="0">
+            <a:spAutoFit/>
+          </a:bodyPr>
+          <a:lstStyle/>
+          <a:p>
+            <a:r>
+              <a:rPr lang="ru-RU" sz="3000" b="1" dirty="0">
+                <a:solidFill>
+                  <a:schemeClr val="bg1"/>
+                </a:solidFill>
+                <a:latin typeface="Arial" panose="020B0604020202020204" pitchFamily="34" charset="0"/>
+                <a:cs typeface="Arial" panose="020B0604020202020204" pitchFamily="34" charset="0"/>
+              </a:rPr>
+              <a:t>Расширение проверок (по предложениям экспертов из жюри)</a:t>
+            </a:r>
+            <a:r>
+              <a:rPr lang="en-US" sz="3000" b="1" dirty="0">
+                <a:solidFill>
+                  <a:schemeClr val="bg1"/>
+                </a:solidFill>
+                <a:latin typeface="Arial" panose="020B0604020202020204" pitchFamily="34" charset="0"/>
+                <a:cs typeface="Arial" panose="020B0604020202020204" pitchFamily="34" charset="0"/>
+              </a:rPr>
+              <a:t>:</a:t>
+            </a:r>
+            <a:endParaRPr lang="ru-RU" sz="2500" b="1" dirty="0">
+              <a:solidFill>
+                <a:schemeClr val="bg1"/>
+              </a:solidFill>
+              <a:latin typeface="Arial" panose="020B0604020202020204" pitchFamily="34" charset="0"/>
+              <a:cs typeface="Arial" panose="020B0604020202020204" pitchFamily="34" charset="0"/>
+            </a:endParaRPr>
+          </a:p>
+        </p:txBody>
+      </p:sp>
       <p:pic>
         <p:nvPicPr>
-          <p:cNvPr id="4" name="Picture 3">
-            <a:extLst>
-              <a:ext uri="{FF2B5EF4-FFF2-40B4-BE49-F238E27FC236}">
-                <a16:creationId xmlns:a16="http://schemas.microsoft.com/office/drawing/2014/main" id="{C03615FD-1B51-4D7C-A033-5E45ABB7E24A}"/>
+          <p:cNvPr id="7" name="Picture 6">
+            <a:extLst>
+              <a:ext uri="{FF2B5EF4-FFF2-40B4-BE49-F238E27FC236}">
+                <a16:creationId xmlns:a16="http://schemas.microsoft.com/office/drawing/2014/main" id="{5F97C5D7-254E-434A-ABCF-D96104E38148}"/>
               </a:ext>
             </a:extLst>
           </p:cNvPr>
@@ -9484,8 +10258,8 @@
         </p:blipFill>
         <p:spPr>
           <a:xfrm>
-            <a:off x="0" y="2339706"/>
-            <a:ext cx="12192000" cy="4334933"/>
+            <a:off x="4061984" y="1644993"/>
+            <a:ext cx="8078327" cy="4877481"/>
           </a:xfrm>
           <a:prstGeom prst="rect">
             <a:avLst/>
@@ -9495,7 +10269,7 @@
     </p:spTree>
     <p:extLst>
       <p:ext uri="{BB962C8B-B14F-4D97-AF65-F5344CB8AC3E}">
-        <p14:creationId xmlns:p14="http://schemas.microsoft.com/office/powerpoint/2010/main" val="1763766263"/>
+        <p14:creationId xmlns:p14="http://schemas.microsoft.com/office/powerpoint/2010/main" val="2154116844"/>
       </p:ext>
     </p:extLst>
   </p:cSld>
@@ -9594,7 +10368,7 @@
                 <a:latin typeface="Arial" panose="020B0604020202020204" pitchFamily="34" charset="0"/>
                 <a:cs typeface="Arial" panose="020B0604020202020204" pitchFamily="34" charset="0"/>
               </a:rPr>
-              <a:t>Примеры уязвимостей</a:t>
+              <a:t>Дождитесь результатов</a:t>
             </a:r>
           </a:p>
         </p:txBody>
@@ -9645,7 +10419,7 @@
         <p:spPr>
           <a:xfrm>
             <a:off x="353137" y="1278425"/>
-            <a:ext cx="6097136" cy="553998"/>
+            <a:ext cx="6097136" cy="707886"/>
           </a:xfrm>
           <a:prstGeom prst="rect">
             <a:avLst/>
@@ -9659,7 +10433,7 @@
           <a:lstStyle/>
           <a:p>
             <a:r>
-              <a:rPr lang="en-US" sz="3000" dirty="0">
+              <a:rPr lang="en-US" sz="4000" dirty="0">
                 <a:solidFill>
                   <a:schemeClr val="bg1"/>
                 </a:solidFill>
@@ -9671,10 +10445,10 @@
       </p:sp>
       <p:pic>
         <p:nvPicPr>
-          <p:cNvPr id="10" name="Picture 9">
-            <a:extLst>
-              <a:ext uri="{FF2B5EF4-FFF2-40B4-BE49-F238E27FC236}">
-                <a16:creationId xmlns:a16="http://schemas.microsoft.com/office/drawing/2014/main" id="{18D55B43-3C84-4ABE-BA8D-9C69494977FA}"/>
+          <p:cNvPr id="7" name="Picture 6">
+            <a:extLst>
+              <a:ext uri="{FF2B5EF4-FFF2-40B4-BE49-F238E27FC236}">
+                <a16:creationId xmlns:a16="http://schemas.microsoft.com/office/drawing/2014/main" id="{B5A98BDD-8FE9-4027-923D-F1CF5D867D44}"/>
               </a:ext>
             </a:extLst>
           </p:cNvPr>
@@ -9691,8 +10465,38 @@
         </p:blipFill>
         <p:spPr>
           <a:xfrm>
-            <a:off x="-54591" y="2158650"/>
-            <a:ext cx="12192000" cy="4442564"/>
+            <a:off x="0" y="2504552"/>
+            <a:ext cx="12192000" cy="1412167"/>
+          </a:xfrm>
+          <a:prstGeom prst="rect">
+            <a:avLst/>
+          </a:prstGeom>
+        </p:spPr>
+      </p:pic>
+      <p:pic>
+        <p:nvPicPr>
+          <p:cNvPr id="13" name="Picture 12">
+            <a:extLst>
+              <a:ext uri="{FF2B5EF4-FFF2-40B4-BE49-F238E27FC236}">
+                <a16:creationId xmlns:a16="http://schemas.microsoft.com/office/drawing/2014/main" id="{420A32D3-4B02-4680-BC0D-A33905D970E8}"/>
+              </a:ext>
+            </a:extLst>
+          </p:cNvPr>
+          <p:cNvPicPr>
+            <a:picLocks noChangeAspect="1"/>
+          </p:cNvPicPr>
+          <p:nvPr/>
+        </p:nvPicPr>
+        <p:blipFill>
+          <a:blip r:embed="rId5"/>
+          <a:stretch>
+            <a:fillRect/>
+          </a:stretch>
+        </p:blipFill>
+        <p:spPr>
+          <a:xfrm>
+            <a:off x="669987" y="4759742"/>
+            <a:ext cx="10592718" cy="1577477"/>
           </a:xfrm>
           <a:prstGeom prst="rect">
             <a:avLst/>
@@ -9702,7 +10506,7 @@
     </p:spTree>
     <p:extLst>
       <p:ext uri="{BB962C8B-B14F-4D97-AF65-F5344CB8AC3E}">
-        <p14:creationId xmlns:p14="http://schemas.microsoft.com/office/powerpoint/2010/main" val="1386375262"/>
+        <p14:creationId xmlns:p14="http://schemas.microsoft.com/office/powerpoint/2010/main" val="4124136491"/>
       </p:ext>
     </p:extLst>
   </p:cSld>

</xml_diff>